<commit_message>
Update prescriptive analytics script: Remove slides on machine learning and automation, and adjust slide titles for clarity
</commit_message>
<xml_diff>
--- a/prescriptive-analytics/prescriptive-analytics-presentation-designed.pptx
+++ b/prescriptive-analytics/prescriptive-analytics-presentation-designed.pptx
@@ -6,7 +6,7 @@
     <p:sldMasterId id="2147483661" r:id="rId2"/>
   </p:sldMasterIdLst>
   <p:notesMasterIdLst>
-    <p:notesMasterId r:id="rId19"/>
+    <p:notesMasterId r:id="rId17"/>
   </p:notesMasterIdLst>
   <p:sldIdLst>
     <p:sldId id="273" r:id="rId3"/>
@@ -22,46 +22,44 @@
     <p:sldId id="266" r:id="rId13"/>
     <p:sldId id="267" r:id="rId14"/>
     <p:sldId id="268" r:id="rId15"/>
-    <p:sldId id="269" r:id="rId16"/>
-    <p:sldId id="270" r:id="rId17"/>
-    <p:sldId id="272" r:id="rId18"/>
+    <p:sldId id="272" r:id="rId16"/>
   </p:sldIdLst>
   <p:sldSz cx="9144000" cy="5143500" type="screen16x9"/>
   <p:notesSz cx="6858000" cy="9144000"/>
   <p:embeddedFontLst>
     <p:embeddedFont>
       <p:font typeface="Fira Sans Extra Condensed" panose="020B0503050000020004" pitchFamily="34" charset="0"/>
-      <p:regular r:id="rId20"/>
-      <p:bold r:id="rId21"/>
-      <p:italic r:id="rId22"/>
-      <p:boldItalic r:id="rId23"/>
+      <p:regular r:id="rId18"/>
+      <p:bold r:id="rId19"/>
+      <p:italic r:id="rId20"/>
+      <p:boldItalic r:id="rId21"/>
     </p:embeddedFont>
     <p:embeddedFont>
       <p:font typeface="Fira Sans Extra Condensed SemiBold" panose="020B0603050000020004" pitchFamily="34" charset="0"/>
-      <p:regular r:id="rId24"/>
-      <p:bold r:id="rId25"/>
-      <p:italic r:id="rId26"/>
-      <p:boldItalic r:id="rId27"/>
+      <p:regular r:id="rId22"/>
+      <p:bold r:id="rId23"/>
+      <p:italic r:id="rId24"/>
+      <p:boldItalic r:id="rId25"/>
     </p:embeddedFont>
     <p:embeddedFont>
       <p:font typeface="Proxima Nova" panose="020B0604020202020204" charset="0"/>
-      <p:regular r:id="rId28"/>
-      <p:bold r:id="rId29"/>
-      <p:italic r:id="rId30"/>
-      <p:boldItalic r:id="rId31"/>
+      <p:regular r:id="rId26"/>
+      <p:bold r:id="rId27"/>
+      <p:italic r:id="rId28"/>
+      <p:boldItalic r:id="rId29"/>
     </p:embeddedFont>
     <p:embeddedFont>
       <p:font typeface="Proxima Nova Semibold" panose="020B0604020202020204" charset="0"/>
-      <p:regular r:id="rId32"/>
-      <p:bold r:id="rId33"/>
-      <p:boldItalic r:id="rId34"/>
+      <p:regular r:id="rId30"/>
+      <p:bold r:id="rId31"/>
+      <p:boldItalic r:id="rId32"/>
     </p:embeddedFont>
     <p:embeddedFont>
       <p:font typeface="Roboto" panose="02000000000000000000" pitchFamily="2" charset="0"/>
-      <p:regular r:id="rId35"/>
-      <p:bold r:id="rId36"/>
-      <p:italic r:id="rId37"/>
-      <p:boldItalic r:id="rId38"/>
+      <p:regular r:id="rId33"/>
+      <p:bold r:id="rId34"/>
+      <p:italic r:id="rId35"/>
+      <p:boldItalic r:id="rId36"/>
     </p:embeddedFont>
   </p:embeddedFontLst>
   <p:defaultTextStyle>
@@ -1481,262 +1479,6 @@
 </file>
 
 <file path=ppt/notesSlides/notesSlide14.xml><?xml version="1.0" encoding="utf-8"?>
-<p:notes xmlns:a="http://schemas.openxmlformats.org/drawingml/2006/main" xmlns:r="http://schemas.openxmlformats.org/officeDocument/2006/relationships" xmlns:p="http://schemas.openxmlformats.org/presentationml/2006/main">
-  <p:cSld>
-    <p:spTree>
-      <p:nvGrpSpPr>
-        <p:cNvPr id="1" name=""/>
-        <p:cNvGrpSpPr/>
-        <p:nvPr/>
-      </p:nvGrpSpPr>
-      <p:grpSpPr>
-        <a:xfrm>
-          <a:off x="0" y="0"/>
-          <a:ext cx="0" cy="0"/>
-          <a:chOff x="0" y="0"/>
-          <a:chExt cx="0" cy="0"/>
-        </a:xfrm>
-      </p:grpSpPr>
-      <p:sp>
-        <p:nvSpPr>
-          <p:cNvPr id="2" name="Speaker notes"/>
-          <p:cNvSpPr>
-            <a:spLocks noGrp="1"/>
-          </p:cNvSpPr>
-          <p:nvPr>
-            <p:ph type="body" idx="1"/>
-          </p:nvPr>
-        </p:nvSpPr>
-        <p:spPr/>
-        <p:txBody>
-          <a:bodyPr/>
-          <a:lstStyle/>
-          <a:p>
-            <a:r>
-              <a:rPr lang="en-US" sz="1200"/>
-              <a:t>Automation means allowing a computer to do an action. At one level, the system only gives suggestions, and a person chooses and acts. At another level, the system prepares a plan but waits for approval. With automatic action, the system acts within agreed rules and records what it does.</a:t>
-            </a:r>
-          </a:p>
-          <a:p>
-            <a:endParaRPr lang="en-US" sz="1200"/>
-          </a:p>
-          <a:p>
-            <a:r>
-              <a:rPr lang="en-US" sz="1200"/>
-              <a:t>The team chooses the level based on the decision and its possible effects. It should also be able to stop automatic actions if a problem occurs.</a:t>
-            </a:r>
-          </a:p>
-          <a:p>
-            <a:endParaRPr lang="en-US" sz="1200"/>
-          </a:p>
-          <a:p>
-            <a:r>
-              <a:rPr lang="en-US" sz="1200"/>
-              <a:t>--- Full content from the approved Markdown ---</a:t>
-            </a:r>
-          </a:p>
-          <a:p>
-            <a:r>
-              <a:rPr lang="en-US" sz="1200"/>
-              <a:t>## Levels of automation</a:t>
-            </a:r>
-          </a:p>
-          <a:p>
-            <a:endParaRPr lang="en-US" sz="1200"/>
-          </a:p>
-          <a:p>
-            <a:r>
-              <a:rPr lang="en-US" sz="1200"/>
-              <a:t>Automation means allowing a computer to do an action.</a:t>
-            </a:r>
-          </a:p>
-          <a:p>
-            <a:endParaRPr lang="en-US" sz="1200"/>
-          </a:p>
-          <a:p>
-            <a:r>
-              <a:rPr lang="en-US" sz="1200"/>
-              <a:t>| Level | What happens |</a:t>
-            </a:r>
-          </a:p>
-          <a:p>
-            <a:r>
-              <a:rPr lang="en-US" sz="1200"/>
-              <a:t>|:--|:--|</a:t>
-            </a:r>
-          </a:p>
-          <a:p>
-            <a:r>
-              <a:rPr lang="en-US" sz="1200"/>
-              <a:t>| Suggestion only | The system gives options; a person chooses and acts |</a:t>
-            </a:r>
-          </a:p>
-          <a:p>
-            <a:r>
-              <a:rPr lang="en-US" sz="1200"/>
-              <a:t>| Approval needed | The system prepares a plan; a person approves it before action |</a:t>
-            </a:r>
-          </a:p>
-          <a:p>
-            <a:r>
-              <a:rPr lang="en-US" sz="1200"/>
-              <a:t>| Automatic action | The system acts within agreed rules and records what it does |</a:t>
-            </a:r>
-          </a:p>
-          <a:p>
-            <a:endParaRPr lang="en-US" sz="1200"/>
-          </a:p>
-          <a:p>
-            <a:r>
-              <a:rPr lang="en-US" sz="1200"/>
-              <a:t>The team chooses the level based on the decision and its possible effects. It should be able to stop automatic actions when a problem occurs.</a:t>
-            </a:r>
-          </a:p>
-          <a:p>
-            <a:endParaRPr lang="en-US" sz="1200"/>
-          </a:p>
-          <a:p>
-            <a:r>
-              <a:rPr lang="en-US" sz="1200"/>
-              <a:t>---</a:t>
-            </a:r>
-          </a:p>
-          <a:p>
-            <a:endParaRPr lang="en-US" sz="1200"/>
-          </a:p>
-          <a:p>
-            <a:r>
-              <a:rPr lang="en-US" sz="1200"/>
-              <a:t>Design and native vector artwork adapted from Big Data Infographics by Slidesgo.</a:t>
-            </a:r>
-          </a:p>
-        </p:txBody>
-      </p:sp>
-    </p:spTree>
-  </p:cSld>
-  <p:clrMapOvr>
-    <a:masterClrMapping/>
-  </p:clrMapOvr>
-</p:notes>
-</file>
-
-<file path=ppt/notesSlides/notesSlide15.xml><?xml version="1.0" encoding="utf-8"?>
-<p:notes xmlns:a="http://schemas.openxmlformats.org/drawingml/2006/main" xmlns:r="http://schemas.openxmlformats.org/officeDocument/2006/relationships" xmlns:p="http://schemas.openxmlformats.org/presentationml/2006/main">
-  <p:cSld>
-    <p:spTree>
-      <p:nvGrpSpPr>
-        <p:cNvPr id="1" name=""/>
-        <p:cNvGrpSpPr/>
-        <p:nvPr/>
-      </p:nvGrpSpPr>
-      <p:grpSpPr>
-        <a:xfrm>
-          <a:off x="0" y="0"/>
-          <a:ext cx="0" cy="0"/>
-          <a:chOff x="0" y="0"/>
-          <a:chExt cx="0" cy="0"/>
-        </a:xfrm>
-      </p:grpSpPr>
-      <p:sp>
-        <p:nvSpPr>
-          <p:cNvPr id="2" name="Speaker notes"/>
-          <p:cNvSpPr>
-            <a:spLocks noGrp="1"/>
-          </p:cNvSpPr>
-          <p:nvPr>
-            <p:ph type="body" idx="1"/>
-          </p:nvPr>
-        </p:nvSpPr>
-        <p:spPr/>
-        <p:txBody>
-          <a:bodyPr/>
-          <a:lstStyle/>
-          <a:p>
-            <a:r>
-              <a:rPr lang="en-US" sz="1200"/>
-              <a:t>A plan may meet the business goal but still affect people unfairly. For example, a work plan might give the same workers the busiest hours every week.</a:t>
-            </a:r>
-          </a:p>
-          <a:p>
-            <a:endParaRPr lang="en-US" sz="1200"/>
-          </a:p>
-          <a:p>
-            <a:r>
-              <a:rPr lang="en-US" sz="1200"/>
-              <a:t>The team can include rules for breaks, reasonable working hours, and sharing difficult tasks fairly. People must decide what fairness means in that situation and include it in the model's goals or rules.</a:t>
-            </a:r>
-          </a:p>
-          <a:p>
-            <a:endParaRPr lang="en-US" sz="1200"/>
-          </a:p>
-          <a:p>
-            <a:r>
-              <a:rPr lang="en-US" sz="1200"/>
-              <a:t>--- Full content from the approved Markdown ---</a:t>
-            </a:r>
-          </a:p>
-          <a:p>
-            <a:r>
-              <a:rPr lang="en-US" sz="1200"/>
-              <a:t>## Fairness in decision-making</a:t>
-            </a:r>
-          </a:p>
-          <a:p>
-            <a:endParaRPr lang="en-US" sz="1200"/>
-          </a:p>
-          <a:p>
-            <a:r>
-              <a:rPr lang="en-US" sz="1200"/>
-              <a:t>A plan can meet a business goal and still affect people unfairly.</a:t>
-            </a:r>
-          </a:p>
-          <a:p>
-            <a:endParaRPr lang="en-US" sz="1200"/>
-          </a:p>
-          <a:p>
-            <a:r>
-              <a:rPr lang="en-US" sz="1200"/>
-              <a:t>For example, a work plan might give the same workers the busiest hours every week.</a:t>
-            </a:r>
-          </a:p>
-          <a:p>
-            <a:endParaRPr lang="en-US" sz="1200"/>
-          </a:p>
-          <a:p>
-            <a:r>
-              <a:rPr lang="en-US" sz="1200"/>
-              <a:t>The team can include rules for breaks, reasonable working hours, and sharing difficult tasks fairly.</a:t>
-            </a:r>
-          </a:p>
-          <a:p>
-            <a:endParaRPr lang="en-US" sz="1200"/>
-          </a:p>
-          <a:p>
-            <a:r>
-              <a:rPr lang="en-US" sz="1200"/>
-              <a:t>**People must decide what fairness means for the decision and include it in the goals or rules.**</a:t>
-            </a:r>
-          </a:p>
-          <a:p>
-            <a:endParaRPr lang="en-US" sz="1200"/>
-          </a:p>
-          <a:p>
-            <a:r>
-              <a:rPr lang="en-US" sz="1200"/>
-              <a:t>Design and native vector artwork adapted from Big Data Infographics by Slidesgo.</a:t>
-            </a:r>
-          </a:p>
-        </p:txBody>
-      </p:sp>
-    </p:spTree>
-  </p:cSld>
-  <p:clrMapOvr>
-    <a:masterClrMapping/>
-  </p:clrMapOvr>
-</p:notes>
-</file>
-
-<file path=ppt/notesSlides/notesSlide16.xml><?xml version="1.0" encoding="utf-8"?>
 <p:notes xmlns:a="http://schemas.openxmlformats.org/drawingml/2006/main" xmlns:r="http://schemas.openxmlformats.org/officeDocument/2006/relationships" xmlns:p="http://schemas.openxmlformats.org/presentationml/2006/main">
   <p:cSld>
     <p:spTree>
@@ -23001,3433 +22743,6 @@
 </file>
 
 <file path=ppt/slides/slide14.xml><?xml version="1.0" encoding="utf-8"?>
-<p:sld xmlns:a="http://schemas.openxmlformats.org/drawingml/2006/main" xmlns:r="http://schemas.openxmlformats.org/officeDocument/2006/relationships" xmlns:p="http://schemas.openxmlformats.org/presentationml/2006/main" showMasterSp="0">
-  <p:cSld name="Levels of automation">
-    <p:bg>
-      <p:bgPr>
-        <a:solidFill>
-          <a:srgbClr val="FFFFFF"/>
-        </a:solidFill>
-        <a:effectLst/>
-      </p:bgPr>
-    </p:bg>
-    <p:spTree>
-      <p:nvGrpSpPr>
-        <p:cNvPr id="1" name="Root"/>
-        <p:cNvGrpSpPr/>
-        <p:nvPr/>
-      </p:nvGrpSpPr>
-      <p:grpSpPr>
-        <a:xfrm>
-          <a:off x="0" y="0"/>
-          <a:ext cx="0" cy="0"/>
-          <a:chOff x="0" y="0"/>
-          <a:chExt cx="0" cy="0"/>
-        </a:xfrm>
-      </p:grpSpPr>
-      <p:sp>
-        <p:nvSpPr>
-          <p:cNvPr id="2" name="Text"/>
-          <p:cNvSpPr txBox="1"/>
-          <p:nvPr/>
-        </p:nvSpPr>
-        <p:spPr>
-          <a:xfrm>
-            <a:off x="495300" y="361950"/>
-            <a:ext cx="8172450" cy="552450"/>
-          </a:xfrm>
-          <a:prstGeom prst="rect">
-            <a:avLst/>
-          </a:prstGeom>
-          <a:noFill/>
-          <a:ln w="9525">
-            <a:noFill/>
-          </a:ln>
-        </p:spPr>
-        <p:txBody>
-          <a:bodyPr wrap="none" lIns="0" tIns="0" rIns="0" bIns="0" anchor="t">
-            <a:noAutofit/>
-          </a:bodyPr>
-          <a:lstStyle/>
-          <a:p>
-            <a:pPr marL="0" indent="0" algn="l">
-              <a:lnSpc>
-                <a:spcPts val="3938"/>
-              </a:lnSpc>
-              <a:spcAft>
-                <a:spcPts val="0"/>
-              </a:spcAft>
-              <a:buNone/>
-            </a:pPr>
-            <a:r>
-              <a:rPr lang="en-US" sz="3150" b="1">
-                <a:solidFill>
-                  <a:srgbClr val="435D74"/>
-                </a:solidFill>
-                <a:latin typeface="Fira Sans Extra Condensed"/>
-                <a:ea typeface="Fira Sans Extra Condensed"/>
-                <a:cs typeface="Fira Sans Extra Condensed"/>
-              </a:rPr>
-              <a:t>Levels of automation</a:t>
-            </a:r>
-            <a:endParaRPr lang="en-US" sz="3150"/>
-          </a:p>
-        </p:txBody>
-      </p:sp>
-      <p:cxnSp>
-        <p:nvCxnSpPr>
-          <p:cNvPr id="3" name="Connector"/>
-          <p:cNvCxnSpPr/>
-          <p:nvPr/>
-        </p:nvCxnSpPr>
-        <p:spPr>
-          <a:xfrm>
-            <a:off x="495300" y="4762500"/>
-            <a:ext cx="8153400" cy="95"/>
-          </a:xfrm>
-          <a:prstGeom prst="line">
-            <a:avLst/>
-          </a:prstGeom>
-          <a:ln w="6191">
-            <a:solidFill>
-              <a:srgbClr val="D8E2E8"/>
-            </a:solidFill>
-          </a:ln>
-        </p:spPr>
-      </p:cxnSp>
-      <p:sp>
-        <p:nvSpPr>
-          <p:cNvPr id="4" name="Text"/>
-          <p:cNvSpPr txBox="1"/>
-          <p:nvPr/>
-        </p:nvSpPr>
-        <p:spPr>
-          <a:xfrm>
-            <a:off x="495300" y="4867275"/>
-            <a:ext cx="2762250" cy="171450"/>
-          </a:xfrm>
-          <a:prstGeom prst="rect">
-            <a:avLst/>
-          </a:prstGeom>
-          <a:noFill/>
-          <a:ln w="9525">
-            <a:noFill/>
-          </a:ln>
-        </p:spPr>
-        <p:txBody>
-          <a:bodyPr wrap="none" lIns="0" tIns="0" rIns="0" bIns="0" anchor="t">
-            <a:noAutofit/>
-          </a:bodyPr>
-          <a:lstStyle/>
-          <a:p>
-            <a:pPr marL="0" indent="0" algn="l">
-              <a:lnSpc>
-                <a:spcPts val="1031"/>
-              </a:lnSpc>
-              <a:spcAft>
-                <a:spcPts val="0"/>
-              </a:spcAft>
-              <a:buNone/>
-            </a:pPr>
-            <a:r>
-              <a:rPr lang="en-US" sz="825" b="0">
-                <a:solidFill>
-                  <a:srgbClr val="6D8495"/>
-                </a:solidFill>
-                <a:latin typeface="Roboto"/>
-                <a:ea typeface="Roboto"/>
-                <a:cs typeface="Roboto"/>
-              </a:rPr>
-              <a:t>Prescriptive analytics</a:t>
-            </a:r>
-            <a:endParaRPr lang="en-US" sz="825"/>
-          </a:p>
-        </p:txBody>
-      </p:sp>
-      <p:sp>
-        <p:nvSpPr>
-          <p:cNvPr id="6" name="Text"/>
-          <p:cNvSpPr txBox="1"/>
-          <p:nvPr/>
-        </p:nvSpPr>
-        <p:spPr>
-          <a:xfrm>
-            <a:off x="8048625" y="4867275"/>
-            <a:ext cx="600075" cy="171450"/>
-          </a:xfrm>
-          <a:prstGeom prst="rect">
-            <a:avLst/>
-          </a:prstGeom>
-          <a:noFill/>
-          <a:ln w="9525">
-            <a:noFill/>
-          </a:ln>
-        </p:spPr>
-        <p:txBody>
-          <a:bodyPr wrap="none" lIns="0" tIns="0" rIns="0" bIns="0" anchor="t">
-            <a:noAutofit/>
-          </a:bodyPr>
-          <a:lstStyle/>
-          <a:p>
-            <a:pPr algn="r">
-              <a:lnSpc>
-                <a:spcPts val="1031"/>
-              </a:lnSpc>
-            </a:pPr>
-            <a:r>
-              <a:rPr lang="en-US" sz="825" b="0" dirty="0">
-                <a:solidFill>
-                  <a:srgbClr val="6D8495"/>
-                </a:solidFill>
-                <a:latin typeface="Roboto"/>
-                <a:ea typeface="Roboto"/>
-                <a:cs typeface="Roboto"/>
-              </a:rPr>
-              <a:t>14 </a:t>
-            </a:r>
-            <a:r>
-              <a:rPr lang="en-US" sz="825" dirty="0">
-                <a:solidFill>
-                  <a:srgbClr val="6D8495"/>
-                </a:solidFill>
-                <a:latin typeface="Roboto"/>
-                <a:ea typeface="Roboto"/>
-                <a:cs typeface="Roboto"/>
-              </a:rPr>
-              <a:t>/ 16</a:t>
-            </a:r>
-            <a:endParaRPr lang="en-US" sz="825" dirty="0"/>
-          </a:p>
-        </p:txBody>
-      </p:sp>
-      <p:sp>
-        <p:nvSpPr>
-          <p:cNvPr id="7" name="Text"/>
-          <p:cNvSpPr txBox="1"/>
-          <p:nvPr/>
-        </p:nvSpPr>
-        <p:spPr>
-          <a:xfrm>
-            <a:off x="495300" y="1019175"/>
-            <a:ext cx="8153400" cy="381000"/>
-          </a:xfrm>
-          <a:prstGeom prst="rect">
-            <a:avLst/>
-          </a:prstGeom>
-          <a:noFill/>
-          <a:ln w="9525">
-            <a:noFill/>
-          </a:ln>
-        </p:spPr>
-        <p:txBody>
-          <a:bodyPr wrap="none" lIns="0" tIns="0" rIns="0" bIns="0" anchor="t">
-            <a:noAutofit/>
-          </a:bodyPr>
-          <a:lstStyle/>
-          <a:p>
-            <a:pPr marL="0" indent="0" algn="l">
-              <a:lnSpc>
-                <a:spcPts val="2156"/>
-              </a:lnSpc>
-              <a:spcAft>
-                <a:spcPts val="0"/>
-              </a:spcAft>
-              <a:buNone/>
-            </a:pPr>
-            <a:r>
-              <a:rPr lang="en-US" sz="1725" b="0">
-                <a:solidFill>
-                  <a:srgbClr val="007D8B"/>
-                </a:solidFill>
-                <a:latin typeface="Roboto"/>
-                <a:ea typeface="Roboto"/>
-                <a:cs typeface="Roboto"/>
-              </a:rPr>
-              <a:t>Automation = allowing a computer to do an action.</a:t>
-            </a:r>
-            <a:endParaRPr lang="en-US" sz="1725"/>
-          </a:p>
-        </p:txBody>
-      </p:sp>
-      <p:sp>
-        <p:nvSpPr>
-          <p:cNvPr id="8" name="Circle"/>
-          <p:cNvSpPr/>
-          <p:nvPr/>
-        </p:nvSpPr>
-        <p:spPr>
-          <a:xfrm>
-            <a:off x="1276350" y="1619250"/>
-            <a:ext cx="781050" cy="781050"/>
-          </a:xfrm>
-          <a:prstGeom prst="ellipse">
-            <a:avLst/>
-          </a:prstGeom>
-          <a:solidFill>
-            <a:srgbClr val="F3F6F8"/>
-          </a:solidFill>
-          <a:ln w="9525">
-            <a:noFill/>
-          </a:ln>
-        </p:spPr>
-        <p:txBody>
-          <a:bodyPr/>
-          <a:lstStyle/>
-          <a:p>
-            <a:endParaRPr lang="en-US"/>
-          </a:p>
-        </p:txBody>
-      </p:sp>
-      <p:grpSp>
-        <p:nvGrpSpPr>
-          <p:cNvPr id="9" name="Slidesgo vector icon"/>
-          <p:cNvGrpSpPr/>
-          <p:nvPr/>
-        </p:nvGrpSpPr>
-        <p:grpSpPr>
-          <a:xfrm>
-            <a:off x="1495425" y="1828800"/>
-            <a:ext cx="333375" cy="331725"/>
-            <a:chOff x="-63679950" y="3360375"/>
-            <a:chExt cx="318225" cy="316650"/>
-          </a:xfrm>
-        </p:grpSpPr>
-        <p:sp>
-          <p:nvSpPr>
-            <p:cNvPr id="10" name="Slidesgo vector icon"/>
-            <p:cNvSpPr/>
-            <p:nvPr/>
-          </p:nvSpPr>
-          <p:spPr>
-            <a:xfrm>
-              <a:off x="-63497200" y="3423400"/>
-              <a:ext cx="40975" cy="40975"/>
-            </a:xfrm>
-            <a:custGeom>
-              <a:avLst/>
-              <a:gdLst/>
-              <a:ahLst/>
-              <a:cxnLst/>
-              <a:rect l="l" t="t" r="r" b="b"/>
-              <a:pathLst>
-                <a:path w="1639" h="1639" extrusionOk="0">
-                  <a:moveTo>
-                    <a:pt x="819" y="0"/>
-                  </a:moveTo>
-                  <a:cubicBezTo>
-                    <a:pt x="378" y="0"/>
-                    <a:pt x="0" y="378"/>
-                    <a:pt x="0" y="819"/>
-                  </a:cubicBezTo>
-                  <a:cubicBezTo>
-                    <a:pt x="0" y="1260"/>
-                    <a:pt x="378" y="1638"/>
-                    <a:pt x="819" y="1638"/>
-                  </a:cubicBezTo>
-                  <a:cubicBezTo>
-                    <a:pt x="1260" y="1638"/>
-                    <a:pt x="1638" y="1260"/>
-                    <a:pt x="1638" y="819"/>
-                  </a:cubicBezTo>
-                  <a:cubicBezTo>
-                    <a:pt x="1638" y="378"/>
-                    <a:pt x="1260" y="0"/>
-                    <a:pt x="819" y="0"/>
-                  </a:cubicBezTo>
-                  <a:close/>
-                </a:path>
-              </a:pathLst>
-            </a:custGeom>
-            <a:solidFill>
-              <a:srgbClr val="007D8B"/>
-            </a:solidFill>
-            <a:ln>
-              <a:noFill/>
-            </a:ln>
-          </p:spPr>
-          <p:txBody>
-            <a:bodyPr spcFirstLastPara="1" wrap="square" lIns="91425" tIns="91425" rIns="91425" bIns="91425" anchor="ctr" anchorCtr="0">
-              <a:noAutofit/>
-            </a:bodyPr>
-            <a:lstStyle/>
-            <a:p>
-              <a:pPr marL="0" lvl="0" indent="0" algn="l" rtl="0">
-                <a:spcBef>
-                  <a:spcPts val="0"/>
-                </a:spcBef>
-                <a:spcAft>
-                  <a:spcPts val="0"/>
-                </a:spcAft>
-                <a:buNone/>
-              </a:pPr>
-              <a:endParaRPr/>
-            </a:p>
-          </p:txBody>
-        </p:sp>
-        <p:sp>
-          <p:nvSpPr>
-            <p:cNvPr id="11" name="Slidesgo vector icon"/>
-            <p:cNvSpPr/>
-            <p:nvPr/>
-          </p:nvSpPr>
-          <p:spPr>
-            <a:xfrm>
-              <a:off x="-63516900" y="3485625"/>
-              <a:ext cx="79575" cy="29950"/>
-            </a:xfrm>
-            <a:custGeom>
-              <a:avLst/>
-              <a:gdLst/>
-              <a:ahLst/>
-              <a:cxnLst/>
-              <a:rect l="l" t="t" r="r" b="b"/>
-              <a:pathLst>
-                <a:path w="3183" h="1198" extrusionOk="0">
-                  <a:moveTo>
-                    <a:pt x="1607" y="0"/>
-                  </a:moveTo>
-                  <a:cubicBezTo>
-                    <a:pt x="820" y="0"/>
-                    <a:pt x="190" y="504"/>
-                    <a:pt x="1" y="1197"/>
-                  </a:cubicBezTo>
-                  <a:lnTo>
-                    <a:pt x="3183" y="1197"/>
-                  </a:lnTo>
-                  <a:cubicBezTo>
-                    <a:pt x="3025" y="504"/>
-                    <a:pt x="2395" y="0"/>
-                    <a:pt x="1607" y="0"/>
-                  </a:cubicBezTo>
-                  <a:close/>
-                </a:path>
-              </a:pathLst>
-            </a:custGeom>
-            <a:solidFill>
-              <a:srgbClr val="007D8B"/>
-            </a:solidFill>
-            <a:ln>
-              <a:noFill/>
-            </a:ln>
-          </p:spPr>
-          <p:txBody>
-            <a:bodyPr spcFirstLastPara="1" wrap="square" lIns="91425" tIns="91425" rIns="91425" bIns="91425" anchor="ctr" anchorCtr="0">
-              <a:noAutofit/>
-            </a:bodyPr>
-            <a:lstStyle/>
-            <a:p>
-              <a:pPr marL="0" lvl="0" indent="0" algn="l" rtl="0">
-                <a:spcBef>
-                  <a:spcPts val="0"/>
-                </a:spcBef>
-                <a:spcAft>
-                  <a:spcPts val="0"/>
-                </a:spcAft>
-                <a:buNone/>
-              </a:pPr>
-              <a:endParaRPr/>
-            </a:p>
-          </p:txBody>
-        </p:sp>
-        <p:sp>
-          <p:nvSpPr>
-            <p:cNvPr id="12" name="Slidesgo vector icon"/>
-            <p:cNvSpPr/>
-            <p:nvPr/>
-          </p:nvSpPr>
-          <p:spPr>
-            <a:xfrm>
-              <a:off x="-63618500" y="3360375"/>
-              <a:ext cx="256775" cy="256600"/>
-            </a:xfrm>
-            <a:custGeom>
-              <a:avLst/>
-              <a:gdLst/>
-              <a:ahLst/>
-              <a:cxnLst/>
-              <a:rect l="l" t="t" r="r" b="b"/>
-              <a:pathLst>
-                <a:path w="10271" h="10264" extrusionOk="0">
-                  <a:moveTo>
-                    <a:pt x="5703" y="1639"/>
-                  </a:moveTo>
-                  <a:cubicBezTo>
-                    <a:pt x="6616" y="1639"/>
-                    <a:pt x="7373" y="2395"/>
-                    <a:pt x="7373" y="3309"/>
-                  </a:cubicBezTo>
-                  <a:cubicBezTo>
-                    <a:pt x="7373" y="3750"/>
-                    <a:pt x="7215" y="4128"/>
-                    <a:pt x="6900" y="4443"/>
-                  </a:cubicBezTo>
-                  <a:cubicBezTo>
-                    <a:pt x="7625" y="4884"/>
-                    <a:pt x="8192" y="5672"/>
-                    <a:pt x="8192" y="6617"/>
-                  </a:cubicBezTo>
-                  <a:cubicBezTo>
-                    <a:pt x="8160" y="6900"/>
-                    <a:pt x="8003" y="7058"/>
-                    <a:pt x="7751" y="7058"/>
-                  </a:cubicBezTo>
-                  <a:lnTo>
-                    <a:pt x="3623" y="7058"/>
-                  </a:lnTo>
-                  <a:cubicBezTo>
-                    <a:pt x="3371" y="7058"/>
-                    <a:pt x="3214" y="6837"/>
-                    <a:pt x="3214" y="6617"/>
-                  </a:cubicBezTo>
-                  <a:cubicBezTo>
-                    <a:pt x="3214" y="5672"/>
-                    <a:pt x="3749" y="4884"/>
-                    <a:pt x="4537" y="4443"/>
-                  </a:cubicBezTo>
-                  <a:cubicBezTo>
-                    <a:pt x="4254" y="4128"/>
-                    <a:pt x="4065" y="3718"/>
-                    <a:pt x="4065" y="3309"/>
-                  </a:cubicBezTo>
-                  <a:cubicBezTo>
-                    <a:pt x="4065" y="2395"/>
-                    <a:pt x="4789" y="1639"/>
-                    <a:pt x="5703" y="1639"/>
-                  </a:cubicBezTo>
-                  <a:close/>
-                  <a:moveTo>
-                    <a:pt x="5703" y="1"/>
-                  </a:moveTo>
-                  <a:cubicBezTo>
-                    <a:pt x="3182" y="1"/>
-                    <a:pt x="1135" y="2049"/>
-                    <a:pt x="1135" y="4569"/>
-                  </a:cubicBezTo>
-                  <a:cubicBezTo>
-                    <a:pt x="1135" y="5609"/>
-                    <a:pt x="1481" y="6648"/>
-                    <a:pt x="2206" y="7467"/>
-                  </a:cubicBezTo>
-                  <a:lnTo>
-                    <a:pt x="1607" y="8066"/>
-                  </a:lnTo>
-                  <a:lnTo>
-                    <a:pt x="756" y="7184"/>
-                  </a:lnTo>
-                  <a:cubicBezTo>
-                    <a:pt x="678" y="7121"/>
-                    <a:pt x="567" y="7089"/>
-                    <a:pt x="457" y="7089"/>
-                  </a:cubicBezTo>
-                  <a:cubicBezTo>
-                    <a:pt x="347" y="7089"/>
-                    <a:pt x="237" y="7121"/>
-                    <a:pt x="158" y="7184"/>
-                  </a:cubicBezTo>
-                  <a:cubicBezTo>
-                    <a:pt x="0" y="7341"/>
-                    <a:pt x="0" y="7625"/>
-                    <a:pt x="158" y="7783"/>
-                  </a:cubicBezTo>
-                  <a:lnTo>
-                    <a:pt x="1324" y="8980"/>
-                  </a:lnTo>
-                  <a:lnTo>
-                    <a:pt x="2521" y="10145"/>
-                  </a:lnTo>
-                  <a:cubicBezTo>
-                    <a:pt x="2600" y="10224"/>
-                    <a:pt x="2710" y="10264"/>
-                    <a:pt x="2820" y="10264"/>
-                  </a:cubicBezTo>
-                  <a:cubicBezTo>
-                    <a:pt x="2930" y="10264"/>
-                    <a:pt x="3041" y="10224"/>
-                    <a:pt x="3119" y="10145"/>
-                  </a:cubicBezTo>
-                  <a:cubicBezTo>
-                    <a:pt x="3277" y="9988"/>
-                    <a:pt x="3277" y="9704"/>
-                    <a:pt x="3119" y="9547"/>
-                  </a:cubicBezTo>
-                  <a:lnTo>
-                    <a:pt x="2237" y="8696"/>
-                  </a:lnTo>
-                  <a:lnTo>
-                    <a:pt x="2836" y="8098"/>
-                  </a:lnTo>
-                  <a:cubicBezTo>
-                    <a:pt x="3655" y="8759"/>
-                    <a:pt x="4695" y="9169"/>
-                    <a:pt x="5734" y="9169"/>
-                  </a:cubicBezTo>
-                  <a:cubicBezTo>
-                    <a:pt x="8255" y="9169"/>
-                    <a:pt x="10271" y="7121"/>
-                    <a:pt x="10271" y="4632"/>
-                  </a:cubicBezTo>
-                  <a:cubicBezTo>
-                    <a:pt x="10239" y="2049"/>
-                    <a:pt x="8223" y="1"/>
-                    <a:pt x="5703" y="1"/>
-                  </a:cubicBezTo>
-                  <a:close/>
-                </a:path>
-              </a:pathLst>
-            </a:custGeom>
-            <a:solidFill>
-              <a:srgbClr val="007D8B"/>
-            </a:solidFill>
-            <a:ln>
-              <a:noFill/>
-            </a:ln>
-          </p:spPr>
-          <p:txBody>
-            <a:bodyPr spcFirstLastPara="1" wrap="square" lIns="91425" tIns="91425" rIns="91425" bIns="91425" anchor="ctr" anchorCtr="0">
-              <a:noAutofit/>
-            </a:bodyPr>
-            <a:lstStyle/>
-            <a:p>
-              <a:pPr marL="0" lvl="0" indent="0" algn="l" rtl="0">
-                <a:spcBef>
-                  <a:spcPts val="0"/>
-                </a:spcBef>
-                <a:spcAft>
-                  <a:spcPts val="0"/>
-                </a:spcAft>
-                <a:buNone/>
-              </a:pPr>
-              <a:endParaRPr/>
-            </a:p>
-          </p:txBody>
-        </p:sp>
-        <p:sp>
-          <p:nvSpPr>
-            <p:cNvPr id="13" name="Slidesgo vector icon"/>
-            <p:cNvSpPr/>
-            <p:nvPr/>
-          </p:nvSpPr>
-          <p:spPr>
-            <a:xfrm>
-              <a:off x="-63679950" y="3576200"/>
-              <a:ext cx="102425" cy="100825"/>
-            </a:xfrm>
-            <a:custGeom>
-              <a:avLst/>
-              <a:gdLst/>
-              <a:ahLst/>
-              <a:cxnLst/>
-              <a:rect l="l" t="t" r="r" b="b"/>
-              <a:pathLst>
-                <a:path w="4097" h="4033" extrusionOk="0">
-                  <a:moveTo>
-                    <a:pt x="2332" y="0"/>
-                  </a:moveTo>
-                  <a:lnTo>
-                    <a:pt x="159" y="2142"/>
-                  </a:lnTo>
-                  <a:cubicBezTo>
-                    <a:pt x="1" y="2300"/>
-                    <a:pt x="1" y="2584"/>
-                    <a:pt x="159" y="2741"/>
-                  </a:cubicBezTo>
-                  <a:lnTo>
-                    <a:pt x="1356" y="3938"/>
-                  </a:lnTo>
-                  <a:cubicBezTo>
-                    <a:pt x="1434" y="4001"/>
-                    <a:pt x="1545" y="4033"/>
-                    <a:pt x="1655" y="4033"/>
-                  </a:cubicBezTo>
-                  <a:cubicBezTo>
-                    <a:pt x="1765" y="4033"/>
-                    <a:pt x="1876" y="4001"/>
-                    <a:pt x="1954" y="3938"/>
-                  </a:cubicBezTo>
-                  <a:lnTo>
-                    <a:pt x="4097" y="1764"/>
-                  </a:lnTo>
-                  <a:lnTo>
-                    <a:pt x="2332" y="0"/>
-                  </a:lnTo>
-                  <a:close/>
-                </a:path>
-              </a:pathLst>
-            </a:custGeom>
-            <a:solidFill>
-              <a:srgbClr val="007D8B"/>
-            </a:solidFill>
-            <a:ln>
-              <a:noFill/>
-            </a:ln>
-          </p:spPr>
-          <p:txBody>
-            <a:bodyPr spcFirstLastPara="1" wrap="square" lIns="91425" tIns="91425" rIns="91425" bIns="91425" anchor="ctr" anchorCtr="0">
-              <a:noAutofit/>
-            </a:bodyPr>
-            <a:lstStyle/>
-            <a:p>
-              <a:pPr marL="0" lvl="0" indent="0" algn="l" rtl="0">
-                <a:spcBef>
-                  <a:spcPts val="0"/>
-                </a:spcBef>
-                <a:spcAft>
-                  <a:spcPts val="0"/>
-                </a:spcAft>
-                <a:buNone/>
-              </a:pPr>
-              <a:endParaRPr/>
-            </a:p>
-          </p:txBody>
-        </p:sp>
-      </p:grpSp>
-      <p:sp>
-        <p:nvSpPr>
-          <p:cNvPr id="14" name="Text"/>
-          <p:cNvSpPr txBox="1"/>
-          <p:nvPr/>
-        </p:nvSpPr>
-        <p:spPr>
-          <a:xfrm>
-            <a:off x="495300" y="2686050"/>
-            <a:ext cx="2409825" cy="466725"/>
-          </a:xfrm>
-          <a:prstGeom prst="rect">
-            <a:avLst/>
-          </a:prstGeom>
-          <a:noFill/>
-          <a:ln w="9525">
-            <a:noFill/>
-          </a:ln>
-        </p:spPr>
-        <p:txBody>
-          <a:bodyPr wrap="none" lIns="0" tIns="0" rIns="0" bIns="0" anchor="t">
-            <a:noAutofit/>
-          </a:bodyPr>
-          <a:lstStyle/>
-          <a:p>
-            <a:pPr marL="0" indent="0" algn="ctr">
-              <a:lnSpc>
-                <a:spcPts val="2906"/>
-              </a:lnSpc>
-              <a:spcAft>
-                <a:spcPts val="0"/>
-              </a:spcAft>
-              <a:buNone/>
-            </a:pPr>
-            <a:r>
-              <a:rPr lang="en-US" sz="2325" b="1">
-                <a:solidFill>
-                  <a:srgbClr val="435D74"/>
-                </a:solidFill>
-                <a:latin typeface="Fira Sans Extra Condensed"/>
-                <a:ea typeface="Fira Sans Extra Condensed"/>
-                <a:cs typeface="Fira Sans Extra Condensed"/>
-              </a:rPr>
-              <a:t>Suggestion only</a:t>
-            </a:r>
-            <a:endParaRPr lang="en-US" sz="2325"/>
-          </a:p>
-        </p:txBody>
-      </p:sp>
-      <p:sp>
-        <p:nvSpPr>
-          <p:cNvPr id="15" name="Text"/>
-          <p:cNvSpPr txBox="1"/>
-          <p:nvPr/>
-        </p:nvSpPr>
-        <p:spPr>
-          <a:xfrm>
-            <a:off x="495300" y="3343275"/>
-            <a:ext cx="2409825" cy="685800"/>
-          </a:xfrm>
-          <a:prstGeom prst="rect">
-            <a:avLst/>
-          </a:prstGeom>
-          <a:noFill/>
-          <a:ln w="9525">
-            <a:noFill/>
-          </a:ln>
-        </p:spPr>
-        <p:txBody>
-          <a:bodyPr wrap="none" lIns="0" tIns="0" rIns="0" bIns="0" anchor="t">
-            <a:noAutofit/>
-          </a:bodyPr>
-          <a:lstStyle/>
-          <a:p>
-            <a:pPr marL="0" indent="0" algn="ctr">
-              <a:lnSpc>
-                <a:spcPts val="1781"/>
-              </a:lnSpc>
-              <a:spcAft>
-                <a:spcPts val="0"/>
-              </a:spcAft>
-              <a:buNone/>
-            </a:pPr>
-            <a:r>
-              <a:rPr lang="en-US" sz="1425" b="0">
-                <a:solidFill>
-                  <a:srgbClr val="435D74"/>
-                </a:solidFill>
-                <a:latin typeface="Roboto"/>
-                <a:ea typeface="Roboto"/>
-                <a:cs typeface="Roboto"/>
-              </a:rPr>
-              <a:t>System gives options.</a:t>
-            </a:r>
-            <a:endParaRPr lang="en-US" sz="1425"/>
-          </a:p>
-          <a:p>
-            <a:pPr marL="0" indent="0" algn="ctr">
-              <a:lnSpc>
-                <a:spcPts val="1781"/>
-              </a:lnSpc>
-              <a:spcAft>
-                <a:spcPts val="0"/>
-              </a:spcAft>
-              <a:buNone/>
-            </a:pPr>
-            <a:r>
-              <a:rPr lang="en-US" sz="1425" b="0">
-                <a:solidFill>
-                  <a:srgbClr val="435D74"/>
-                </a:solidFill>
-                <a:latin typeface="Roboto"/>
-                <a:ea typeface="Roboto"/>
-                <a:cs typeface="Roboto"/>
-              </a:rPr>
-              <a:t>A person chooses and acts.</a:t>
-            </a:r>
-            <a:endParaRPr lang="en-US" sz="1425"/>
-          </a:p>
-        </p:txBody>
-      </p:sp>
-      <p:cxnSp>
-        <p:nvCxnSpPr>
-          <p:cNvPr id="16" name="Connector"/>
-          <p:cNvCxnSpPr/>
-          <p:nvPr/>
-        </p:nvCxnSpPr>
-        <p:spPr>
-          <a:xfrm>
-            <a:off x="2466975" y="2000250"/>
-            <a:ext cx="714375" cy="95"/>
-          </a:xfrm>
-          <a:prstGeom prst="line">
-            <a:avLst/>
-          </a:prstGeom>
-          <a:ln w="19050">
-            <a:solidFill>
-              <a:srgbClr val="869FB2"/>
-            </a:solidFill>
-            <a:tailEnd type="triangle" w="sm" len="sm"/>
-          </a:ln>
-        </p:spPr>
-      </p:cxnSp>
-      <p:sp>
-        <p:nvSpPr>
-          <p:cNvPr id="17" name="Circle"/>
-          <p:cNvSpPr/>
-          <p:nvPr/>
-        </p:nvSpPr>
-        <p:spPr>
-          <a:xfrm>
-            <a:off x="4152900" y="1619250"/>
-            <a:ext cx="781050" cy="781050"/>
-          </a:xfrm>
-          <a:prstGeom prst="ellipse">
-            <a:avLst/>
-          </a:prstGeom>
-          <a:solidFill>
-            <a:srgbClr val="F3F6F8"/>
-          </a:solidFill>
-          <a:ln w="9525">
-            <a:noFill/>
-          </a:ln>
-        </p:spPr>
-        <p:txBody>
-          <a:bodyPr/>
-          <a:lstStyle/>
-          <a:p>
-            <a:endParaRPr lang="en-US"/>
-          </a:p>
-        </p:txBody>
-      </p:sp>
-      <p:grpSp>
-        <p:nvGrpSpPr>
-          <p:cNvPr id="18" name="Slidesgo vector icon"/>
-          <p:cNvGrpSpPr/>
-          <p:nvPr/>
-        </p:nvGrpSpPr>
-        <p:grpSpPr>
-          <a:xfrm>
-            <a:off x="4371975" y="1828800"/>
-            <a:ext cx="333375" cy="333375"/>
-            <a:chOff x="1487200" y="4993750"/>
-            <a:chExt cx="483125" cy="483125"/>
-          </a:xfrm>
-        </p:grpSpPr>
-        <p:sp>
-          <p:nvSpPr>
-            <p:cNvPr id="19" name="Slidesgo vector icon"/>
-            <p:cNvSpPr/>
-            <p:nvPr/>
-          </p:nvSpPr>
-          <p:spPr>
-            <a:xfrm>
-              <a:off x="1487200" y="4993750"/>
-              <a:ext cx="483125" cy="483125"/>
-            </a:xfrm>
-            <a:custGeom>
-              <a:avLst/>
-              <a:gdLst/>
-              <a:ahLst/>
-              <a:cxnLst/>
-              <a:rect l="l" t="t" r="r" b="b"/>
-              <a:pathLst>
-                <a:path w="19325" h="19325" extrusionOk="0">
-                  <a:moveTo>
-                    <a:pt x="9662" y="1133"/>
-                  </a:moveTo>
-                  <a:cubicBezTo>
-                    <a:pt x="11824" y="1133"/>
-                    <a:pt x="13983" y="1975"/>
-                    <a:pt x="15668" y="3657"/>
-                  </a:cubicBezTo>
-                  <a:cubicBezTo>
-                    <a:pt x="19035" y="7027"/>
-                    <a:pt x="19035" y="12302"/>
-                    <a:pt x="15668" y="15668"/>
-                  </a:cubicBezTo>
-                  <a:cubicBezTo>
-                    <a:pt x="13983" y="17352"/>
-                    <a:pt x="11822" y="18193"/>
-                    <a:pt x="9661" y="18193"/>
-                  </a:cubicBezTo>
-                  <a:cubicBezTo>
-                    <a:pt x="7500" y="18193"/>
-                    <a:pt x="5340" y="17352"/>
-                    <a:pt x="3657" y="15668"/>
-                  </a:cubicBezTo>
-                  <a:cubicBezTo>
-                    <a:pt x="290" y="12302"/>
-                    <a:pt x="290" y="7024"/>
-                    <a:pt x="3657" y="3657"/>
-                  </a:cubicBezTo>
-                  <a:cubicBezTo>
-                    <a:pt x="5342" y="1975"/>
-                    <a:pt x="7500" y="1133"/>
-                    <a:pt x="9662" y="1133"/>
-                  </a:cubicBezTo>
-                  <a:close/>
-                  <a:moveTo>
-                    <a:pt x="9662" y="1"/>
-                  </a:moveTo>
-                  <a:cubicBezTo>
-                    <a:pt x="7117" y="1"/>
-                    <a:pt x="4698" y="1015"/>
-                    <a:pt x="2857" y="2857"/>
-                  </a:cubicBezTo>
-                  <a:cubicBezTo>
-                    <a:pt x="1015" y="4699"/>
-                    <a:pt x="0" y="7117"/>
-                    <a:pt x="0" y="9663"/>
-                  </a:cubicBezTo>
-                  <a:cubicBezTo>
-                    <a:pt x="0" y="12208"/>
-                    <a:pt x="1015" y="14627"/>
-                    <a:pt x="2857" y="16469"/>
-                  </a:cubicBezTo>
-                  <a:cubicBezTo>
-                    <a:pt x="4698" y="18310"/>
-                    <a:pt x="7117" y="19325"/>
-                    <a:pt x="9662" y="19325"/>
-                  </a:cubicBezTo>
-                  <a:cubicBezTo>
-                    <a:pt x="12208" y="19325"/>
-                    <a:pt x="14626" y="18310"/>
-                    <a:pt x="16468" y="16469"/>
-                  </a:cubicBezTo>
-                  <a:cubicBezTo>
-                    <a:pt x="18310" y="14627"/>
-                    <a:pt x="19325" y="12208"/>
-                    <a:pt x="19325" y="9663"/>
-                  </a:cubicBezTo>
-                  <a:cubicBezTo>
-                    <a:pt x="19325" y="7117"/>
-                    <a:pt x="18310" y="4699"/>
-                    <a:pt x="16468" y="2857"/>
-                  </a:cubicBezTo>
-                  <a:cubicBezTo>
-                    <a:pt x="14626" y="1015"/>
-                    <a:pt x="12208" y="1"/>
-                    <a:pt x="9662" y="1"/>
-                  </a:cubicBezTo>
-                  <a:close/>
-                </a:path>
-              </a:pathLst>
-            </a:custGeom>
-            <a:solidFill>
-              <a:srgbClr val="007D8B"/>
-            </a:solidFill>
-            <a:ln>
-              <a:noFill/>
-            </a:ln>
-          </p:spPr>
-          <p:txBody>
-            <a:bodyPr spcFirstLastPara="1" wrap="square" lIns="91425" tIns="91425" rIns="91425" bIns="91425" anchor="ctr" anchorCtr="0">
-              <a:noAutofit/>
-            </a:bodyPr>
-            <a:lstStyle/>
-            <a:p>
-              <a:pPr marL="0" lvl="0" indent="0" algn="l" rtl="0">
-                <a:spcBef>
-                  <a:spcPts val="0"/>
-                </a:spcBef>
-                <a:spcAft>
-                  <a:spcPts val="0"/>
-                </a:spcAft>
-                <a:buNone/>
-              </a:pPr>
-              <a:endParaRPr>
-                <a:solidFill>
-                  <a:srgbClr val="007D8B"/>
-                </a:solidFill>
-              </a:endParaRPr>
-            </a:p>
-          </p:txBody>
-        </p:sp>
-        <p:sp>
-          <p:nvSpPr>
-            <p:cNvPr id="20" name="Slidesgo vector icon"/>
-            <p:cNvSpPr/>
-            <p:nvPr/>
-          </p:nvSpPr>
-          <p:spPr>
-            <a:xfrm>
-              <a:off x="1602600" y="5143950"/>
-              <a:ext cx="250350" cy="182725"/>
-            </a:xfrm>
-            <a:custGeom>
-              <a:avLst/>
-              <a:gdLst/>
-              <a:ahLst/>
-              <a:cxnLst/>
-              <a:rect l="l" t="t" r="r" b="b"/>
-              <a:pathLst>
-                <a:path w="10014" h="7309" extrusionOk="0">
-                  <a:moveTo>
-                    <a:pt x="8149" y="1134"/>
-                  </a:moveTo>
-                  <a:cubicBezTo>
-                    <a:pt x="8294" y="1134"/>
-                    <a:pt x="8439" y="1189"/>
-                    <a:pt x="8549" y="1300"/>
-                  </a:cubicBezTo>
-                  <a:cubicBezTo>
-                    <a:pt x="8769" y="1520"/>
-                    <a:pt x="8769" y="1879"/>
-                    <a:pt x="8549" y="2100"/>
-                  </a:cubicBezTo>
-                  <a:lnTo>
-                    <a:pt x="4639" y="6007"/>
-                  </a:lnTo>
-                  <a:cubicBezTo>
-                    <a:pt x="4527" y="6120"/>
-                    <a:pt x="4377" y="6177"/>
-                    <a:pt x="4227" y="6177"/>
-                  </a:cubicBezTo>
-                  <a:cubicBezTo>
-                    <a:pt x="4081" y="6177"/>
-                    <a:pt x="3937" y="6123"/>
-                    <a:pt x="3830" y="6016"/>
-                  </a:cubicBezTo>
-                  <a:lnTo>
-                    <a:pt x="1547" y="3748"/>
-                  </a:lnTo>
-                  <a:cubicBezTo>
-                    <a:pt x="1296" y="3534"/>
-                    <a:pt x="1281" y="3151"/>
-                    <a:pt x="1514" y="2918"/>
-                  </a:cubicBezTo>
-                  <a:cubicBezTo>
-                    <a:pt x="1626" y="2806"/>
-                    <a:pt x="1771" y="2750"/>
-                    <a:pt x="1916" y="2750"/>
-                  </a:cubicBezTo>
-                  <a:cubicBezTo>
-                    <a:pt x="2074" y="2750"/>
-                    <a:pt x="2232" y="2817"/>
-                    <a:pt x="2344" y="2948"/>
-                  </a:cubicBezTo>
-                  <a:lnTo>
-                    <a:pt x="3784" y="4388"/>
-                  </a:lnTo>
-                  <a:cubicBezTo>
-                    <a:pt x="3793" y="4401"/>
-                    <a:pt x="3805" y="4410"/>
-                    <a:pt x="3817" y="4419"/>
-                  </a:cubicBezTo>
-                  <a:cubicBezTo>
-                    <a:pt x="3817" y="4422"/>
-                    <a:pt x="3820" y="4422"/>
-                    <a:pt x="3823" y="4425"/>
-                  </a:cubicBezTo>
-                  <a:cubicBezTo>
-                    <a:pt x="3934" y="4535"/>
-                    <a:pt x="4078" y="4590"/>
-                    <a:pt x="4222" y="4590"/>
-                  </a:cubicBezTo>
-                  <a:cubicBezTo>
-                    <a:pt x="4367" y="4590"/>
-                    <a:pt x="4512" y="4535"/>
-                    <a:pt x="4624" y="4425"/>
-                  </a:cubicBezTo>
-                  <a:lnTo>
-                    <a:pt x="7749" y="1300"/>
-                  </a:lnTo>
-                  <a:cubicBezTo>
-                    <a:pt x="7859" y="1189"/>
-                    <a:pt x="8004" y="1134"/>
-                    <a:pt x="8149" y="1134"/>
-                  </a:cubicBezTo>
-                  <a:close/>
-                  <a:moveTo>
-                    <a:pt x="8146" y="1"/>
-                  </a:moveTo>
-                  <a:cubicBezTo>
-                    <a:pt x="7712" y="1"/>
-                    <a:pt x="7279" y="166"/>
-                    <a:pt x="6949" y="496"/>
-                  </a:cubicBezTo>
-                  <a:lnTo>
-                    <a:pt x="6946" y="496"/>
-                  </a:lnTo>
-                  <a:lnTo>
-                    <a:pt x="4219" y="3223"/>
-                  </a:lnTo>
-                  <a:lnTo>
-                    <a:pt x="3144" y="2148"/>
-                  </a:lnTo>
-                  <a:cubicBezTo>
-                    <a:pt x="2808" y="1779"/>
-                    <a:pt x="2348" y="1594"/>
-                    <a:pt x="1887" y="1594"/>
-                  </a:cubicBezTo>
-                  <a:cubicBezTo>
-                    <a:pt x="1453" y="1594"/>
-                    <a:pt x="1019" y="1758"/>
-                    <a:pt x="686" y="2091"/>
-                  </a:cubicBezTo>
-                  <a:cubicBezTo>
-                    <a:pt x="1" y="2776"/>
-                    <a:pt x="28" y="3896"/>
-                    <a:pt x="747" y="4549"/>
-                  </a:cubicBezTo>
-                  <a:lnTo>
-                    <a:pt x="3029" y="6819"/>
-                  </a:lnTo>
-                  <a:cubicBezTo>
-                    <a:pt x="3344" y="7131"/>
-                    <a:pt x="3768" y="7308"/>
-                    <a:pt x="4214" y="7308"/>
-                  </a:cubicBezTo>
-                  <a:cubicBezTo>
-                    <a:pt x="4218" y="7308"/>
-                    <a:pt x="4221" y="7308"/>
-                    <a:pt x="4225" y="7308"/>
-                  </a:cubicBezTo>
-                  <a:cubicBezTo>
-                    <a:pt x="4678" y="7308"/>
-                    <a:pt x="5116" y="7127"/>
-                    <a:pt x="5439" y="6807"/>
-                  </a:cubicBezTo>
-                  <a:lnTo>
-                    <a:pt x="9349" y="2900"/>
-                  </a:lnTo>
-                  <a:cubicBezTo>
-                    <a:pt x="10013" y="2236"/>
-                    <a:pt x="10013" y="1161"/>
-                    <a:pt x="9349" y="499"/>
-                  </a:cubicBezTo>
-                  <a:cubicBezTo>
-                    <a:pt x="9017" y="167"/>
-                    <a:pt x="8581" y="1"/>
-                    <a:pt x="8146" y="1"/>
-                  </a:cubicBezTo>
-                  <a:close/>
-                </a:path>
-              </a:pathLst>
-            </a:custGeom>
-            <a:solidFill>
-              <a:srgbClr val="007D8B"/>
-            </a:solidFill>
-            <a:ln>
-              <a:noFill/>
-            </a:ln>
-          </p:spPr>
-          <p:txBody>
-            <a:bodyPr spcFirstLastPara="1" wrap="square" lIns="91425" tIns="91425" rIns="91425" bIns="91425" anchor="ctr" anchorCtr="0">
-              <a:noAutofit/>
-            </a:bodyPr>
-            <a:lstStyle/>
-            <a:p>
-              <a:pPr marL="0" lvl="0" indent="0" algn="l" rtl="0">
-                <a:spcBef>
-                  <a:spcPts val="0"/>
-                </a:spcBef>
-                <a:spcAft>
-                  <a:spcPts val="0"/>
-                </a:spcAft>
-                <a:buNone/>
-              </a:pPr>
-              <a:endParaRPr>
-                <a:solidFill>
-                  <a:srgbClr val="007D8B"/>
-                </a:solidFill>
-              </a:endParaRPr>
-            </a:p>
-          </p:txBody>
-        </p:sp>
-      </p:grpSp>
-      <p:sp>
-        <p:nvSpPr>
-          <p:cNvPr id="21" name="Text"/>
-          <p:cNvSpPr txBox="1"/>
-          <p:nvPr/>
-        </p:nvSpPr>
-        <p:spPr>
-          <a:xfrm>
-            <a:off x="3371850" y="2686050"/>
-            <a:ext cx="2409825" cy="466725"/>
-          </a:xfrm>
-          <a:prstGeom prst="rect">
-            <a:avLst/>
-          </a:prstGeom>
-          <a:noFill/>
-          <a:ln w="9525">
-            <a:noFill/>
-          </a:ln>
-        </p:spPr>
-        <p:txBody>
-          <a:bodyPr wrap="none" lIns="0" tIns="0" rIns="0" bIns="0" anchor="t">
-            <a:noAutofit/>
-          </a:bodyPr>
-          <a:lstStyle/>
-          <a:p>
-            <a:pPr marL="0" indent="0" algn="ctr">
-              <a:lnSpc>
-                <a:spcPts val="2906"/>
-              </a:lnSpc>
-              <a:spcAft>
-                <a:spcPts val="0"/>
-              </a:spcAft>
-              <a:buNone/>
-            </a:pPr>
-            <a:r>
-              <a:rPr lang="en-US" sz="2325" b="1">
-                <a:solidFill>
-                  <a:srgbClr val="435D74"/>
-                </a:solidFill>
-                <a:latin typeface="Fira Sans Extra Condensed"/>
-                <a:ea typeface="Fira Sans Extra Condensed"/>
-                <a:cs typeface="Fira Sans Extra Condensed"/>
-              </a:rPr>
-              <a:t>Approval needed</a:t>
-            </a:r>
-            <a:endParaRPr lang="en-US" sz="2325"/>
-          </a:p>
-        </p:txBody>
-      </p:sp>
-      <p:sp>
-        <p:nvSpPr>
-          <p:cNvPr id="22" name="Text"/>
-          <p:cNvSpPr txBox="1"/>
-          <p:nvPr/>
-        </p:nvSpPr>
-        <p:spPr>
-          <a:xfrm>
-            <a:off x="3371850" y="3343275"/>
-            <a:ext cx="2409825" cy="685800"/>
-          </a:xfrm>
-          <a:prstGeom prst="rect">
-            <a:avLst/>
-          </a:prstGeom>
-          <a:noFill/>
-          <a:ln w="9525">
-            <a:noFill/>
-          </a:ln>
-        </p:spPr>
-        <p:txBody>
-          <a:bodyPr wrap="none" lIns="0" tIns="0" rIns="0" bIns="0" anchor="t">
-            <a:noAutofit/>
-          </a:bodyPr>
-          <a:lstStyle/>
-          <a:p>
-            <a:pPr marL="0" indent="0" algn="ctr">
-              <a:lnSpc>
-                <a:spcPts val="1781"/>
-              </a:lnSpc>
-              <a:spcAft>
-                <a:spcPts val="0"/>
-              </a:spcAft>
-              <a:buNone/>
-            </a:pPr>
-            <a:r>
-              <a:rPr lang="en-US" sz="1425" b="0">
-                <a:solidFill>
-                  <a:srgbClr val="435D74"/>
-                </a:solidFill>
-                <a:latin typeface="Roboto"/>
-                <a:ea typeface="Roboto"/>
-                <a:cs typeface="Roboto"/>
-              </a:rPr>
-              <a:t>System prepares a plan.</a:t>
-            </a:r>
-            <a:endParaRPr lang="en-US" sz="1425"/>
-          </a:p>
-          <a:p>
-            <a:pPr marL="0" indent="0" algn="ctr">
-              <a:lnSpc>
-                <a:spcPts val="1781"/>
-              </a:lnSpc>
-              <a:spcAft>
-                <a:spcPts val="0"/>
-              </a:spcAft>
-              <a:buNone/>
-            </a:pPr>
-            <a:r>
-              <a:rPr lang="en-US" sz="1425" b="0">
-                <a:solidFill>
-                  <a:srgbClr val="435D74"/>
-                </a:solidFill>
-                <a:latin typeface="Roboto"/>
-                <a:ea typeface="Roboto"/>
-                <a:cs typeface="Roboto"/>
-              </a:rPr>
-              <a:t>A person approves it.</a:t>
-            </a:r>
-            <a:endParaRPr lang="en-US" sz="1425"/>
-          </a:p>
-        </p:txBody>
-      </p:sp>
-      <p:cxnSp>
-        <p:nvCxnSpPr>
-          <p:cNvPr id="23" name="Connector"/>
-          <p:cNvCxnSpPr/>
-          <p:nvPr/>
-        </p:nvCxnSpPr>
-        <p:spPr>
-          <a:xfrm>
-            <a:off x="5343525" y="2000250"/>
-            <a:ext cx="714375" cy="95"/>
-          </a:xfrm>
-          <a:prstGeom prst="line">
-            <a:avLst/>
-          </a:prstGeom>
-          <a:ln w="19050">
-            <a:solidFill>
-              <a:srgbClr val="869FB2"/>
-            </a:solidFill>
-            <a:tailEnd type="triangle" w="sm" len="sm"/>
-          </a:ln>
-        </p:spPr>
-      </p:cxnSp>
-      <p:sp>
-        <p:nvSpPr>
-          <p:cNvPr id="24" name="Circle"/>
-          <p:cNvSpPr/>
-          <p:nvPr/>
-        </p:nvSpPr>
-        <p:spPr>
-          <a:xfrm>
-            <a:off x="7029450" y="1619250"/>
-            <a:ext cx="781050" cy="781050"/>
-          </a:xfrm>
-          <a:prstGeom prst="ellipse">
-            <a:avLst/>
-          </a:prstGeom>
-          <a:solidFill>
-            <a:srgbClr val="435D74"/>
-          </a:solidFill>
-          <a:ln w="9525">
-            <a:noFill/>
-          </a:ln>
-        </p:spPr>
-        <p:txBody>
-          <a:bodyPr/>
-          <a:lstStyle/>
-          <a:p>
-            <a:endParaRPr lang="en-US"/>
-          </a:p>
-        </p:txBody>
-      </p:sp>
-      <p:grpSp>
-        <p:nvGrpSpPr>
-          <p:cNvPr id="25" name="Slidesgo vector icon"/>
-          <p:cNvGrpSpPr/>
-          <p:nvPr/>
-        </p:nvGrpSpPr>
-        <p:grpSpPr>
-          <a:xfrm>
-            <a:off x="7248525" y="1828800"/>
-            <a:ext cx="333375" cy="333367"/>
-            <a:chOff x="1412450" y="1954475"/>
-            <a:chExt cx="297750" cy="296175"/>
-          </a:xfrm>
-        </p:grpSpPr>
-        <p:sp>
-          <p:nvSpPr>
-            <p:cNvPr id="26" name="Slidesgo vector icon"/>
-            <p:cNvSpPr/>
-            <p:nvPr/>
-          </p:nvSpPr>
-          <p:spPr>
-            <a:xfrm>
-              <a:off x="1483350" y="2023800"/>
-              <a:ext cx="155975" cy="155975"/>
-            </a:xfrm>
-            <a:custGeom>
-              <a:avLst/>
-              <a:gdLst/>
-              <a:ahLst/>
-              <a:cxnLst/>
-              <a:rect l="l" t="t" r="r" b="b"/>
-              <a:pathLst>
-                <a:path w="6239" h="6239" extrusionOk="0">
-                  <a:moveTo>
-                    <a:pt x="3119" y="2079"/>
-                  </a:moveTo>
-                  <a:cubicBezTo>
-                    <a:pt x="3529" y="2079"/>
-                    <a:pt x="3844" y="2395"/>
-                    <a:pt x="3844" y="2773"/>
-                  </a:cubicBezTo>
-                  <a:cubicBezTo>
-                    <a:pt x="3844" y="3182"/>
-                    <a:pt x="3529" y="3497"/>
-                    <a:pt x="3119" y="3497"/>
-                  </a:cubicBezTo>
-                  <a:cubicBezTo>
-                    <a:pt x="2741" y="3497"/>
-                    <a:pt x="2426" y="3182"/>
-                    <a:pt x="2426" y="2773"/>
-                  </a:cubicBezTo>
-                  <a:cubicBezTo>
-                    <a:pt x="2426" y="2395"/>
-                    <a:pt x="2741" y="2079"/>
-                    <a:pt x="3119" y="2079"/>
-                  </a:cubicBezTo>
-                  <a:close/>
-                  <a:moveTo>
-                    <a:pt x="3119" y="725"/>
-                  </a:moveTo>
-                  <a:cubicBezTo>
-                    <a:pt x="4474" y="725"/>
-                    <a:pt x="5577" y="1827"/>
-                    <a:pt x="5577" y="3182"/>
-                  </a:cubicBezTo>
-                  <a:cubicBezTo>
-                    <a:pt x="5577" y="3686"/>
-                    <a:pt x="5388" y="4159"/>
-                    <a:pt x="5136" y="4537"/>
-                  </a:cubicBezTo>
-                  <a:cubicBezTo>
-                    <a:pt x="4884" y="4190"/>
-                    <a:pt x="4537" y="3907"/>
-                    <a:pt x="4191" y="3718"/>
-                  </a:cubicBezTo>
-                  <a:cubicBezTo>
-                    <a:pt x="4411" y="3497"/>
-                    <a:pt x="4537" y="3182"/>
-                    <a:pt x="4537" y="2804"/>
-                  </a:cubicBezTo>
-                  <a:cubicBezTo>
-                    <a:pt x="4537" y="2079"/>
-                    <a:pt x="3907" y="1449"/>
-                    <a:pt x="3151" y="1449"/>
-                  </a:cubicBezTo>
-                  <a:cubicBezTo>
-                    <a:pt x="2426" y="1449"/>
-                    <a:pt x="1796" y="2079"/>
-                    <a:pt x="1796" y="2804"/>
-                  </a:cubicBezTo>
-                  <a:cubicBezTo>
-                    <a:pt x="1796" y="3182"/>
-                    <a:pt x="1891" y="3497"/>
-                    <a:pt x="2143" y="3718"/>
-                  </a:cubicBezTo>
-                  <a:cubicBezTo>
-                    <a:pt x="1733" y="3907"/>
-                    <a:pt x="1418" y="4190"/>
-                    <a:pt x="1198" y="4537"/>
-                  </a:cubicBezTo>
-                  <a:cubicBezTo>
-                    <a:pt x="914" y="4159"/>
-                    <a:pt x="756" y="3686"/>
-                    <a:pt x="756" y="3182"/>
-                  </a:cubicBezTo>
-                  <a:cubicBezTo>
-                    <a:pt x="662" y="1796"/>
-                    <a:pt x="1796" y="725"/>
-                    <a:pt x="3119" y="725"/>
-                  </a:cubicBezTo>
-                  <a:close/>
-                  <a:moveTo>
-                    <a:pt x="3119" y="4190"/>
-                  </a:moveTo>
-                  <a:cubicBezTo>
-                    <a:pt x="3749" y="4190"/>
-                    <a:pt x="4317" y="4505"/>
-                    <a:pt x="4632" y="5041"/>
-                  </a:cubicBezTo>
-                  <a:cubicBezTo>
-                    <a:pt x="4222" y="5387"/>
-                    <a:pt x="3686" y="5577"/>
-                    <a:pt x="3119" y="5577"/>
-                  </a:cubicBezTo>
-                  <a:cubicBezTo>
-                    <a:pt x="2584" y="5577"/>
-                    <a:pt x="2017" y="5387"/>
-                    <a:pt x="1639" y="5041"/>
-                  </a:cubicBezTo>
-                  <a:cubicBezTo>
-                    <a:pt x="1954" y="4505"/>
-                    <a:pt x="2489" y="4190"/>
-                    <a:pt x="3119" y="4190"/>
-                  </a:cubicBezTo>
-                  <a:close/>
-                  <a:moveTo>
-                    <a:pt x="3119" y="0"/>
-                  </a:moveTo>
-                  <a:cubicBezTo>
-                    <a:pt x="1387" y="0"/>
-                    <a:pt x="0" y="1418"/>
-                    <a:pt x="0" y="3119"/>
-                  </a:cubicBezTo>
-                  <a:cubicBezTo>
-                    <a:pt x="0" y="4852"/>
-                    <a:pt x="1387" y="6238"/>
-                    <a:pt x="3119" y="6238"/>
-                  </a:cubicBezTo>
-                  <a:cubicBezTo>
-                    <a:pt x="4852" y="6238"/>
-                    <a:pt x="6238" y="4820"/>
-                    <a:pt x="6238" y="3119"/>
-                  </a:cubicBezTo>
-                  <a:cubicBezTo>
-                    <a:pt x="6238" y="1386"/>
-                    <a:pt x="4821" y="0"/>
-                    <a:pt x="3119" y="0"/>
-                  </a:cubicBezTo>
-                  <a:close/>
-                </a:path>
-              </a:pathLst>
-            </a:custGeom>
-            <a:solidFill>
-              <a:srgbClr val="5FD0DB"/>
-            </a:solidFill>
-            <a:ln>
-              <a:noFill/>
-            </a:ln>
-          </p:spPr>
-          <p:txBody>
-            <a:bodyPr spcFirstLastPara="1" wrap="square" lIns="91425" tIns="91425" rIns="91425" bIns="91425" anchor="ctr" anchorCtr="0">
-              <a:noAutofit/>
-            </a:bodyPr>
-            <a:lstStyle/>
-            <a:p>
-              <a:pPr marL="0" lvl="0" indent="0" algn="l" rtl="0">
-                <a:spcBef>
-                  <a:spcPts val="0"/>
-                </a:spcBef>
-                <a:spcAft>
-                  <a:spcPts val="0"/>
-                </a:spcAft>
-                <a:buNone/>
-              </a:pPr>
-              <a:endParaRPr/>
-            </a:p>
-          </p:txBody>
-        </p:sp>
-        <p:sp>
-          <p:nvSpPr>
-            <p:cNvPr id="27" name="Slidesgo vector icon"/>
-            <p:cNvSpPr/>
-            <p:nvPr/>
-          </p:nvSpPr>
-          <p:spPr>
-            <a:xfrm>
-              <a:off x="1412450" y="1954475"/>
-              <a:ext cx="297750" cy="296175"/>
-            </a:xfrm>
-            <a:custGeom>
-              <a:avLst/>
-              <a:gdLst/>
-              <a:ahLst/>
-              <a:cxnLst/>
-              <a:rect l="l" t="t" r="r" b="b"/>
-              <a:pathLst>
-                <a:path w="11910" h="11847" extrusionOk="0">
-                  <a:moveTo>
-                    <a:pt x="6365" y="662"/>
-                  </a:moveTo>
-                  <a:lnTo>
-                    <a:pt x="6522" y="1513"/>
-                  </a:lnTo>
-                  <a:cubicBezTo>
-                    <a:pt x="6554" y="1702"/>
-                    <a:pt x="6617" y="1765"/>
-                    <a:pt x="6774" y="1797"/>
-                  </a:cubicBezTo>
-                  <a:cubicBezTo>
-                    <a:pt x="7342" y="1923"/>
-                    <a:pt x="7814" y="2112"/>
-                    <a:pt x="8287" y="2427"/>
-                  </a:cubicBezTo>
-                  <a:cubicBezTo>
-                    <a:pt x="8350" y="2474"/>
-                    <a:pt x="8421" y="2498"/>
-                    <a:pt x="8488" y="2498"/>
-                  </a:cubicBezTo>
-                  <a:cubicBezTo>
-                    <a:pt x="8554" y="2498"/>
-                    <a:pt x="8618" y="2474"/>
-                    <a:pt x="8665" y="2427"/>
-                  </a:cubicBezTo>
-                  <a:lnTo>
-                    <a:pt x="9389" y="1923"/>
-                  </a:lnTo>
-                  <a:lnTo>
-                    <a:pt x="9925" y="2490"/>
-                  </a:lnTo>
-                  <a:lnTo>
-                    <a:pt x="9421" y="3183"/>
-                  </a:lnTo>
-                  <a:cubicBezTo>
-                    <a:pt x="9358" y="3309"/>
-                    <a:pt x="9358" y="3466"/>
-                    <a:pt x="9421" y="3592"/>
-                  </a:cubicBezTo>
-                  <a:cubicBezTo>
-                    <a:pt x="9736" y="4065"/>
-                    <a:pt x="9925" y="4537"/>
-                    <a:pt x="10051" y="5073"/>
-                  </a:cubicBezTo>
-                  <a:cubicBezTo>
-                    <a:pt x="10082" y="5231"/>
-                    <a:pt x="10209" y="5294"/>
-                    <a:pt x="10335" y="5357"/>
-                  </a:cubicBezTo>
-                  <a:lnTo>
-                    <a:pt x="11185" y="5514"/>
-                  </a:lnTo>
-                  <a:lnTo>
-                    <a:pt x="11185" y="6302"/>
-                  </a:lnTo>
-                  <a:lnTo>
-                    <a:pt x="10335" y="6459"/>
-                  </a:lnTo>
-                  <a:cubicBezTo>
-                    <a:pt x="10177" y="6491"/>
-                    <a:pt x="10082" y="6585"/>
-                    <a:pt x="10051" y="6743"/>
-                  </a:cubicBezTo>
-                  <a:cubicBezTo>
-                    <a:pt x="9925" y="7278"/>
-                    <a:pt x="9736" y="7751"/>
-                    <a:pt x="9421" y="8224"/>
-                  </a:cubicBezTo>
-                  <a:cubicBezTo>
-                    <a:pt x="9358" y="8350"/>
-                    <a:pt x="9358" y="8507"/>
-                    <a:pt x="9421" y="8633"/>
-                  </a:cubicBezTo>
-                  <a:lnTo>
-                    <a:pt x="9925" y="9326"/>
-                  </a:lnTo>
-                  <a:lnTo>
-                    <a:pt x="9389" y="9893"/>
-                  </a:lnTo>
-                  <a:lnTo>
-                    <a:pt x="8665" y="9358"/>
-                  </a:lnTo>
-                  <a:cubicBezTo>
-                    <a:pt x="8618" y="9326"/>
-                    <a:pt x="8554" y="9310"/>
-                    <a:pt x="8488" y="9310"/>
-                  </a:cubicBezTo>
-                  <a:cubicBezTo>
-                    <a:pt x="8421" y="9310"/>
-                    <a:pt x="8350" y="9326"/>
-                    <a:pt x="8287" y="9358"/>
-                  </a:cubicBezTo>
-                  <a:cubicBezTo>
-                    <a:pt x="7814" y="9673"/>
-                    <a:pt x="7342" y="9893"/>
-                    <a:pt x="6774" y="9988"/>
-                  </a:cubicBezTo>
-                  <a:cubicBezTo>
-                    <a:pt x="6617" y="10051"/>
-                    <a:pt x="6554" y="10145"/>
-                    <a:pt x="6522" y="10271"/>
-                  </a:cubicBezTo>
-                  <a:lnTo>
-                    <a:pt x="6365" y="11153"/>
-                  </a:lnTo>
-                  <a:lnTo>
-                    <a:pt x="5577" y="11153"/>
-                  </a:lnTo>
-                  <a:lnTo>
-                    <a:pt x="5420" y="10271"/>
-                  </a:lnTo>
-                  <a:cubicBezTo>
-                    <a:pt x="5357" y="10114"/>
-                    <a:pt x="5294" y="10051"/>
-                    <a:pt x="5136" y="9988"/>
-                  </a:cubicBezTo>
-                  <a:cubicBezTo>
-                    <a:pt x="4569" y="9893"/>
-                    <a:pt x="4097" y="9673"/>
-                    <a:pt x="3624" y="9358"/>
-                  </a:cubicBezTo>
-                  <a:cubicBezTo>
-                    <a:pt x="3561" y="9326"/>
-                    <a:pt x="3498" y="9310"/>
-                    <a:pt x="3435" y="9310"/>
-                  </a:cubicBezTo>
-                  <a:cubicBezTo>
-                    <a:pt x="3372" y="9310"/>
-                    <a:pt x="3309" y="9326"/>
-                    <a:pt x="3246" y="9358"/>
-                  </a:cubicBezTo>
-                  <a:lnTo>
-                    <a:pt x="2521" y="9893"/>
-                  </a:lnTo>
-                  <a:lnTo>
-                    <a:pt x="1986" y="9326"/>
-                  </a:lnTo>
-                  <a:lnTo>
-                    <a:pt x="2490" y="8633"/>
-                  </a:lnTo>
-                  <a:cubicBezTo>
-                    <a:pt x="2584" y="8507"/>
-                    <a:pt x="2584" y="8350"/>
-                    <a:pt x="2490" y="8224"/>
-                  </a:cubicBezTo>
-                  <a:cubicBezTo>
-                    <a:pt x="2175" y="7751"/>
-                    <a:pt x="1986" y="7278"/>
-                    <a:pt x="1860" y="6743"/>
-                  </a:cubicBezTo>
-                  <a:cubicBezTo>
-                    <a:pt x="1828" y="6585"/>
-                    <a:pt x="1702" y="6491"/>
-                    <a:pt x="1576" y="6459"/>
-                  </a:cubicBezTo>
-                  <a:lnTo>
-                    <a:pt x="726" y="6302"/>
-                  </a:lnTo>
-                  <a:lnTo>
-                    <a:pt x="726" y="5514"/>
-                  </a:lnTo>
-                  <a:lnTo>
-                    <a:pt x="1576" y="5357"/>
-                  </a:lnTo>
-                  <a:cubicBezTo>
-                    <a:pt x="1734" y="5325"/>
-                    <a:pt x="1828" y="5231"/>
-                    <a:pt x="1860" y="5073"/>
-                  </a:cubicBezTo>
-                  <a:cubicBezTo>
-                    <a:pt x="1986" y="4506"/>
-                    <a:pt x="2175" y="4065"/>
-                    <a:pt x="2490" y="3592"/>
-                  </a:cubicBezTo>
-                  <a:cubicBezTo>
-                    <a:pt x="2584" y="3466"/>
-                    <a:pt x="2584" y="3309"/>
-                    <a:pt x="2490" y="3183"/>
-                  </a:cubicBezTo>
-                  <a:lnTo>
-                    <a:pt x="1986" y="2490"/>
-                  </a:lnTo>
-                  <a:lnTo>
-                    <a:pt x="2521" y="1923"/>
-                  </a:lnTo>
-                  <a:lnTo>
-                    <a:pt x="3246" y="2427"/>
-                  </a:lnTo>
-                  <a:cubicBezTo>
-                    <a:pt x="3309" y="2474"/>
-                    <a:pt x="3372" y="2498"/>
-                    <a:pt x="3435" y="2498"/>
-                  </a:cubicBezTo>
-                  <a:cubicBezTo>
-                    <a:pt x="3498" y="2498"/>
-                    <a:pt x="3561" y="2474"/>
-                    <a:pt x="3624" y="2427"/>
-                  </a:cubicBezTo>
-                  <a:cubicBezTo>
-                    <a:pt x="4097" y="2112"/>
-                    <a:pt x="4569" y="1923"/>
-                    <a:pt x="5136" y="1797"/>
-                  </a:cubicBezTo>
-                  <a:cubicBezTo>
-                    <a:pt x="5294" y="1765"/>
-                    <a:pt x="5357" y="1639"/>
-                    <a:pt x="5420" y="1513"/>
-                  </a:cubicBezTo>
-                  <a:lnTo>
-                    <a:pt x="5577" y="662"/>
-                  </a:lnTo>
-                  <a:close/>
-                  <a:moveTo>
-                    <a:pt x="5262" y="1"/>
-                  </a:moveTo>
-                  <a:cubicBezTo>
-                    <a:pt x="5073" y="1"/>
-                    <a:pt x="4916" y="127"/>
-                    <a:pt x="4884" y="284"/>
-                  </a:cubicBezTo>
-                  <a:lnTo>
-                    <a:pt x="4727" y="1166"/>
-                  </a:lnTo>
-                  <a:cubicBezTo>
-                    <a:pt x="4254" y="1292"/>
-                    <a:pt x="3813" y="1481"/>
-                    <a:pt x="3435" y="1734"/>
-                  </a:cubicBezTo>
-                  <a:lnTo>
-                    <a:pt x="2679" y="1229"/>
-                  </a:lnTo>
-                  <a:cubicBezTo>
-                    <a:pt x="2610" y="1174"/>
-                    <a:pt x="2541" y="1149"/>
-                    <a:pt x="2474" y="1149"/>
-                  </a:cubicBezTo>
-                  <a:cubicBezTo>
-                    <a:pt x="2389" y="1149"/>
-                    <a:pt x="2309" y="1190"/>
-                    <a:pt x="2238" y="1261"/>
-                  </a:cubicBezTo>
-                  <a:lnTo>
-                    <a:pt x="1261" y="2238"/>
-                  </a:lnTo>
-                  <a:cubicBezTo>
-                    <a:pt x="1135" y="2364"/>
-                    <a:pt x="1135" y="2553"/>
-                    <a:pt x="1230" y="2679"/>
-                  </a:cubicBezTo>
-                  <a:lnTo>
-                    <a:pt x="1734" y="3435"/>
-                  </a:lnTo>
-                  <a:cubicBezTo>
-                    <a:pt x="1513" y="3813"/>
-                    <a:pt x="1324" y="4254"/>
-                    <a:pt x="1198" y="4726"/>
-                  </a:cubicBezTo>
-                  <a:lnTo>
-                    <a:pt x="284" y="4884"/>
-                  </a:lnTo>
-                  <a:cubicBezTo>
-                    <a:pt x="127" y="4915"/>
-                    <a:pt x="1" y="5042"/>
-                    <a:pt x="1" y="5231"/>
-                  </a:cubicBezTo>
-                  <a:lnTo>
-                    <a:pt x="1" y="6617"/>
-                  </a:lnTo>
-                  <a:cubicBezTo>
-                    <a:pt x="64" y="6774"/>
-                    <a:pt x="158" y="6932"/>
-                    <a:pt x="316" y="6963"/>
-                  </a:cubicBezTo>
-                  <a:lnTo>
-                    <a:pt x="1230" y="7121"/>
-                  </a:lnTo>
-                  <a:cubicBezTo>
-                    <a:pt x="1356" y="7593"/>
-                    <a:pt x="1545" y="8034"/>
-                    <a:pt x="1797" y="8413"/>
-                  </a:cubicBezTo>
-                  <a:lnTo>
-                    <a:pt x="1261" y="9169"/>
-                  </a:lnTo>
-                  <a:cubicBezTo>
-                    <a:pt x="1167" y="9295"/>
-                    <a:pt x="1198" y="9484"/>
-                    <a:pt x="1324" y="9610"/>
-                  </a:cubicBezTo>
-                  <a:lnTo>
-                    <a:pt x="2301" y="10586"/>
-                  </a:lnTo>
-                  <a:cubicBezTo>
-                    <a:pt x="2368" y="10654"/>
-                    <a:pt x="2454" y="10685"/>
-                    <a:pt x="2533" y="10685"/>
-                  </a:cubicBezTo>
-                  <a:cubicBezTo>
-                    <a:pt x="2602" y="10685"/>
-                    <a:pt x="2666" y="10662"/>
-                    <a:pt x="2710" y="10618"/>
-                  </a:cubicBezTo>
-                  <a:lnTo>
-                    <a:pt x="3466" y="10114"/>
-                  </a:lnTo>
-                  <a:cubicBezTo>
-                    <a:pt x="3876" y="10366"/>
-                    <a:pt x="4286" y="10555"/>
-                    <a:pt x="4790" y="10681"/>
-                  </a:cubicBezTo>
-                  <a:lnTo>
-                    <a:pt x="4947" y="11563"/>
-                  </a:lnTo>
-                  <a:cubicBezTo>
-                    <a:pt x="4979" y="11721"/>
-                    <a:pt x="5105" y="11847"/>
-                    <a:pt x="5294" y="11847"/>
-                  </a:cubicBezTo>
-                  <a:lnTo>
-                    <a:pt x="6680" y="11847"/>
-                  </a:lnTo>
-                  <a:cubicBezTo>
-                    <a:pt x="6837" y="11847"/>
-                    <a:pt x="6995" y="11721"/>
-                    <a:pt x="7027" y="11563"/>
-                  </a:cubicBezTo>
-                  <a:lnTo>
-                    <a:pt x="7184" y="10681"/>
-                  </a:lnTo>
-                  <a:cubicBezTo>
-                    <a:pt x="7657" y="10555"/>
-                    <a:pt x="8098" y="10366"/>
-                    <a:pt x="8476" y="10114"/>
-                  </a:cubicBezTo>
-                  <a:lnTo>
-                    <a:pt x="9232" y="10618"/>
-                  </a:lnTo>
-                  <a:cubicBezTo>
-                    <a:pt x="9301" y="10673"/>
-                    <a:pt x="9370" y="10698"/>
-                    <a:pt x="9436" y="10698"/>
-                  </a:cubicBezTo>
-                  <a:cubicBezTo>
-                    <a:pt x="9521" y="10698"/>
-                    <a:pt x="9602" y="10657"/>
-                    <a:pt x="9673" y="10586"/>
-                  </a:cubicBezTo>
-                  <a:lnTo>
-                    <a:pt x="10650" y="9610"/>
-                  </a:lnTo>
-                  <a:cubicBezTo>
-                    <a:pt x="10776" y="9484"/>
-                    <a:pt x="10776" y="9295"/>
-                    <a:pt x="10681" y="9169"/>
-                  </a:cubicBezTo>
-                  <a:lnTo>
-                    <a:pt x="10177" y="8413"/>
-                  </a:lnTo>
-                  <a:cubicBezTo>
-                    <a:pt x="10398" y="8034"/>
-                    <a:pt x="10618" y="7593"/>
-                    <a:pt x="10713" y="7121"/>
-                  </a:cubicBezTo>
-                  <a:lnTo>
-                    <a:pt x="11626" y="6963"/>
-                  </a:lnTo>
-                  <a:cubicBezTo>
-                    <a:pt x="11784" y="6932"/>
-                    <a:pt x="11910" y="6806"/>
-                    <a:pt x="11910" y="6617"/>
-                  </a:cubicBezTo>
-                  <a:lnTo>
-                    <a:pt x="11910" y="5231"/>
-                  </a:lnTo>
-                  <a:cubicBezTo>
-                    <a:pt x="11910" y="5073"/>
-                    <a:pt x="11784" y="4915"/>
-                    <a:pt x="11626" y="4884"/>
-                  </a:cubicBezTo>
-                  <a:lnTo>
-                    <a:pt x="10713" y="4726"/>
-                  </a:lnTo>
-                  <a:cubicBezTo>
-                    <a:pt x="10618" y="4254"/>
-                    <a:pt x="10398" y="3813"/>
-                    <a:pt x="10177" y="3403"/>
-                  </a:cubicBezTo>
-                  <a:lnTo>
-                    <a:pt x="10681" y="2679"/>
-                  </a:lnTo>
-                  <a:cubicBezTo>
-                    <a:pt x="10807" y="2553"/>
-                    <a:pt x="10776" y="2364"/>
-                    <a:pt x="10650" y="2238"/>
-                  </a:cubicBezTo>
-                  <a:lnTo>
-                    <a:pt x="9673" y="1261"/>
-                  </a:lnTo>
-                  <a:cubicBezTo>
-                    <a:pt x="9605" y="1193"/>
-                    <a:pt x="9520" y="1162"/>
-                    <a:pt x="9435" y="1162"/>
-                  </a:cubicBezTo>
-                  <a:cubicBezTo>
-                    <a:pt x="9362" y="1162"/>
-                    <a:pt x="9290" y="1186"/>
-                    <a:pt x="9232" y="1229"/>
-                  </a:cubicBezTo>
-                  <a:lnTo>
-                    <a:pt x="8476" y="1734"/>
-                  </a:lnTo>
-                  <a:cubicBezTo>
-                    <a:pt x="8098" y="1481"/>
-                    <a:pt x="7657" y="1292"/>
-                    <a:pt x="7184" y="1166"/>
-                  </a:cubicBezTo>
-                  <a:lnTo>
-                    <a:pt x="6995" y="284"/>
-                  </a:lnTo>
-                  <a:cubicBezTo>
-                    <a:pt x="6932" y="127"/>
-                    <a:pt x="6837" y="1"/>
-                    <a:pt x="6617" y="1"/>
-                  </a:cubicBezTo>
-                  <a:close/>
-                </a:path>
-              </a:pathLst>
-            </a:custGeom>
-            <a:solidFill>
-              <a:srgbClr val="5FD0DB"/>
-            </a:solidFill>
-            <a:ln>
-              <a:noFill/>
-            </a:ln>
-          </p:spPr>
-          <p:txBody>
-            <a:bodyPr spcFirstLastPara="1" wrap="square" lIns="91425" tIns="91425" rIns="91425" bIns="91425" anchor="ctr" anchorCtr="0">
-              <a:noAutofit/>
-            </a:bodyPr>
-            <a:lstStyle/>
-            <a:p>
-              <a:pPr marL="0" lvl="0" indent="0" algn="l" rtl="0">
-                <a:spcBef>
-                  <a:spcPts val="0"/>
-                </a:spcBef>
-                <a:spcAft>
-                  <a:spcPts val="0"/>
-                </a:spcAft>
-                <a:buNone/>
-              </a:pPr>
-              <a:endParaRPr/>
-            </a:p>
-          </p:txBody>
-        </p:sp>
-      </p:grpSp>
-      <p:sp>
-        <p:nvSpPr>
-          <p:cNvPr id="28" name="Text"/>
-          <p:cNvSpPr txBox="1"/>
-          <p:nvPr/>
-        </p:nvSpPr>
-        <p:spPr>
-          <a:xfrm>
-            <a:off x="6248400" y="2686050"/>
-            <a:ext cx="2409825" cy="466725"/>
-          </a:xfrm>
-          <a:prstGeom prst="rect">
-            <a:avLst/>
-          </a:prstGeom>
-          <a:noFill/>
-          <a:ln w="9525">
-            <a:noFill/>
-          </a:ln>
-        </p:spPr>
-        <p:txBody>
-          <a:bodyPr wrap="none" lIns="0" tIns="0" rIns="0" bIns="0" anchor="t">
-            <a:noAutofit/>
-          </a:bodyPr>
-          <a:lstStyle/>
-          <a:p>
-            <a:pPr marL="0" indent="0" algn="ctr">
-              <a:lnSpc>
-                <a:spcPts val="2906"/>
-              </a:lnSpc>
-              <a:spcAft>
-                <a:spcPts val="0"/>
-              </a:spcAft>
-              <a:buNone/>
-            </a:pPr>
-            <a:r>
-              <a:rPr lang="en-US" sz="2325" b="1">
-                <a:solidFill>
-                  <a:srgbClr val="435D74"/>
-                </a:solidFill>
-                <a:latin typeface="Fira Sans Extra Condensed"/>
-                <a:ea typeface="Fira Sans Extra Condensed"/>
-                <a:cs typeface="Fira Sans Extra Condensed"/>
-              </a:rPr>
-              <a:t>Automatic action</a:t>
-            </a:r>
-            <a:endParaRPr lang="en-US" sz="2325"/>
-          </a:p>
-        </p:txBody>
-      </p:sp>
-      <p:sp>
-        <p:nvSpPr>
-          <p:cNvPr id="29" name="Text"/>
-          <p:cNvSpPr txBox="1"/>
-          <p:nvPr/>
-        </p:nvSpPr>
-        <p:spPr>
-          <a:xfrm>
-            <a:off x="6248400" y="3343275"/>
-            <a:ext cx="2409825" cy="685800"/>
-          </a:xfrm>
-          <a:prstGeom prst="rect">
-            <a:avLst/>
-          </a:prstGeom>
-          <a:noFill/>
-          <a:ln w="9525">
-            <a:noFill/>
-          </a:ln>
-        </p:spPr>
-        <p:txBody>
-          <a:bodyPr wrap="none" lIns="0" tIns="0" rIns="0" bIns="0" anchor="t">
-            <a:noAutofit/>
-          </a:bodyPr>
-          <a:lstStyle/>
-          <a:p>
-            <a:pPr marL="0" indent="0" algn="ctr">
-              <a:lnSpc>
-                <a:spcPts val="1781"/>
-              </a:lnSpc>
-              <a:spcAft>
-                <a:spcPts val="0"/>
-              </a:spcAft>
-              <a:buNone/>
-            </a:pPr>
-            <a:r>
-              <a:rPr lang="en-US" sz="1425" b="0">
-                <a:solidFill>
-                  <a:srgbClr val="435D74"/>
-                </a:solidFill>
-                <a:latin typeface="Roboto"/>
-                <a:ea typeface="Roboto"/>
-                <a:cs typeface="Roboto"/>
-              </a:rPr>
-              <a:t>System acts within agreed</a:t>
-            </a:r>
-            <a:endParaRPr lang="en-US" sz="1425"/>
-          </a:p>
-          <a:p>
-            <a:pPr marL="0" indent="0" algn="ctr">
-              <a:lnSpc>
-                <a:spcPts val="1781"/>
-              </a:lnSpc>
-              <a:spcAft>
-                <a:spcPts val="0"/>
-              </a:spcAft>
-              <a:buNone/>
-            </a:pPr>
-            <a:r>
-              <a:rPr lang="en-US" sz="1425" b="0">
-                <a:solidFill>
-                  <a:srgbClr val="435D74"/>
-                </a:solidFill>
-                <a:latin typeface="Roboto"/>
-                <a:ea typeface="Roboto"/>
-                <a:cs typeface="Roboto"/>
-              </a:rPr>
-              <a:t>rules</a:t>
-            </a:r>
-            <a:endParaRPr lang="en-US" sz="1425"/>
-          </a:p>
-          <a:p>
-            <a:pPr marL="0" indent="0" algn="ctr">
-              <a:lnSpc>
-                <a:spcPts val="1781"/>
-              </a:lnSpc>
-              <a:spcAft>
-                <a:spcPts val="0"/>
-              </a:spcAft>
-              <a:buNone/>
-            </a:pPr>
-            <a:r>
-              <a:rPr lang="en-US" sz="1425" b="0">
-                <a:solidFill>
-                  <a:srgbClr val="435D74"/>
-                </a:solidFill>
-                <a:latin typeface="Roboto"/>
-                <a:ea typeface="Roboto"/>
-                <a:cs typeface="Roboto"/>
-              </a:rPr>
-              <a:t>and records its actions.</a:t>
-            </a:r>
-            <a:endParaRPr lang="en-US" sz="1425"/>
-          </a:p>
-        </p:txBody>
-      </p:sp>
-      <p:sp>
-        <p:nvSpPr>
-          <p:cNvPr id="30" name="Panel"/>
-          <p:cNvSpPr/>
-          <p:nvPr/>
-        </p:nvSpPr>
-        <p:spPr>
-          <a:xfrm>
-            <a:off x="495300" y="4219575"/>
-            <a:ext cx="8153400" cy="400050"/>
-          </a:xfrm>
-          <a:prstGeom prst="roundRect">
-            <a:avLst>
-              <a:gd name="adj" fmla="val 10000"/>
-            </a:avLst>
-          </a:prstGeom>
-          <a:solidFill>
-            <a:srgbClr val="F3F6F8"/>
-          </a:solidFill>
-          <a:ln w="9525">
-            <a:noFill/>
-          </a:ln>
-        </p:spPr>
-        <p:txBody>
-          <a:bodyPr/>
-          <a:lstStyle/>
-          <a:p>
-            <a:endParaRPr lang="en-US"/>
-          </a:p>
-        </p:txBody>
-      </p:sp>
-      <p:sp>
-        <p:nvSpPr>
-          <p:cNvPr id="31" name="Text"/>
-          <p:cNvSpPr txBox="1"/>
-          <p:nvPr/>
-        </p:nvSpPr>
-        <p:spPr>
-          <a:xfrm>
-            <a:off x="666750" y="4295775"/>
-            <a:ext cx="7810500" cy="295275"/>
-          </a:xfrm>
-          <a:prstGeom prst="rect">
-            <a:avLst/>
-          </a:prstGeom>
-          <a:noFill/>
-          <a:ln w="9525">
-            <a:noFill/>
-          </a:ln>
-        </p:spPr>
-        <p:txBody>
-          <a:bodyPr wrap="none" lIns="0" tIns="0" rIns="0" bIns="0" anchor="t">
-            <a:noAutofit/>
-          </a:bodyPr>
-          <a:lstStyle/>
-          <a:p>
-            <a:pPr marL="0" indent="0" algn="l">
-              <a:lnSpc>
-                <a:spcPts val="1688"/>
-              </a:lnSpc>
-              <a:spcAft>
-                <a:spcPts val="0"/>
-              </a:spcAft>
-              <a:buNone/>
-            </a:pPr>
-            <a:r>
-              <a:rPr lang="en-US" sz="1350" b="0">
-                <a:solidFill>
-                  <a:srgbClr val="435D74"/>
-                </a:solidFill>
-                <a:latin typeface="Roboto"/>
-                <a:ea typeface="Roboto"/>
-                <a:cs typeface="Roboto"/>
-              </a:rPr>
-              <a:t>Choose the level carefully and provide a way to stop automatic actions.</a:t>
-            </a:r>
-            <a:endParaRPr lang="en-US" sz="1350"/>
-          </a:p>
-        </p:txBody>
-      </p:sp>
-    </p:spTree>
-  </p:cSld>
-  <p:clrMapOvr>
-    <a:masterClrMapping/>
-  </p:clrMapOvr>
-</p:sld>
-</file>
-
-<file path=ppt/slides/slide15.xml><?xml version="1.0" encoding="utf-8"?>
-<p:sld xmlns:a="http://schemas.openxmlformats.org/drawingml/2006/main" xmlns:r="http://schemas.openxmlformats.org/officeDocument/2006/relationships" xmlns:p="http://schemas.openxmlformats.org/presentationml/2006/main" showMasterSp="0">
-  <p:cSld name="Fairness in decision-making">
-    <p:bg>
-      <p:bgPr>
-        <a:solidFill>
-          <a:srgbClr val="FFFFFF"/>
-        </a:solidFill>
-        <a:effectLst/>
-      </p:bgPr>
-    </p:bg>
-    <p:spTree>
-      <p:nvGrpSpPr>
-        <p:cNvPr id="1" name="Root"/>
-        <p:cNvGrpSpPr/>
-        <p:nvPr/>
-      </p:nvGrpSpPr>
-      <p:grpSpPr>
-        <a:xfrm>
-          <a:off x="0" y="0"/>
-          <a:ext cx="0" cy="0"/>
-          <a:chOff x="0" y="0"/>
-          <a:chExt cx="0" cy="0"/>
-        </a:xfrm>
-      </p:grpSpPr>
-      <p:sp>
-        <p:nvSpPr>
-          <p:cNvPr id="2" name="Text"/>
-          <p:cNvSpPr txBox="1"/>
-          <p:nvPr/>
-        </p:nvSpPr>
-        <p:spPr>
-          <a:xfrm>
-            <a:off x="495300" y="361950"/>
-            <a:ext cx="8172450" cy="552450"/>
-          </a:xfrm>
-          <a:prstGeom prst="rect">
-            <a:avLst/>
-          </a:prstGeom>
-          <a:noFill/>
-          <a:ln w="9525">
-            <a:noFill/>
-          </a:ln>
-        </p:spPr>
-        <p:txBody>
-          <a:bodyPr wrap="none" lIns="0" tIns="0" rIns="0" bIns="0" anchor="t">
-            <a:noAutofit/>
-          </a:bodyPr>
-          <a:lstStyle/>
-          <a:p>
-            <a:pPr marL="0" indent="0" algn="l">
-              <a:lnSpc>
-                <a:spcPts val="3938"/>
-              </a:lnSpc>
-              <a:spcAft>
-                <a:spcPts val="0"/>
-              </a:spcAft>
-              <a:buNone/>
-            </a:pPr>
-            <a:r>
-              <a:rPr lang="en-US" sz="3150" b="1">
-                <a:solidFill>
-                  <a:srgbClr val="435D74"/>
-                </a:solidFill>
-                <a:latin typeface="Fira Sans Extra Condensed"/>
-                <a:ea typeface="Fira Sans Extra Condensed"/>
-                <a:cs typeface="Fira Sans Extra Condensed"/>
-              </a:rPr>
-              <a:t>Fairness in decision-making</a:t>
-            </a:r>
-            <a:endParaRPr lang="en-US" sz="3150"/>
-          </a:p>
-        </p:txBody>
-      </p:sp>
-      <p:cxnSp>
-        <p:nvCxnSpPr>
-          <p:cNvPr id="3" name="Connector"/>
-          <p:cNvCxnSpPr/>
-          <p:nvPr/>
-        </p:nvCxnSpPr>
-        <p:spPr>
-          <a:xfrm>
-            <a:off x="495300" y="4762500"/>
-            <a:ext cx="8153400" cy="95"/>
-          </a:xfrm>
-          <a:prstGeom prst="line">
-            <a:avLst/>
-          </a:prstGeom>
-          <a:ln w="6191">
-            <a:solidFill>
-              <a:srgbClr val="D8E2E8"/>
-            </a:solidFill>
-          </a:ln>
-        </p:spPr>
-      </p:cxnSp>
-      <p:sp>
-        <p:nvSpPr>
-          <p:cNvPr id="4" name="Text"/>
-          <p:cNvSpPr txBox="1"/>
-          <p:nvPr/>
-        </p:nvSpPr>
-        <p:spPr>
-          <a:xfrm>
-            <a:off x="495300" y="4867275"/>
-            <a:ext cx="2762250" cy="171450"/>
-          </a:xfrm>
-          <a:prstGeom prst="rect">
-            <a:avLst/>
-          </a:prstGeom>
-          <a:noFill/>
-          <a:ln w="9525">
-            <a:noFill/>
-          </a:ln>
-        </p:spPr>
-        <p:txBody>
-          <a:bodyPr wrap="none" lIns="0" tIns="0" rIns="0" bIns="0" anchor="t">
-            <a:noAutofit/>
-          </a:bodyPr>
-          <a:lstStyle/>
-          <a:p>
-            <a:pPr marL="0" indent="0" algn="l">
-              <a:lnSpc>
-                <a:spcPts val="1031"/>
-              </a:lnSpc>
-              <a:spcAft>
-                <a:spcPts val="0"/>
-              </a:spcAft>
-              <a:buNone/>
-            </a:pPr>
-            <a:r>
-              <a:rPr lang="en-US" sz="825" b="0">
-                <a:solidFill>
-                  <a:srgbClr val="6D8495"/>
-                </a:solidFill>
-                <a:latin typeface="Roboto"/>
-                <a:ea typeface="Roboto"/>
-                <a:cs typeface="Roboto"/>
-              </a:rPr>
-              <a:t>Prescriptive analytics</a:t>
-            </a:r>
-            <a:endParaRPr lang="en-US" sz="825"/>
-          </a:p>
-        </p:txBody>
-      </p:sp>
-      <p:sp>
-        <p:nvSpPr>
-          <p:cNvPr id="5" name="Text"/>
-          <p:cNvSpPr txBox="1"/>
-          <p:nvPr/>
-        </p:nvSpPr>
-        <p:spPr>
-          <a:xfrm>
-            <a:off x="5429250" y="4867275"/>
-            <a:ext cx="2381250" cy="171450"/>
-          </a:xfrm>
-          <a:prstGeom prst="rect">
-            <a:avLst/>
-          </a:prstGeom>
-          <a:noFill/>
-          <a:ln w="9525">
-            <a:noFill/>
-          </a:ln>
-        </p:spPr>
-        <p:txBody>
-          <a:bodyPr wrap="none" lIns="0" tIns="0" rIns="0" bIns="0" anchor="t">
-            <a:noAutofit/>
-          </a:bodyPr>
-          <a:lstStyle/>
-          <a:p>
-            <a:pPr marL="0" indent="0" algn="r">
-              <a:lnSpc>
-                <a:spcPts val="1031"/>
-              </a:lnSpc>
-              <a:spcAft>
-                <a:spcPts val="0"/>
-              </a:spcAft>
-              <a:buNone/>
-            </a:pPr>
-            <a:r>
-              <a:rPr lang="en-US" sz="825" b="0">
-                <a:solidFill>
-                  <a:srgbClr val="6D8495"/>
-                </a:solidFill>
-                <a:latin typeface="Roboto"/>
-                <a:ea typeface="Roboto"/>
-                <a:cs typeface="Roboto"/>
-              </a:rPr>
-              <a:t>Template artwork: Slidesgo</a:t>
-            </a:r>
-            <a:endParaRPr lang="en-US" sz="825"/>
-          </a:p>
-        </p:txBody>
-      </p:sp>
-      <p:sp>
-        <p:nvSpPr>
-          <p:cNvPr id="6" name="Text"/>
-          <p:cNvSpPr txBox="1"/>
-          <p:nvPr/>
-        </p:nvSpPr>
-        <p:spPr>
-          <a:xfrm>
-            <a:off x="8048625" y="4867275"/>
-            <a:ext cx="600075" cy="171450"/>
-          </a:xfrm>
-          <a:prstGeom prst="rect">
-            <a:avLst/>
-          </a:prstGeom>
-          <a:noFill/>
-          <a:ln w="9525">
-            <a:noFill/>
-          </a:ln>
-        </p:spPr>
-        <p:txBody>
-          <a:bodyPr wrap="none" lIns="0" tIns="0" rIns="0" bIns="0" anchor="t">
-            <a:noAutofit/>
-          </a:bodyPr>
-          <a:lstStyle/>
-          <a:p>
-            <a:pPr marL="0" indent="0" algn="r">
-              <a:lnSpc>
-                <a:spcPts val="1031"/>
-              </a:lnSpc>
-              <a:spcAft>
-                <a:spcPts val="0"/>
-              </a:spcAft>
-              <a:buNone/>
-            </a:pPr>
-            <a:r>
-              <a:rPr lang="en-US" sz="825" b="0" dirty="0">
-                <a:solidFill>
-                  <a:srgbClr val="6D8495"/>
-                </a:solidFill>
-                <a:latin typeface="Roboto"/>
-                <a:ea typeface="Roboto"/>
-                <a:cs typeface="Roboto"/>
-              </a:rPr>
-              <a:t>15 / 16</a:t>
-            </a:r>
-            <a:endParaRPr lang="en-US" sz="825" dirty="0"/>
-          </a:p>
-        </p:txBody>
-      </p:sp>
-      <p:sp>
-        <p:nvSpPr>
-          <p:cNvPr id="7" name="Text"/>
-          <p:cNvSpPr txBox="1"/>
-          <p:nvPr/>
-        </p:nvSpPr>
-        <p:spPr>
-          <a:xfrm>
-            <a:off x="495300" y="1143000"/>
-            <a:ext cx="4476750" cy="742950"/>
-          </a:xfrm>
-          <a:prstGeom prst="rect">
-            <a:avLst/>
-          </a:prstGeom>
-          <a:noFill/>
-          <a:ln w="9525">
-            <a:noFill/>
-          </a:ln>
-        </p:spPr>
-        <p:txBody>
-          <a:bodyPr wrap="none" lIns="0" tIns="0" rIns="0" bIns="0" anchor="t">
-            <a:noAutofit/>
-          </a:bodyPr>
-          <a:lstStyle/>
-          <a:p>
-            <a:pPr marL="0" indent="0" algn="l">
-              <a:lnSpc>
-                <a:spcPts val="2812"/>
-              </a:lnSpc>
-              <a:spcAft>
-                <a:spcPts val="0"/>
-              </a:spcAft>
-              <a:buNone/>
-            </a:pPr>
-            <a:r>
-              <a:rPr lang="en-US" sz="2250" b="1">
-                <a:solidFill>
-                  <a:srgbClr val="435D74"/>
-                </a:solidFill>
-                <a:latin typeface="Fira Sans Extra Condensed"/>
-                <a:ea typeface="Fira Sans Extra Condensed"/>
-                <a:cs typeface="Fira Sans Extra Condensed"/>
-              </a:rPr>
-              <a:t>A plan can meet a business goal</a:t>
-            </a:r>
-            <a:endParaRPr lang="en-US" sz="2250"/>
-          </a:p>
-          <a:p>
-            <a:pPr marL="0" indent="0" algn="l">
-              <a:lnSpc>
-                <a:spcPts val="2812"/>
-              </a:lnSpc>
-              <a:spcAft>
-                <a:spcPts val="0"/>
-              </a:spcAft>
-              <a:buNone/>
-            </a:pPr>
-            <a:r>
-              <a:rPr lang="en-US" sz="2250" b="1">
-                <a:solidFill>
-                  <a:srgbClr val="435D74"/>
-                </a:solidFill>
-                <a:latin typeface="Fira Sans Extra Condensed"/>
-                <a:ea typeface="Fira Sans Extra Condensed"/>
-                <a:cs typeface="Fira Sans Extra Condensed"/>
-              </a:rPr>
-              <a:t>and still affect people unfairly.</a:t>
-            </a:r>
-            <a:endParaRPr lang="en-US" sz="2250"/>
-          </a:p>
-        </p:txBody>
-      </p:sp>
-      <p:sp>
-        <p:nvSpPr>
-          <p:cNvPr id="8" name="Text"/>
-          <p:cNvSpPr txBox="1"/>
-          <p:nvPr/>
-        </p:nvSpPr>
-        <p:spPr>
-          <a:xfrm>
-            <a:off x="495300" y="2266950"/>
-            <a:ext cx="4381500" cy="771525"/>
-          </a:xfrm>
-          <a:prstGeom prst="rect">
-            <a:avLst/>
-          </a:prstGeom>
-          <a:noFill/>
-          <a:ln w="9525">
-            <a:noFill/>
-          </a:ln>
-        </p:spPr>
-        <p:txBody>
-          <a:bodyPr wrap="none" lIns="0" tIns="0" rIns="0" bIns="0" anchor="t">
-            <a:noAutofit/>
-          </a:bodyPr>
-          <a:lstStyle/>
-          <a:p>
-            <a:pPr marL="0" indent="0" algn="l">
-              <a:lnSpc>
-                <a:spcPts val="2156"/>
-              </a:lnSpc>
-              <a:spcAft>
-                <a:spcPts val="0"/>
-              </a:spcAft>
-              <a:buNone/>
-            </a:pPr>
-            <a:r>
-              <a:rPr lang="en-US" sz="1725" b="0">
-                <a:solidFill>
-                  <a:srgbClr val="435D74"/>
-                </a:solidFill>
-                <a:latin typeface="Roboto"/>
-                <a:ea typeface="Roboto"/>
-                <a:cs typeface="Roboto"/>
-              </a:rPr>
-              <a:t>A work plan might give the same workers</a:t>
-            </a:r>
-            <a:endParaRPr lang="en-US" sz="1725"/>
-          </a:p>
-          <a:p>
-            <a:pPr marL="0" indent="0" algn="l">
-              <a:lnSpc>
-                <a:spcPts val="2156"/>
-              </a:lnSpc>
-              <a:spcAft>
-                <a:spcPts val="0"/>
-              </a:spcAft>
-              <a:buNone/>
-            </a:pPr>
-            <a:r>
-              <a:rPr lang="en-US" sz="1725" b="0">
-                <a:solidFill>
-                  <a:srgbClr val="435D74"/>
-                </a:solidFill>
-                <a:latin typeface="Roboto"/>
-                <a:ea typeface="Roboto"/>
-                <a:cs typeface="Roboto"/>
-              </a:rPr>
-              <a:t>the busiest hours every week.</a:t>
-            </a:r>
-            <a:endParaRPr lang="en-US" sz="1725"/>
-          </a:p>
-        </p:txBody>
-      </p:sp>
-      <p:sp>
-        <p:nvSpPr>
-          <p:cNvPr id="9" name="Text"/>
-          <p:cNvSpPr txBox="1"/>
-          <p:nvPr/>
-        </p:nvSpPr>
-        <p:spPr>
-          <a:xfrm>
-            <a:off x="495300" y="3476625"/>
-            <a:ext cx="4448175" cy="581025"/>
-          </a:xfrm>
-          <a:prstGeom prst="rect">
-            <a:avLst/>
-          </a:prstGeom>
-          <a:noFill/>
-          <a:ln w="9525">
-            <a:noFill/>
-          </a:ln>
-        </p:spPr>
-        <p:txBody>
-          <a:bodyPr wrap="none" lIns="0" tIns="0" rIns="0" bIns="0" anchor="t">
-            <a:noAutofit/>
-          </a:bodyPr>
-          <a:lstStyle/>
-          <a:p>
-            <a:pPr marL="0" indent="0" algn="l">
-              <a:lnSpc>
-                <a:spcPts val="2344"/>
-              </a:lnSpc>
-              <a:spcAft>
-                <a:spcPts val="0"/>
-              </a:spcAft>
-              <a:buNone/>
-            </a:pPr>
-            <a:r>
-              <a:rPr lang="en-US" sz="1875" b="1">
-                <a:solidFill>
-                  <a:srgbClr val="007D8B"/>
-                </a:solidFill>
-                <a:latin typeface="Fira Sans Extra Condensed"/>
-                <a:ea typeface="Fira Sans Extra Condensed"/>
-                <a:cs typeface="Fira Sans Extra Condensed"/>
-              </a:rPr>
-              <a:t>Include fairness in the goals or rules.</a:t>
-            </a:r>
-            <a:endParaRPr lang="en-US" sz="1875"/>
-          </a:p>
-        </p:txBody>
-      </p:sp>
-      <p:sp>
-        <p:nvSpPr>
-          <p:cNvPr id="10" name="Panel"/>
-          <p:cNvSpPr/>
-          <p:nvPr/>
-        </p:nvSpPr>
-        <p:spPr>
-          <a:xfrm>
-            <a:off x="5400675" y="1123950"/>
-            <a:ext cx="3248025" cy="3019425"/>
-          </a:xfrm>
-          <a:prstGeom prst="roundRect">
-            <a:avLst>
-              <a:gd name="adj" fmla="val 10000"/>
-            </a:avLst>
-          </a:prstGeom>
-          <a:solidFill>
-            <a:srgbClr val="F3F6F8"/>
-          </a:solidFill>
-          <a:ln w="9525">
-            <a:noFill/>
-          </a:ln>
-        </p:spPr>
-        <p:txBody>
-          <a:bodyPr/>
-          <a:lstStyle/>
-          <a:p>
-            <a:endParaRPr lang="en-US"/>
-          </a:p>
-        </p:txBody>
-      </p:sp>
-      <p:grpSp>
-        <p:nvGrpSpPr>
-          <p:cNvPr id="11" name="Slidesgo vector icon"/>
-          <p:cNvGrpSpPr/>
-          <p:nvPr/>
-        </p:nvGrpSpPr>
-        <p:grpSpPr>
-          <a:xfrm>
-            <a:off x="6619875" y="1304925"/>
-            <a:ext cx="552450" cy="549482"/>
-            <a:chOff x="-5635200" y="2037975"/>
-            <a:chExt cx="293025" cy="291450"/>
-          </a:xfrm>
-        </p:grpSpPr>
-        <p:sp>
-          <p:nvSpPr>
-            <p:cNvPr id="12" name="Slidesgo vector icon"/>
-            <p:cNvSpPr/>
-            <p:nvPr/>
-          </p:nvSpPr>
-          <p:spPr>
-            <a:xfrm>
-              <a:off x="-5635200" y="2037975"/>
-              <a:ext cx="293025" cy="291450"/>
-            </a:xfrm>
-            <a:custGeom>
-              <a:avLst/>
-              <a:gdLst/>
-              <a:ahLst/>
-              <a:cxnLst/>
-              <a:rect l="l" t="t" r="r" b="b"/>
-              <a:pathLst>
-                <a:path w="11721" h="11658" extrusionOk="0">
-                  <a:moveTo>
-                    <a:pt x="2395" y="725"/>
-                  </a:moveTo>
-                  <a:cubicBezTo>
-                    <a:pt x="2930" y="725"/>
-                    <a:pt x="3403" y="1197"/>
-                    <a:pt x="3403" y="1733"/>
-                  </a:cubicBezTo>
-                  <a:cubicBezTo>
-                    <a:pt x="3403" y="2300"/>
-                    <a:pt x="2930" y="2773"/>
-                    <a:pt x="2395" y="2773"/>
-                  </a:cubicBezTo>
-                  <a:cubicBezTo>
-                    <a:pt x="1828" y="2773"/>
-                    <a:pt x="1355" y="2300"/>
-                    <a:pt x="1355" y="1733"/>
-                  </a:cubicBezTo>
-                  <a:cubicBezTo>
-                    <a:pt x="1355" y="1197"/>
-                    <a:pt x="1828" y="725"/>
-                    <a:pt x="2395" y="725"/>
-                  </a:cubicBezTo>
-                  <a:close/>
-                  <a:moveTo>
-                    <a:pt x="10303" y="725"/>
-                  </a:moveTo>
-                  <a:lnTo>
-                    <a:pt x="10303" y="6585"/>
-                  </a:lnTo>
-                  <a:lnTo>
-                    <a:pt x="10334" y="6585"/>
-                  </a:lnTo>
-                  <a:cubicBezTo>
-                    <a:pt x="10334" y="6774"/>
-                    <a:pt x="10177" y="6931"/>
-                    <a:pt x="9988" y="6931"/>
-                  </a:cubicBezTo>
-                  <a:lnTo>
-                    <a:pt x="4789" y="6931"/>
-                  </a:lnTo>
-                  <a:lnTo>
-                    <a:pt x="4789" y="5167"/>
-                  </a:lnTo>
-                  <a:cubicBezTo>
-                    <a:pt x="4789" y="4253"/>
-                    <a:pt x="4285" y="3434"/>
-                    <a:pt x="3498" y="3025"/>
-                  </a:cubicBezTo>
-                  <a:cubicBezTo>
-                    <a:pt x="3844" y="2710"/>
-                    <a:pt x="4096" y="2237"/>
-                    <a:pt x="4096" y="1733"/>
-                  </a:cubicBezTo>
-                  <a:cubicBezTo>
-                    <a:pt x="4096" y="1355"/>
-                    <a:pt x="3970" y="977"/>
-                    <a:pt x="3718" y="725"/>
-                  </a:cubicBezTo>
-                  <a:close/>
-                  <a:moveTo>
-                    <a:pt x="2710" y="3466"/>
-                  </a:moveTo>
-                  <a:cubicBezTo>
-                    <a:pt x="3498" y="3623"/>
-                    <a:pt x="4096" y="4316"/>
-                    <a:pt x="4096" y="5167"/>
-                  </a:cubicBezTo>
-                  <a:lnTo>
-                    <a:pt x="4096" y="7246"/>
-                  </a:lnTo>
-                  <a:cubicBezTo>
-                    <a:pt x="4128" y="7435"/>
-                    <a:pt x="3970" y="7593"/>
-                    <a:pt x="3750" y="7593"/>
-                  </a:cubicBezTo>
-                  <a:cubicBezTo>
-                    <a:pt x="3561" y="7593"/>
-                    <a:pt x="3403" y="7750"/>
-                    <a:pt x="3403" y="7971"/>
-                  </a:cubicBezTo>
-                  <a:lnTo>
-                    <a:pt x="3403" y="10712"/>
-                  </a:lnTo>
-                  <a:cubicBezTo>
-                    <a:pt x="3403" y="10901"/>
-                    <a:pt x="3246" y="11058"/>
-                    <a:pt x="3056" y="11058"/>
-                  </a:cubicBezTo>
-                  <a:lnTo>
-                    <a:pt x="1670" y="11058"/>
-                  </a:lnTo>
-                  <a:cubicBezTo>
-                    <a:pt x="1481" y="11058"/>
-                    <a:pt x="1324" y="10901"/>
-                    <a:pt x="1324" y="10712"/>
-                  </a:cubicBezTo>
-                  <a:lnTo>
-                    <a:pt x="1324" y="7971"/>
-                  </a:lnTo>
-                  <a:cubicBezTo>
-                    <a:pt x="1324" y="7750"/>
-                    <a:pt x="1166" y="7593"/>
-                    <a:pt x="977" y="7593"/>
-                  </a:cubicBezTo>
-                  <a:cubicBezTo>
-                    <a:pt x="788" y="7593"/>
-                    <a:pt x="631" y="7435"/>
-                    <a:pt x="631" y="7246"/>
-                  </a:cubicBezTo>
-                  <a:lnTo>
-                    <a:pt x="631" y="5167"/>
-                  </a:lnTo>
-                  <a:cubicBezTo>
-                    <a:pt x="631" y="4316"/>
-                    <a:pt x="1198" y="3623"/>
-                    <a:pt x="1985" y="3466"/>
-                  </a:cubicBezTo>
-                  <a:lnTo>
-                    <a:pt x="1985" y="5829"/>
-                  </a:lnTo>
-                  <a:cubicBezTo>
-                    <a:pt x="1985" y="6018"/>
-                    <a:pt x="2143" y="6175"/>
-                    <a:pt x="2363" y="6175"/>
-                  </a:cubicBezTo>
-                  <a:cubicBezTo>
-                    <a:pt x="2552" y="6175"/>
-                    <a:pt x="2710" y="6018"/>
-                    <a:pt x="2710" y="5829"/>
-                  </a:cubicBezTo>
-                  <a:lnTo>
-                    <a:pt x="2710" y="3466"/>
-                  </a:lnTo>
-                  <a:close/>
-                  <a:moveTo>
-                    <a:pt x="2395" y="0"/>
-                  </a:moveTo>
-                  <a:cubicBezTo>
-                    <a:pt x="1450" y="0"/>
-                    <a:pt x="694" y="756"/>
-                    <a:pt x="694" y="1702"/>
-                  </a:cubicBezTo>
-                  <a:cubicBezTo>
-                    <a:pt x="694" y="2206"/>
-                    <a:pt x="946" y="2678"/>
-                    <a:pt x="1292" y="2993"/>
-                  </a:cubicBezTo>
-                  <a:cubicBezTo>
-                    <a:pt x="536" y="3403"/>
-                    <a:pt x="1" y="4222"/>
-                    <a:pt x="1" y="5136"/>
-                  </a:cubicBezTo>
-                  <a:lnTo>
-                    <a:pt x="1" y="7215"/>
-                  </a:lnTo>
-                  <a:cubicBezTo>
-                    <a:pt x="1" y="7656"/>
-                    <a:pt x="253" y="8034"/>
-                    <a:pt x="662" y="8192"/>
-                  </a:cubicBezTo>
-                  <a:lnTo>
-                    <a:pt x="662" y="10649"/>
-                  </a:lnTo>
-                  <a:cubicBezTo>
-                    <a:pt x="662" y="11184"/>
-                    <a:pt x="1135" y="11657"/>
-                    <a:pt x="1670" y="11657"/>
-                  </a:cubicBezTo>
-                  <a:lnTo>
-                    <a:pt x="3056" y="11657"/>
-                  </a:lnTo>
-                  <a:cubicBezTo>
-                    <a:pt x="3624" y="11657"/>
-                    <a:pt x="4096" y="11184"/>
-                    <a:pt x="4096" y="10649"/>
-                  </a:cubicBezTo>
-                  <a:lnTo>
-                    <a:pt x="4096" y="8192"/>
-                  </a:lnTo>
-                  <a:cubicBezTo>
-                    <a:pt x="4348" y="8065"/>
-                    <a:pt x="4600" y="7876"/>
-                    <a:pt x="4726" y="7561"/>
-                  </a:cubicBezTo>
-                  <a:lnTo>
-                    <a:pt x="9988" y="7561"/>
-                  </a:lnTo>
-                  <a:cubicBezTo>
-                    <a:pt x="10555" y="7561"/>
-                    <a:pt x="11027" y="7089"/>
-                    <a:pt x="11027" y="6553"/>
-                  </a:cubicBezTo>
-                  <a:lnTo>
-                    <a:pt x="11027" y="662"/>
-                  </a:lnTo>
-                  <a:lnTo>
-                    <a:pt x="11374" y="662"/>
-                  </a:lnTo>
-                  <a:cubicBezTo>
-                    <a:pt x="11563" y="662"/>
-                    <a:pt x="11720" y="504"/>
-                    <a:pt x="11720" y="315"/>
-                  </a:cubicBezTo>
-                  <a:cubicBezTo>
-                    <a:pt x="11720" y="158"/>
-                    <a:pt x="11563" y="0"/>
-                    <a:pt x="11374" y="0"/>
-                  </a:cubicBezTo>
-                  <a:close/>
-                </a:path>
-              </a:pathLst>
-            </a:custGeom>
-            <a:solidFill>
-              <a:srgbClr val="007D8B"/>
-            </a:solidFill>
-            <a:ln>
-              <a:noFill/>
-            </a:ln>
-          </p:spPr>
-          <p:txBody>
-            <a:bodyPr spcFirstLastPara="1" wrap="square" lIns="91425" tIns="91425" rIns="91425" bIns="91425" anchor="ctr" anchorCtr="0">
-              <a:noAutofit/>
-            </a:bodyPr>
-            <a:lstStyle/>
-            <a:p>
-              <a:pPr marL="0" lvl="0" indent="0" algn="l" rtl="0">
-                <a:spcBef>
-                  <a:spcPts val="0"/>
-                </a:spcBef>
-                <a:spcAft>
-                  <a:spcPts val="0"/>
-                </a:spcAft>
-                <a:buNone/>
-              </a:pPr>
-              <a:endParaRPr/>
-            </a:p>
-          </p:txBody>
-        </p:sp>
-        <p:sp>
-          <p:nvSpPr>
-            <p:cNvPr id="13" name="Slidesgo vector icon"/>
-            <p:cNvSpPr/>
-            <p:nvPr/>
-          </p:nvSpPr>
-          <p:spPr>
-            <a:xfrm>
-              <a:off x="-5496575" y="2072625"/>
-              <a:ext cx="102425" cy="102425"/>
-            </a:xfrm>
-            <a:custGeom>
-              <a:avLst/>
-              <a:gdLst/>
-              <a:ahLst/>
-              <a:cxnLst/>
-              <a:rect l="l" t="t" r="r" b="b"/>
-              <a:pathLst>
-                <a:path w="4097" h="4097" extrusionOk="0">
-                  <a:moveTo>
-                    <a:pt x="2395" y="725"/>
-                  </a:moveTo>
-                  <a:cubicBezTo>
-                    <a:pt x="2867" y="851"/>
-                    <a:pt x="3245" y="1229"/>
-                    <a:pt x="3371" y="1733"/>
-                  </a:cubicBezTo>
-                  <a:lnTo>
-                    <a:pt x="2395" y="1733"/>
-                  </a:lnTo>
-                  <a:lnTo>
-                    <a:pt x="2395" y="725"/>
-                  </a:lnTo>
-                  <a:close/>
-                  <a:moveTo>
-                    <a:pt x="1733" y="757"/>
-                  </a:moveTo>
-                  <a:lnTo>
-                    <a:pt x="1733" y="2080"/>
-                  </a:lnTo>
-                  <a:cubicBezTo>
-                    <a:pt x="1733" y="2269"/>
-                    <a:pt x="1891" y="2426"/>
-                    <a:pt x="2080" y="2426"/>
-                  </a:cubicBezTo>
-                  <a:lnTo>
-                    <a:pt x="3403" y="2426"/>
-                  </a:lnTo>
-                  <a:cubicBezTo>
-                    <a:pt x="3245" y="3025"/>
-                    <a:pt x="2741" y="3466"/>
-                    <a:pt x="2080" y="3466"/>
-                  </a:cubicBezTo>
-                  <a:cubicBezTo>
-                    <a:pt x="1324" y="3466"/>
-                    <a:pt x="693" y="2836"/>
-                    <a:pt x="693" y="2080"/>
-                  </a:cubicBezTo>
-                  <a:cubicBezTo>
-                    <a:pt x="693" y="1418"/>
-                    <a:pt x="1135" y="851"/>
-                    <a:pt x="1733" y="757"/>
-                  </a:cubicBezTo>
-                  <a:close/>
-                  <a:moveTo>
-                    <a:pt x="2048" y="0"/>
-                  </a:moveTo>
-                  <a:cubicBezTo>
-                    <a:pt x="883" y="0"/>
-                    <a:pt x="0" y="914"/>
-                    <a:pt x="0" y="2048"/>
-                  </a:cubicBezTo>
-                  <a:cubicBezTo>
-                    <a:pt x="0" y="3182"/>
-                    <a:pt x="946" y="4096"/>
-                    <a:pt x="2048" y="4096"/>
-                  </a:cubicBezTo>
-                  <a:cubicBezTo>
-                    <a:pt x="3182" y="4096"/>
-                    <a:pt x="4096" y="3182"/>
-                    <a:pt x="4096" y="2048"/>
-                  </a:cubicBezTo>
-                  <a:cubicBezTo>
-                    <a:pt x="4096" y="914"/>
-                    <a:pt x="3182" y="0"/>
-                    <a:pt x="2048" y="0"/>
-                  </a:cubicBezTo>
-                  <a:close/>
-                </a:path>
-              </a:pathLst>
-            </a:custGeom>
-            <a:solidFill>
-              <a:srgbClr val="007D8B"/>
-            </a:solidFill>
-            <a:ln>
-              <a:noFill/>
-            </a:ln>
-          </p:spPr>
-          <p:txBody>
-            <a:bodyPr spcFirstLastPara="1" wrap="square" lIns="91425" tIns="91425" rIns="91425" bIns="91425" anchor="ctr" anchorCtr="0">
-              <a:noAutofit/>
-            </a:bodyPr>
-            <a:lstStyle/>
-            <a:p>
-              <a:pPr marL="0" lvl="0" indent="0" algn="l" rtl="0">
-                <a:spcBef>
-                  <a:spcPts val="0"/>
-                </a:spcBef>
-                <a:spcAft>
-                  <a:spcPts val="0"/>
-                </a:spcAft>
-                <a:buNone/>
-              </a:pPr>
-              <a:endParaRPr/>
-            </a:p>
-          </p:txBody>
-        </p:sp>
-      </p:grpSp>
-      <p:sp>
-        <p:nvSpPr>
-          <p:cNvPr id="14" name="Circle"/>
-          <p:cNvSpPr/>
-          <p:nvPr/>
-        </p:nvSpPr>
-        <p:spPr>
-          <a:xfrm>
-            <a:off x="5629275" y="2257425"/>
-            <a:ext cx="161925" cy="161925"/>
-          </a:xfrm>
-          <a:prstGeom prst="ellipse">
-            <a:avLst/>
-          </a:prstGeom>
-          <a:solidFill>
-            <a:srgbClr val="5FD0DB"/>
-          </a:solidFill>
-          <a:ln w="9525">
-            <a:noFill/>
-          </a:ln>
-        </p:spPr>
-        <p:txBody>
-          <a:bodyPr/>
-          <a:lstStyle/>
-          <a:p>
-            <a:endParaRPr lang="en-US"/>
-          </a:p>
-        </p:txBody>
-      </p:sp>
-      <p:sp>
-        <p:nvSpPr>
-          <p:cNvPr id="15" name="Text"/>
-          <p:cNvSpPr txBox="1"/>
-          <p:nvPr/>
-        </p:nvSpPr>
-        <p:spPr>
-          <a:xfrm>
-            <a:off x="5943600" y="2209800"/>
-            <a:ext cx="2495550" cy="638175"/>
-          </a:xfrm>
-          <a:prstGeom prst="rect">
-            <a:avLst/>
-          </a:prstGeom>
-          <a:noFill/>
-          <a:ln w="9525">
-            <a:noFill/>
-          </a:ln>
-        </p:spPr>
-        <p:txBody>
-          <a:bodyPr wrap="none" lIns="0" tIns="0" rIns="0" bIns="0" anchor="t">
-            <a:noAutofit/>
-          </a:bodyPr>
-          <a:lstStyle/>
-          <a:p>
-            <a:pPr marL="0" indent="0" algn="l">
-              <a:lnSpc>
-                <a:spcPts val="2062"/>
-              </a:lnSpc>
-              <a:spcAft>
-                <a:spcPts val="0"/>
-              </a:spcAft>
-              <a:buNone/>
-            </a:pPr>
-            <a:r>
-              <a:rPr lang="en-US" sz="1650" b="0">
-                <a:solidFill>
-                  <a:srgbClr val="435D74"/>
-                </a:solidFill>
-                <a:latin typeface="Roboto"/>
-                <a:ea typeface="Roboto"/>
-                <a:cs typeface="Roboto"/>
-              </a:rPr>
-              <a:t>Breaks</a:t>
-            </a:r>
-            <a:endParaRPr lang="en-US" sz="1650"/>
-          </a:p>
-        </p:txBody>
-      </p:sp>
-      <p:sp>
-        <p:nvSpPr>
-          <p:cNvPr id="16" name="Circle"/>
-          <p:cNvSpPr/>
-          <p:nvPr/>
-        </p:nvSpPr>
-        <p:spPr>
-          <a:xfrm>
-            <a:off x="5629275" y="2819400"/>
-            <a:ext cx="161925" cy="161925"/>
-          </a:xfrm>
-          <a:prstGeom prst="ellipse">
-            <a:avLst/>
-          </a:prstGeom>
-          <a:solidFill>
-            <a:srgbClr val="5FD0DB"/>
-          </a:solidFill>
-          <a:ln w="9525">
-            <a:noFill/>
-          </a:ln>
-        </p:spPr>
-        <p:txBody>
-          <a:bodyPr/>
-          <a:lstStyle/>
-          <a:p>
-            <a:endParaRPr lang="en-US"/>
-          </a:p>
-        </p:txBody>
-      </p:sp>
-      <p:sp>
-        <p:nvSpPr>
-          <p:cNvPr id="17" name="Text"/>
-          <p:cNvSpPr txBox="1"/>
-          <p:nvPr/>
-        </p:nvSpPr>
-        <p:spPr>
-          <a:xfrm>
-            <a:off x="5943600" y="2771775"/>
-            <a:ext cx="2495550" cy="638175"/>
-          </a:xfrm>
-          <a:prstGeom prst="rect">
-            <a:avLst/>
-          </a:prstGeom>
-          <a:noFill/>
-          <a:ln w="9525">
-            <a:noFill/>
-          </a:ln>
-        </p:spPr>
-        <p:txBody>
-          <a:bodyPr wrap="none" lIns="0" tIns="0" rIns="0" bIns="0" anchor="t">
-            <a:noAutofit/>
-          </a:bodyPr>
-          <a:lstStyle/>
-          <a:p>
-            <a:pPr marL="0" indent="0" algn="l">
-              <a:lnSpc>
-                <a:spcPts val="2062"/>
-              </a:lnSpc>
-              <a:spcAft>
-                <a:spcPts val="0"/>
-              </a:spcAft>
-              <a:buNone/>
-            </a:pPr>
-            <a:r>
-              <a:rPr lang="en-US" sz="1650" b="0">
-                <a:solidFill>
-                  <a:srgbClr val="435D74"/>
-                </a:solidFill>
-                <a:latin typeface="Roboto"/>
-                <a:ea typeface="Roboto"/>
-                <a:cs typeface="Roboto"/>
-              </a:rPr>
-              <a:t>Reasonable working hours</a:t>
-            </a:r>
-            <a:endParaRPr lang="en-US" sz="1650"/>
-          </a:p>
-        </p:txBody>
-      </p:sp>
-      <p:sp>
-        <p:nvSpPr>
-          <p:cNvPr id="18" name="Circle"/>
-          <p:cNvSpPr/>
-          <p:nvPr/>
-        </p:nvSpPr>
-        <p:spPr>
-          <a:xfrm>
-            <a:off x="5629275" y="3381375"/>
-            <a:ext cx="161925" cy="161925"/>
-          </a:xfrm>
-          <a:prstGeom prst="ellipse">
-            <a:avLst/>
-          </a:prstGeom>
-          <a:solidFill>
-            <a:srgbClr val="5FD0DB"/>
-          </a:solidFill>
-          <a:ln w="9525">
-            <a:noFill/>
-          </a:ln>
-        </p:spPr>
-        <p:txBody>
-          <a:bodyPr/>
-          <a:lstStyle/>
-          <a:p>
-            <a:endParaRPr lang="en-US"/>
-          </a:p>
-        </p:txBody>
-      </p:sp>
-      <p:sp>
-        <p:nvSpPr>
-          <p:cNvPr id="19" name="Text"/>
-          <p:cNvSpPr txBox="1"/>
-          <p:nvPr/>
-        </p:nvSpPr>
-        <p:spPr>
-          <a:xfrm>
-            <a:off x="5943600" y="3333750"/>
-            <a:ext cx="2495550" cy="638175"/>
-          </a:xfrm>
-          <a:prstGeom prst="rect">
-            <a:avLst/>
-          </a:prstGeom>
-          <a:noFill/>
-          <a:ln w="9525">
-            <a:noFill/>
-          </a:ln>
-        </p:spPr>
-        <p:txBody>
-          <a:bodyPr wrap="none" lIns="0" tIns="0" rIns="0" bIns="0" anchor="t">
-            <a:noAutofit/>
-          </a:bodyPr>
-          <a:lstStyle/>
-          <a:p>
-            <a:pPr marL="0" indent="0" algn="l">
-              <a:lnSpc>
-                <a:spcPts val="2062"/>
-              </a:lnSpc>
-              <a:spcAft>
-                <a:spcPts val="0"/>
-              </a:spcAft>
-              <a:buNone/>
-            </a:pPr>
-            <a:r>
-              <a:rPr lang="en-US" sz="1650" b="0">
-                <a:solidFill>
-                  <a:srgbClr val="435D74"/>
-                </a:solidFill>
-                <a:latin typeface="Roboto"/>
-                <a:ea typeface="Roboto"/>
-                <a:cs typeface="Roboto"/>
-              </a:rPr>
-              <a:t>Sharing difficult tasks</a:t>
-            </a:r>
-            <a:endParaRPr lang="en-US" sz="1650"/>
-          </a:p>
-          <a:p>
-            <a:pPr marL="0" indent="0" algn="l">
-              <a:lnSpc>
-                <a:spcPts val="2062"/>
-              </a:lnSpc>
-              <a:spcAft>
-                <a:spcPts val="0"/>
-              </a:spcAft>
-              <a:buNone/>
-            </a:pPr>
-            <a:r>
-              <a:rPr lang="en-US" sz="1650" b="0">
-                <a:solidFill>
-                  <a:srgbClr val="435D74"/>
-                </a:solidFill>
-                <a:latin typeface="Roboto"/>
-                <a:ea typeface="Roboto"/>
-                <a:cs typeface="Roboto"/>
-              </a:rPr>
-              <a:t>fairly</a:t>
-            </a:r>
-            <a:endParaRPr lang="en-US" sz="1650"/>
-          </a:p>
-        </p:txBody>
-      </p:sp>
-      <p:sp>
-        <p:nvSpPr>
-          <p:cNvPr id="21" name="Text"/>
-          <p:cNvSpPr txBox="1"/>
-          <p:nvPr/>
-        </p:nvSpPr>
-        <p:spPr>
-          <a:xfrm>
-            <a:off x="5095875" y="4371975"/>
-            <a:ext cx="3552825" cy="257175"/>
-          </a:xfrm>
-          <a:prstGeom prst="rect">
-            <a:avLst/>
-          </a:prstGeom>
-          <a:noFill/>
-          <a:ln w="9525">
-            <a:noFill/>
-          </a:ln>
-        </p:spPr>
-        <p:txBody>
-          <a:bodyPr wrap="none" lIns="0" tIns="0" rIns="0" bIns="0" anchor="t">
-            <a:noAutofit/>
-          </a:bodyPr>
-          <a:lstStyle/>
-          <a:p>
-            <a:pPr marL="0" indent="0" algn="r">
-              <a:lnSpc>
-                <a:spcPts val="1312"/>
-              </a:lnSpc>
-              <a:spcAft>
-                <a:spcPts val="0"/>
-              </a:spcAft>
-              <a:buNone/>
-            </a:pPr>
-            <a:r>
-              <a:rPr lang="en-US" sz="1050" b="0">
-                <a:solidFill>
-                  <a:srgbClr val="6D8495"/>
-                </a:solidFill>
-                <a:latin typeface="Roboto"/>
-                <a:ea typeface="Roboto"/>
-                <a:cs typeface="Roboto"/>
-              </a:rPr>
-              <a:t>Design and vector artwork by Slidesgo</a:t>
-            </a:r>
-            <a:endParaRPr lang="en-US" sz="1050"/>
-          </a:p>
-        </p:txBody>
-      </p:sp>
-    </p:spTree>
-  </p:cSld>
-  <p:clrMapOvr>
-    <a:masterClrMapping/>
-  </p:clrMapOvr>
-</p:sld>
-</file>
-
-<file path=ppt/slides/slide16.xml><?xml version="1.0" encoding="utf-8"?>
 <p:sld xmlns:a="http://schemas.openxmlformats.org/drawingml/2006/main" xmlns:r="http://schemas.openxmlformats.org/officeDocument/2006/relationships" xmlns:p="http://schemas.openxmlformats.org/presentationml/2006/main">
   <p:cSld>
     <p:spTree>

</xml_diff>

<commit_message>
Update prescriptive analytics presentation: Replace existing file with revised version
</commit_message>
<xml_diff>
--- a/prescriptive-analytics/prescriptive-analytics-presentation-designed.pptx
+++ b/prescriptive-analytics/prescriptive-analytics-presentation-designed.pptx
@@ -8968,7 +8968,7 @@
                 <a:ea typeface="Roboto"/>
                 <a:cs typeface="Roboto"/>
               </a:rPr>
-              <a:t>01 / 16</a:t>
+              <a:t>01 / 14</a:t>
             </a:r>
             <a:endParaRPr lang="en-US" sz="825"/>
           </a:p>
@@ -12607,7 +12607,7 @@
                 <a:ea typeface="Roboto"/>
                 <a:cs typeface="Roboto"/>
               </a:rPr>
-              <a:t>10 / 16</a:t>
+              <a:t>10 / 14</a:t>
             </a:r>
             <a:endParaRPr lang="en-US" sz="825"/>
           </a:p>
@@ -15344,7 +15344,7 @@
                 <a:ea typeface="Roboto"/>
                 <a:cs typeface="Roboto"/>
               </a:rPr>
-              <a:t>11 /  16</a:t>
+              <a:t>11 /  14</a:t>
             </a:r>
             <a:endParaRPr lang="en-US" sz="825" dirty="0"/>
           </a:p>
@@ -18056,7 +18056,7 @@
                 <a:ea typeface="Roboto"/>
                 <a:cs typeface="Roboto"/>
               </a:rPr>
-              <a:t> 16</a:t>
+              <a:t> 14</a:t>
             </a:r>
             <a:endParaRPr lang="en-US" sz="825" dirty="0"/>
           </a:p>
@@ -20332,7 +20332,7 @@
                 <a:ea typeface="Roboto"/>
                 <a:cs typeface="Roboto"/>
               </a:rPr>
-              <a:t>/ 16</a:t>
+              <a:t>/ 14</a:t>
             </a:r>
             <a:endParaRPr lang="en-US" sz="825" dirty="0"/>
           </a:p>
@@ -22896,7 +22896,7 @@
                 <a:ea typeface="Roboto"/>
                 <a:cs typeface="Roboto"/>
               </a:rPr>
-              <a:t>16 / 16</a:t>
+              <a:t>14 / 14</a:t>
             </a:r>
             <a:endParaRPr lang="en-US" sz="825" dirty="0"/>
           </a:p>
@@ -23202,7 +23202,7 @@
                 <a:ea typeface="Roboto"/>
                 <a:cs typeface="Roboto"/>
               </a:rPr>
-              <a:t>/ 16</a:t>
+              <a:t>/ 14</a:t>
             </a:r>
             <a:endParaRPr lang="en-US" sz="825" dirty="0"/>
           </a:p>
@@ -26664,7 +26664,7 @@
                 <a:ea typeface="Roboto"/>
                 <a:cs typeface="Roboto"/>
               </a:rPr>
-              <a:t>03 / 16</a:t>
+              <a:t>03 / 14</a:t>
             </a:r>
             <a:endParaRPr lang="en-US" sz="825" dirty="0"/>
           </a:p>
@@ -29125,7 +29125,7 @@
                 <a:ea typeface="Roboto"/>
                 <a:cs typeface="Roboto"/>
               </a:rPr>
-              <a:t>/ 16</a:t>
+              <a:t>/ 14</a:t>
             </a:r>
             <a:endParaRPr lang="en-US" sz="825" dirty="0"/>
           </a:p>
@@ -30782,7 +30782,7 @@
                 <a:ea typeface="Roboto"/>
                 <a:cs typeface="Roboto"/>
               </a:rPr>
-              <a:t>/ 16</a:t>
+              <a:t>/ 14</a:t>
             </a:r>
             <a:endParaRPr lang="en-US" sz="825" dirty="0"/>
           </a:p>
@@ -33862,7 +33862,7 @@
                 <a:ea typeface="Roboto"/>
                 <a:cs typeface="Roboto"/>
               </a:rPr>
-              <a:t>/ 16</a:t>
+              <a:t>/ 14</a:t>
             </a:r>
             <a:endParaRPr lang="en-US" sz="825" dirty="0"/>
           </a:p>
@@ -37475,7 +37475,7 @@
                 <a:ea typeface="Roboto"/>
                 <a:cs typeface="Roboto"/>
               </a:rPr>
-              <a:t>07 / 16</a:t>
+              <a:t>07 / 14</a:t>
             </a:r>
             <a:endParaRPr lang="en-US" sz="825" dirty="0"/>
           </a:p>
@@ -39940,7 +39940,7 @@
                 <a:ea typeface="Roboto"/>
                 <a:cs typeface="Roboto"/>
               </a:rPr>
-              <a:t>/ 16</a:t>
+              <a:t>/ 14</a:t>
             </a:r>
             <a:endParaRPr lang="en-US" sz="825" dirty="0"/>
           </a:p>
@@ -42467,7 +42467,7 @@
                 <a:ea typeface="Roboto"/>
                 <a:cs typeface="Roboto"/>
               </a:rPr>
-              <a:t>/ 16</a:t>
+              <a:t>/ 14</a:t>
             </a:r>
             <a:endParaRPr lang="en-US" sz="825" dirty="0"/>
           </a:p>

</xml_diff>

<commit_message>
Update prescriptive analytics presentation: Replace existing presentation with revised version
</commit_message>
<xml_diff>
--- a/prescriptive-analytics/prescriptive-analytics-presentation-designed.pptx
+++ b/prescriptive-analytics/prescriptive-analytics-presentation-designed.pptx
@@ -20206,7 +20206,7 @@
                 <a:ea typeface="Fira Sans Extra Condensed"/>
                 <a:cs typeface="Fira Sans Extra Condensed"/>
               </a:rPr>
-              <a:t>How machine learning helps</a:t>
+              <a:t>Fairness in decision-making</a:t>
             </a:r>
             <a:endParaRPr lang="en-US" sz="3150"/>
           </a:p>
@@ -20412,7 +20412,7 @@
                 <a:ea typeface="Fira Sans Extra Condensed"/>
                 <a:cs typeface="Fira Sans Extra Condensed"/>
               </a:rPr>
-              <a:t>Machine learning estimates</a:t>
+              <a:t>Fairness concerns</a:t>
             </a:r>
             <a:endParaRPr lang="en-US" sz="2175"/>
           </a:p>
@@ -20492,7 +20492,7 @@
                 <a:ea typeface="Fira Sans Extra Condensed"/>
                 <a:cs typeface="Fira Sans Extra Condensed"/>
               </a:rPr>
-              <a:t>Prescriptive model suggests</a:t>
+              <a:t>Decision rules</a:t>
             </a:r>
             <a:endParaRPr lang="en-US" sz="2175"/>
           </a:p>
@@ -21271,7 +21271,7 @@
                 <a:ea typeface="Roboto"/>
                 <a:cs typeface="Roboto"/>
               </a:rPr>
-              <a:t>How much customers will buy</a:t>
+              <a:t>Same workers get busiest hours</a:t>
             </a:r>
             <a:endParaRPr lang="en-US" sz="1500"/>
           </a:p>
@@ -21342,7 +21342,7 @@
                 <a:ea typeface="Roboto"/>
                 <a:cs typeface="Roboto"/>
               </a:rPr>
-              <a:t>How much stock to order</a:t>
+              <a:t>Share difficult shifts fairly</a:t>
             </a:r>
             <a:endParaRPr lang="en-US" sz="1500"/>
           </a:p>
@@ -22054,7 +22054,7 @@
                 <a:ea typeface="Roboto"/>
                 <a:cs typeface="Roboto"/>
               </a:rPr>
-              <a:t>When a machine may fail</a:t>
+              <a:t>Breaks may be missed</a:t>
             </a:r>
             <a:endParaRPr lang="en-US" sz="1500"/>
           </a:p>
@@ -22125,7 +22125,7 @@
                 <a:ea typeface="Roboto"/>
                 <a:cs typeface="Roboto"/>
               </a:rPr>
-              <a:t>When to plan a repair</a:t>
+              <a:t>Set break and hour limits</a:t>
             </a:r>
             <a:endParaRPr lang="en-US" sz="1500"/>
           </a:p>
@@ -22577,7 +22577,7 @@
                 <a:ea typeface="Roboto"/>
                 <a:cs typeface="Roboto"/>
               </a:rPr>
-              <a:t>How many requests may arrive</a:t>
+              <a:t>People face different effects</a:t>
             </a:r>
             <a:endParaRPr lang="en-US" sz="1500"/>
           </a:p>
@@ -22648,7 +22648,7 @@
                 <a:ea typeface="Roboto"/>
                 <a:cs typeface="Roboto"/>
               </a:rPr>
-              <a:t>How many workers to assign</a:t>
+              <a:t>Add fairness goals to the model</a:t>
             </a:r>
             <a:endParaRPr lang="en-US" sz="1500"/>
           </a:p>
@@ -22728,7 +22728,7 @@
                 <a:ea typeface="Roboto"/>
                 <a:cs typeface="Roboto"/>
               </a:rPr>
-              <a:t>Predictions are inputs. Estimates can also come from people or other methods.</a:t>
+              <a:t>People should help define fair goals and rules.</a:t>
             </a:r>
             <a:endParaRPr lang="en-US" sz="1312"/>
           </a:p>

</xml_diff>

<commit_message>
Add new agenda and rendering scripts for prescriptive analytics presentation
</commit_message>
<xml_diff>
--- a/prescriptive-analytics/prescriptive-analytics-presentation-designed.pptx
+++ b/prescriptive-analytics/prescriptive-analytics-presentation-designed.pptx
@@ -1,6 +1,6 @@
 
 <file path=ppt/presentation.xml><?xml version="1.0" encoding="utf-8"?>
-<p:presentation xmlns:a="http://schemas.openxmlformats.org/drawingml/2006/main" xmlns:r="http://schemas.openxmlformats.org/officeDocument/2006/relationships" xmlns:p="http://schemas.openxmlformats.org/presentationml/2006/main" strictFirstAndLastChars="0" embedTrueTypeFonts="1" saveSubsetFonts="1" autoCompressPictures="0">
+<p:presentation xmlns:a="http://schemas.openxmlformats.org/drawingml/2006/main" xmlns:ns3="http://schemas.microsoft.com/office/powerpoint/2012/main" xmlns:p="http://schemas.openxmlformats.org/presentationml/2006/main" xmlns:r="http://schemas.openxmlformats.org/officeDocument/2006/relationships" strictFirstAndLastChars="0" embedTrueTypeFonts="1" saveSubsetFonts="1" autoCompressPictures="0">
   <p:sldMasterIdLst>
     <p:sldMasterId id="2147483660" r:id="rId1"/>
     <p:sldMasterId id="2147483661" r:id="rId2"/>
@@ -10,6 +10,7 @@
   </p:notesMasterIdLst>
   <p:sldIdLst>
     <p:sldId id="273" r:id="rId3"/>
+    <p:sldId id="275" r:id="rId41"/>
     <p:sldId id="257" r:id="rId4"/>
     <p:sldId id="258" r:id="rId5"/>
     <p:sldId id="259" r:id="rId6"/>
@@ -293,7 +294,7 @@
   </p:defaultTextStyle>
   <p:extLst>
     <p:ext uri="{EFAFB233-063F-42B5-8137-9DF3F51BA10A}">
-      <p15:sldGuideLst xmlns:p15="http://schemas.microsoft.com/office/powerpoint/2012/main"/>
+      <ns3:sldGuideLst/>
     </p:ext>
   </p:extLst>
 </p:presentation>
@@ -8839,7 +8840,7 @@
 </file>
 
 <file path=ppt/slides/slide1.xml><?xml version="1.0" encoding="utf-8"?>
-<p:sld xmlns:a="http://schemas.openxmlformats.org/drawingml/2006/main" xmlns:r="http://schemas.openxmlformats.org/officeDocument/2006/relationships" xmlns:p="http://schemas.openxmlformats.org/presentationml/2006/main">
+<p:sld xmlns:a="http://schemas.openxmlformats.org/drawingml/2006/main" xmlns:ns2="http://schemas.microsoft.com/office/drawing/2014/main" xmlns:p="http://schemas.openxmlformats.org/presentationml/2006/main" xmlns:r="http://schemas.openxmlformats.org/officeDocument/2006/relationships">
   <p:cSld>
     <p:spTree>
       <p:nvGrpSpPr>
@@ -8968,7 +8969,7 @@
                 <a:ea typeface="Roboto"/>
                 <a:cs typeface="Roboto"/>
               </a:rPr>
-              <a:t>01 / 14</a:t>
+              <a:t>01 / 15</a:t>
             </a:r>
             <a:endParaRPr lang="en-US" sz="825"/>
           </a:p>
@@ -9097,7 +9098,7 @@
           <p:cNvPr id="51" name="Group 50">
             <a:extLst>
               <a:ext uri="{FF2B5EF4-FFF2-40B4-BE49-F238E27FC236}">
-                <a16:creationId xmlns:a16="http://schemas.microsoft.com/office/drawing/2014/main" id="{20E8FF80-48AF-6E8D-86E7-41F98FD1B643}"/>
+                <ns2:creationId id="{20E8FF80-48AF-6E8D-86E7-41F98FD1B643}"/>
               </a:ext>
             </a:extLst>
           </p:cNvPr>
@@ -9214,7 +9215,7 @@
           <p:cNvPr id="40" name="Group 39">
             <a:extLst>
               <a:ext uri="{FF2B5EF4-FFF2-40B4-BE49-F238E27FC236}">
-                <a16:creationId xmlns:a16="http://schemas.microsoft.com/office/drawing/2014/main" id="{939B5BBD-A877-6A35-8B74-694742FCBCCE}"/>
+                <ns2:creationId id="{939B5BBD-A877-6A35-8B74-694742FCBCCE}"/>
               </a:ext>
             </a:extLst>
           </p:cNvPr>
@@ -9234,7 +9235,7 @@
             <p:cNvPr id="68" name="Panel">
               <a:extLst>
                 <a:ext uri="{FF2B5EF4-FFF2-40B4-BE49-F238E27FC236}">
-                  <a16:creationId xmlns:a16="http://schemas.microsoft.com/office/drawing/2014/main" id="{76B64712-1503-6DA9-5F3A-F5BBD4156390}"/>
+                  <ns2:creationId id="{76B64712-1503-6DA9-5F3A-F5BBD4156390}"/>
                 </a:ext>
               </a:extLst>
             </p:cNvPr>
@@ -9271,7 +9272,7 @@
             <p:cNvPr id="69" name="Slidesgo vector icon">
               <a:extLst>
                 <a:ext uri="{FF2B5EF4-FFF2-40B4-BE49-F238E27FC236}">
-                  <a16:creationId xmlns:a16="http://schemas.microsoft.com/office/drawing/2014/main" id="{BAC0D6DB-6BF6-63FE-6D4D-8A93553F8E90}"/>
+                  <ns2:creationId id="{BAC0D6DB-6BF6-63FE-6D4D-8A93553F8E90}"/>
                 </a:ext>
               </a:extLst>
             </p:cNvPr>
@@ -9291,7 +9292,7 @@
               <p:cNvPr id="70" name="Slidesgo vector icon">
                 <a:extLst>
                   <a:ext uri="{FF2B5EF4-FFF2-40B4-BE49-F238E27FC236}">
-                    <a16:creationId xmlns:a16="http://schemas.microsoft.com/office/drawing/2014/main" id="{0C83CEB6-43A7-4A15-1385-4CBB301ABE41}"/>
+                    <ns2:creationId id="{0C83CEB6-43A7-4A15-1385-4CBB301ABE41}"/>
                   </a:ext>
                 </a:extLst>
               </p:cNvPr>
@@ -9571,7 +9572,7 @@
               <p:cNvPr id="71" name="Slidesgo vector icon">
                 <a:extLst>
                   <a:ext uri="{FF2B5EF4-FFF2-40B4-BE49-F238E27FC236}">
-                    <a16:creationId xmlns:a16="http://schemas.microsoft.com/office/drawing/2014/main" id="{EF5E70BC-8F9C-B66D-2D69-DC39DC4869C3}"/>
+                    <ns2:creationId id="{EF5E70BC-8F9C-B66D-2D69-DC39DC4869C3}"/>
                   </a:ext>
                 </a:extLst>
               </p:cNvPr>
@@ -9652,7 +9653,7 @@
               <p:cNvPr id="72" name="Slidesgo vector icon">
                 <a:extLst>
                   <a:ext uri="{FF2B5EF4-FFF2-40B4-BE49-F238E27FC236}">
-                    <a16:creationId xmlns:a16="http://schemas.microsoft.com/office/drawing/2014/main" id="{9B725F86-B387-7443-17B5-A7D529D3BA3C}"/>
+                    <ns2:creationId id="{9B725F86-B387-7443-17B5-A7D529D3BA3C}"/>
                   </a:ext>
                 </a:extLst>
               </p:cNvPr>
@@ -9733,7 +9734,7 @@
               <p:cNvPr id="73" name="Slidesgo vector icon">
                 <a:extLst>
                   <a:ext uri="{FF2B5EF4-FFF2-40B4-BE49-F238E27FC236}">
-                    <a16:creationId xmlns:a16="http://schemas.microsoft.com/office/drawing/2014/main" id="{280F64FD-CECA-743A-4D2B-B53067221410}"/>
+                    <ns2:creationId id="{280F64FD-CECA-743A-4D2B-B53067221410}"/>
                   </a:ext>
                 </a:extLst>
               </p:cNvPr>
@@ -9811,7 +9812,7 @@
               <p:cNvPr id="74" name="Slidesgo vector icon">
                 <a:extLst>
                   <a:ext uri="{FF2B5EF4-FFF2-40B4-BE49-F238E27FC236}">
-                    <a16:creationId xmlns:a16="http://schemas.microsoft.com/office/drawing/2014/main" id="{C29E5117-357A-EDB3-B8F0-02609EE375E4}"/>
+                    <ns2:creationId id="{C29E5117-357A-EDB3-B8F0-02609EE375E4}"/>
                   </a:ext>
                 </a:extLst>
               </p:cNvPr>
@@ -9892,7 +9893,7 @@
               <p:cNvPr id="75" name="Slidesgo vector icon">
                 <a:extLst>
                   <a:ext uri="{FF2B5EF4-FFF2-40B4-BE49-F238E27FC236}">
-                    <a16:creationId xmlns:a16="http://schemas.microsoft.com/office/drawing/2014/main" id="{98501499-CC54-F24D-96B8-7ABF9DBBCA89}"/>
+                    <ns2:creationId id="{98501499-CC54-F24D-96B8-7ABF9DBBCA89}"/>
                   </a:ext>
                 </a:extLst>
               </p:cNvPr>
@@ -9970,7 +9971,7 @@
               <p:cNvPr id="76" name="Slidesgo vector icon">
                 <a:extLst>
                   <a:ext uri="{FF2B5EF4-FFF2-40B4-BE49-F238E27FC236}">
-                    <a16:creationId xmlns:a16="http://schemas.microsoft.com/office/drawing/2014/main" id="{BF3A17E8-73EE-5DE4-CF82-9FCD3B24C529}"/>
+                    <ns2:creationId id="{BF3A17E8-73EE-5DE4-CF82-9FCD3B24C529}"/>
                   </a:ext>
                 </a:extLst>
               </p:cNvPr>
@@ -10049,7 +10050,7 @@
             <p:cNvPr id="77" name="Text">
               <a:extLst>
                 <a:ext uri="{FF2B5EF4-FFF2-40B4-BE49-F238E27FC236}">
-                  <a16:creationId xmlns:a16="http://schemas.microsoft.com/office/drawing/2014/main" id="{BFA5BE25-2ED1-D903-8E90-F7AAD5B384ED}"/>
+                  <ns2:creationId id="{BFA5BE25-2ED1-D903-8E90-F7AAD5B384ED}"/>
                 </a:ext>
               </a:extLst>
             </p:cNvPr>
@@ -10105,7 +10106,7 @@
           <p:cNvPr id="39" name="Group 38">
             <a:extLst>
               <a:ext uri="{FF2B5EF4-FFF2-40B4-BE49-F238E27FC236}">
-                <a16:creationId xmlns:a16="http://schemas.microsoft.com/office/drawing/2014/main" id="{FB1F52E7-E646-D736-FBBF-FA6276A0AF49}"/>
+                <ns2:creationId id="{FB1F52E7-E646-D736-FBBF-FA6276A0AF49}"/>
               </a:ext>
             </a:extLst>
           </p:cNvPr>
@@ -10125,7 +10126,7 @@
             <p:cNvPr id="79" name="Panel">
               <a:extLst>
                 <a:ext uri="{FF2B5EF4-FFF2-40B4-BE49-F238E27FC236}">
-                  <a16:creationId xmlns:a16="http://schemas.microsoft.com/office/drawing/2014/main" id="{9254CAC6-CECE-E025-5A56-E4F7F1762FE8}"/>
+                  <ns2:creationId id="{9254CAC6-CECE-E025-5A56-E4F7F1762FE8}"/>
                 </a:ext>
               </a:extLst>
             </p:cNvPr>
@@ -10162,7 +10163,7 @@
             <p:cNvPr id="80" name="Slidesgo vector icon">
               <a:extLst>
                 <a:ext uri="{FF2B5EF4-FFF2-40B4-BE49-F238E27FC236}">
-                  <a16:creationId xmlns:a16="http://schemas.microsoft.com/office/drawing/2014/main" id="{683036B3-E282-2E15-1C58-7F49FBEED0B5}"/>
+                  <ns2:creationId id="{683036B3-E282-2E15-1C58-7F49FBEED0B5}"/>
                 </a:ext>
               </a:extLst>
             </p:cNvPr>
@@ -10182,7 +10183,7 @@
               <p:cNvPr id="81" name="Slidesgo vector icon">
                 <a:extLst>
                   <a:ext uri="{FF2B5EF4-FFF2-40B4-BE49-F238E27FC236}">
-                    <a16:creationId xmlns:a16="http://schemas.microsoft.com/office/drawing/2014/main" id="{481F657E-33C4-8226-36EA-1CFB6747AE27}"/>
+                    <ns2:creationId id="{481F657E-33C4-8226-36EA-1CFB6747AE27}"/>
                   </a:ext>
                 </a:extLst>
               </p:cNvPr>
@@ -10319,7 +10320,7 @@
               <p:cNvPr id="82" name="Slidesgo vector icon">
                 <a:extLst>
                   <a:ext uri="{FF2B5EF4-FFF2-40B4-BE49-F238E27FC236}">
-                    <a16:creationId xmlns:a16="http://schemas.microsoft.com/office/drawing/2014/main" id="{86DD95EA-03D3-45CC-709A-A2B3B20AA8E7}"/>
+                    <ns2:creationId id="{86DD95EA-03D3-45CC-709A-A2B3B20AA8E7}"/>
                   </a:ext>
                 </a:extLst>
               </p:cNvPr>
@@ -10433,7 +10434,7 @@
               <p:cNvPr id="83" name="Slidesgo vector icon">
                 <a:extLst>
                   <a:ext uri="{FF2B5EF4-FFF2-40B4-BE49-F238E27FC236}">
-                    <a16:creationId xmlns:a16="http://schemas.microsoft.com/office/drawing/2014/main" id="{B387EEB1-EAD0-6F59-B9C3-10AC3F717BE3}"/>
+                    <ns2:creationId id="{B387EEB1-EAD0-6F59-B9C3-10AC3F717BE3}"/>
                   </a:ext>
                 </a:extLst>
               </p:cNvPr>
@@ -10564,7 +10565,7 @@
             <p:cNvPr id="84" name="Text">
               <a:extLst>
                 <a:ext uri="{FF2B5EF4-FFF2-40B4-BE49-F238E27FC236}">
-                  <a16:creationId xmlns:a16="http://schemas.microsoft.com/office/drawing/2014/main" id="{5E20359A-8CB1-DEBA-D453-0909D1EDED68}"/>
+                  <ns2:creationId id="{5E20359A-8CB1-DEBA-D453-0909D1EDED68}"/>
                 </a:ext>
               </a:extLst>
             </p:cNvPr>
@@ -10620,7 +10621,7 @@
           <p:cNvPr id="38" name="Group 37">
             <a:extLst>
               <a:ext uri="{FF2B5EF4-FFF2-40B4-BE49-F238E27FC236}">
-                <a16:creationId xmlns:a16="http://schemas.microsoft.com/office/drawing/2014/main" id="{9070D538-8DE9-3F8B-AD9D-4E5621EFC16F}"/>
+                <ns2:creationId id="{9070D538-8DE9-3F8B-AD9D-4E5621EFC16F}"/>
               </a:ext>
             </a:extLst>
           </p:cNvPr>
@@ -10640,7 +10641,7 @@
             <p:cNvPr id="86" name="Panel">
               <a:extLst>
                 <a:ext uri="{FF2B5EF4-FFF2-40B4-BE49-F238E27FC236}">
-                  <a16:creationId xmlns:a16="http://schemas.microsoft.com/office/drawing/2014/main" id="{EDC22F6E-0F73-CF49-F5FB-B3BCD31CB6A2}"/>
+                  <ns2:creationId id="{EDC22F6E-0F73-CF49-F5FB-B3BCD31CB6A2}"/>
                 </a:ext>
               </a:extLst>
             </p:cNvPr>
@@ -10677,7 +10678,7 @@
             <p:cNvPr id="87" name="Slidesgo vector icon">
               <a:extLst>
                 <a:ext uri="{FF2B5EF4-FFF2-40B4-BE49-F238E27FC236}">
-                  <a16:creationId xmlns:a16="http://schemas.microsoft.com/office/drawing/2014/main" id="{CA399CEB-AC7D-BFED-D5B2-A7F8F56112B7}"/>
+                  <ns2:creationId id="{CA399CEB-AC7D-BFED-D5B2-A7F8F56112B7}"/>
                 </a:ext>
               </a:extLst>
             </p:cNvPr>
@@ -10697,7 +10698,7 @@
               <p:cNvPr id="88" name="Slidesgo vector icon">
                 <a:extLst>
                   <a:ext uri="{FF2B5EF4-FFF2-40B4-BE49-F238E27FC236}">
-                    <a16:creationId xmlns:a16="http://schemas.microsoft.com/office/drawing/2014/main" id="{D82A9435-015D-48B2-04C9-F01CD559F540}"/>
+                    <ns2:creationId id="{D82A9435-015D-48B2-04C9-F01CD559F540}"/>
                   </a:ext>
                 </a:extLst>
               </p:cNvPr>
@@ -10982,7 +10983,7 @@
               <p:cNvPr id="89" name="Slidesgo vector icon">
                 <a:extLst>
                   <a:ext uri="{FF2B5EF4-FFF2-40B4-BE49-F238E27FC236}">
-                    <a16:creationId xmlns:a16="http://schemas.microsoft.com/office/drawing/2014/main" id="{1C75B90E-3124-8621-E69F-F9541526FC9D}"/>
+                    <ns2:creationId id="{1C75B90E-3124-8621-E69F-F9541526FC9D}"/>
                   </a:ext>
                 </a:extLst>
               </p:cNvPr>
@@ -11060,7 +11061,7 @@
               <p:cNvPr id="90" name="Slidesgo vector icon">
                 <a:extLst>
                   <a:ext uri="{FF2B5EF4-FFF2-40B4-BE49-F238E27FC236}">
-                    <a16:creationId xmlns:a16="http://schemas.microsoft.com/office/drawing/2014/main" id="{599352D1-9182-F916-21D5-35147D526488}"/>
+                    <ns2:creationId id="{599352D1-9182-F916-21D5-35147D526488}"/>
                   </a:ext>
                 </a:extLst>
               </p:cNvPr>
@@ -11138,7 +11139,7 @@
               <p:cNvPr id="91" name="Slidesgo vector icon">
                 <a:extLst>
                   <a:ext uri="{FF2B5EF4-FFF2-40B4-BE49-F238E27FC236}">
-                    <a16:creationId xmlns:a16="http://schemas.microsoft.com/office/drawing/2014/main" id="{D101E69A-3DB1-54E5-3902-FA79BC9FE66D}"/>
+                    <ns2:creationId id="{D101E69A-3DB1-54E5-3902-FA79BC9FE66D}"/>
                   </a:ext>
                 </a:extLst>
               </p:cNvPr>
@@ -11216,7 +11217,7 @@
               <p:cNvPr id="92" name="Slidesgo vector icon">
                 <a:extLst>
                   <a:ext uri="{FF2B5EF4-FFF2-40B4-BE49-F238E27FC236}">
-                    <a16:creationId xmlns:a16="http://schemas.microsoft.com/office/drawing/2014/main" id="{09BA3F6E-7158-4D9D-166E-5B65520AAFE5}"/>
+                    <ns2:creationId id="{09BA3F6E-7158-4D9D-166E-5B65520AAFE5}"/>
                   </a:ext>
                 </a:extLst>
               </p:cNvPr>
@@ -11298,7 +11299,7 @@
             <p:cNvPr id="93" name="Text">
               <a:extLst>
                 <a:ext uri="{FF2B5EF4-FFF2-40B4-BE49-F238E27FC236}">
-                  <a16:creationId xmlns:a16="http://schemas.microsoft.com/office/drawing/2014/main" id="{460C0600-9A45-FAED-3473-507E0964F0BD}"/>
+                  <ns2:creationId id="{460C0600-9A45-FAED-3473-507E0964F0BD}"/>
                 </a:ext>
               </a:extLst>
             </p:cNvPr>
@@ -11354,7 +11355,7 @@
           <p:cNvPr id="47" name="Group 46">
             <a:extLst>
               <a:ext uri="{FF2B5EF4-FFF2-40B4-BE49-F238E27FC236}">
-                <a16:creationId xmlns:a16="http://schemas.microsoft.com/office/drawing/2014/main" id="{2D0D158D-A6B3-6592-332E-F3CD1F03E56C}"/>
+                <ns2:creationId id="{2D0D158D-A6B3-6592-332E-F3CD1F03E56C}"/>
               </a:ext>
             </a:extLst>
           </p:cNvPr>
@@ -11374,7 +11375,7 @@
             <p:cNvPr id="97" name="Circle">
               <a:extLst>
                 <a:ext uri="{FF2B5EF4-FFF2-40B4-BE49-F238E27FC236}">
-                  <a16:creationId xmlns:a16="http://schemas.microsoft.com/office/drawing/2014/main" id="{0E68E301-BAC8-7A1E-1973-399100DE1A80}"/>
+                  <ns2:creationId id="{0E68E301-BAC8-7A1E-1973-399100DE1A80}"/>
                 </a:ext>
               </a:extLst>
             </p:cNvPr>
@@ -11409,7 +11410,7 @@
             <p:cNvPr id="98" name="Slidesgo vector icon">
               <a:extLst>
                 <a:ext uri="{FF2B5EF4-FFF2-40B4-BE49-F238E27FC236}">
-                  <a16:creationId xmlns:a16="http://schemas.microsoft.com/office/drawing/2014/main" id="{3A6B9F7E-57C1-5DF1-1694-00186F6D3725}"/>
+                  <ns2:creationId id="{3A6B9F7E-57C1-5DF1-1694-00186F6D3725}"/>
                 </a:ext>
               </a:extLst>
             </p:cNvPr>
@@ -11429,7 +11430,7 @@
               <p:cNvPr id="99" name="Slidesgo vector icon">
                 <a:extLst>
                   <a:ext uri="{FF2B5EF4-FFF2-40B4-BE49-F238E27FC236}">
-                    <a16:creationId xmlns:a16="http://schemas.microsoft.com/office/drawing/2014/main" id="{B88D9B61-E981-5903-3A80-F417EF3CF825}"/>
+                    <ns2:creationId id="{B88D9B61-E981-5903-3A80-F417EF3CF825}"/>
                   </a:ext>
                 </a:extLst>
               </p:cNvPr>
@@ -11565,7 +11566,7 @@
               <p:cNvPr id="100" name="Slidesgo vector icon">
                 <a:extLst>
                   <a:ext uri="{FF2B5EF4-FFF2-40B4-BE49-F238E27FC236}">
-                    <a16:creationId xmlns:a16="http://schemas.microsoft.com/office/drawing/2014/main" id="{222C4658-8484-0EC8-9E6C-9AAA9356D16E}"/>
+                    <ns2:creationId id="{222C4658-8484-0EC8-9E6C-9AAA9356D16E}"/>
                   </a:ext>
                 </a:extLst>
               </p:cNvPr>
@@ -11765,7 +11766,7 @@
           <p:cNvPr id="34" name="Panel">
             <a:extLst>
               <a:ext uri="{FF2B5EF4-FFF2-40B4-BE49-F238E27FC236}">
-                <a16:creationId xmlns:a16="http://schemas.microsoft.com/office/drawing/2014/main" id="{9F734626-9B71-0A53-F9EC-E23AAB6032C3}"/>
+                <ns2:creationId id="{9F734626-9B71-0A53-F9EC-E23AAB6032C3}"/>
               </a:ext>
             </a:extLst>
           </p:cNvPr>
@@ -12093,7 +12094,7 @@
           <p:cNvPr id="35" name="Panel">
             <a:extLst>
               <a:ext uri="{FF2B5EF4-FFF2-40B4-BE49-F238E27FC236}">
-                <a16:creationId xmlns:a16="http://schemas.microsoft.com/office/drawing/2014/main" id="{A08C94ED-0C92-6B83-8183-682E3C7A682D}"/>
+                <ns2:creationId id="{A08C94ED-0C92-6B83-8183-682E3C7A682D}"/>
               </a:ext>
             </a:extLst>
           </p:cNvPr>
@@ -12395,7 +12396,7 @@
           <p:cNvPr id="37" name="Picture 36">
             <a:extLst>
               <a:ext uri="{FF2B5EF4-FFF2-40B4-BE49-F238E27FC236}">
-                <a16:creationId xmlns:a16="http://schemas.microsoft.com/office/drawing/2014/main" id="{FDDF18D1-394C-9D32-9BDE-7DFEFB2BDB59}"/>
+                <ns2:creationId id="{FDDF18D1-394C-9D32-9BDE-7DFEFB2BDB59}"/>
               </a:ext>
             </a:extLst>
           </p:cNvPr>
@@ -12429,7 +12430,7 @@
 </file>
 
 <file path=ppt/slides/slide10.xml><?xml version="1.0" encoding="utf-8"?>
-<p:sld xmlns:a="http://schemas.openxmlformats.org/drawingml/2006/main" xmlns:r="http://schemas.openxmlformats.org/officeDocument/2006/relationships" xmlns:p="http://schemas.openxmlformats.org/presentationml/2006/main">
+<p:sld xmlns:a="http://schemas.openxmlformats.org/drawingml/2006/main" xmlns:ns2="http://schemas.microsoft.com/office/drawing/2014/main" xmlns:p="http://schemas.openxmlformats.org/presentationml/2006/main">
   <p:cSld>
     <p:spTree>
       <p:nvGrpSpPr>
@@ -12607,7 +12608,7 @@
                 <a:ea typeface="Roboto"/>
                 <a:cs typeface="Roboto"/>
               </a:rPr>
-              <a:t>10 / 14</a:t>
+              <a:t>11 / 15</a:t>
             </a:r>
             <a:endParaRPr lang="en-US" sz="825"/>
           </a:p>
@@ -13160,7 +13161,7 @@
           <p:cNvPr id="51" name="Slidesgo vector icon">
             <a:extLst>
               <a:ext uri="{FF2B5EF4-FFF2-40B4-BE49-F238E27FC236}">
-                <a16:creationId xmlns:a16="http://schemas.microsoft.com/office/drawing/2014/main" id="{A1C03D15-599F-1E39-91AC-223283FCAD6E}"/>
+                <ns2:creationId id="{A1C03D15-599F-1E39-91AC-223283FCAD6E}"/>
               </a:ext>
             </a:extLst>
           </p:cNvPr>
@@ -13180,7 +13181,7 @@
             <p:cNvPr id="52" name="Slidesgo vector icon">
               <a:extLst>
                 <a:ext uri="{FF2B5EF4-FFF2-40B4-BE49-F238E27FC236}">
-                  <a16:creationId xmlns:a16="http://schemas.microsoft.com/office/drawing/2014/main" id="{96DCC53B-5B42-D9C8-1E00-AA0EDA65B4EF}"/>
+                  <ns2:creationId id="{96DCC53B-5B42-D9C8-1E00-AA0EDA65B4EF}"/>
                 </a:ext>
               </a:extLst>
             </p:cNvPr>
@@ -13262,7 +13263,7 @@
             <p:cNvPr id="53" name="Slidesgo vector icon">
               <a:extLst>
                 <a:ext uri="{FF2B5EF4-FFF2-40B4-BE49-F238E27FC236}">
-                  <a16:creationId xmlns:a16="http://schemas.microsoft.com/office/drawing/2014/main" id="{DDF59275-BE11-9BD9-4D39-C1111EA19AC7}"/>
+                  <ns2:creationId id="{DDF59275-BE11-9BD9-4D39-C1111EA19AC7}"/>
                 </a:ext>
               </a:extLst>
             </p:cNvPr>
@@ -13476,7 +13477,7 @@
           <p:cNvPr id="54" name="Slidesgo vector icon">
             <a:extLst>
               <a:ext uri="{FF2B5EF4-FFF2-40B4-BE49-F238E27FC236}">
-                <a16:creationId xmlns:a16="http://schemas.microsoft.com/office/drawing/2014/main" id="{781956E5-3639-4524-55B1-237F7852C0BB}"/>
+                <ns2:creationId id="{781956E5-3639-4524-55B1-237F7852C0BB}"/>
               </a:ext>
             </a:extLst>
           </p:cNvPr>
@@ -13496,7 +13497,7 @@
             <p:cNvPr id="55" name="Slidesgo vector icon">
               <a:extLst>
                 <a:ext uri="{FF2B5EF4-FFF2-40B4-BE49-F238E27FC236}">
-                  <a16:creationId xmlns:a16="http://schemas.microsoft.com/office/drawing/2014/main" id="{7BE9C7E5-EEBA-AC98-03CD-F4B37F1F88DE}"/>
+                  <ns2:creationId id="{7BE9C7E5-EEBA-AC98-03CD-F4B37F1F88DE}"/>
                 </a:ext>
               </a:extLst>
             </p:cNvPr>
@@ -13778,7 +13779,7 @@
             <p:cNvPr id="56" name="Slidesgo vector icon">
               <a:extLst>
                 <a:ext uri="{FF2B5EF4-FFF2-40B4-BE49-F238E27FC236}">
-                  <a16:creationId xmlns:a16="http://schemas.microsoft.com/office/drawing/2014/main" id="{FADB2C54-B50F-4449-0F20-A8307CC66AC1}"/>
+                  <ns2:creationId id="{FADB2C54-B50F-4449-0F20-A8307CC66AC1}"/>
                 </a:ext>
               </a:extLst>
             </p:cNvPr>
@@ -13898,7 +13899,7 @@
           <p:cNvPr id="57" name="Slidesgo vector icon">
             <a:extLst>
               <a:ext uri="{FF2B5EF4-FFF2-40B4-BE49-F238E27FC236}">
-                <a16:creationId xmlns:a16="http://schemas.microsoft.com/office/drawing/2014/main" id="{FD8C5E2F-88DF-1F42-C60D-8CA7F24B46F5}"/>
+                <ns2:creationId id="{FD8C5E2F-88DF-1F42-C60D-8CA7F24B46F5}"/>
               </a:ext>
             </a:extLst>
           </p:cNvPr>
@@ -13918,7 +13919,7 @@
             <p:cNvPr id="58" name="Slidesgo vector icon">
               <a:extLst>
                 <a:ext uri="{FF2B5EF4-FFF2-40B4-BE49-F238E27FC236}">
-                  <a16:creationId xmlns:a16="http://schemas.microsoft.com/office/drawing/2014/main" id="{1B81B569-68ED-8F45-F8F5-5A96775331D6}"/>
+                  <ns2:creationId id="{1B81B569-68ED-8F45-F8F5-5A96775331D6}"/>
                 </a:ext>
               </a:extLst>
             </p:cNvPr>
@@ -14198,7 +14199,7 @@
             <p:cNvPr id="59" name="Slidesgo vector icon">
               <a:extLst>
                 <a:ext uri="{FF2B5EF4-FFF2-40B4-BE49-F238E27FC236}">
-                  <a16:creationId xmlns:a16="http://schemas.microsoft.com/office/drawing/2014/main" id="{8D1960D0-1F42-77CA-AC4E-79609AF64D28}"/>
+                  <ns2:creationId id="{8D1960D0-1F42-77CA-AC4E-79609AF64D28}"/>
                 </a:ext>
               </a:extLst>
             </p:cNvPr>
@@ -14279,7 +14280,7 @@
             <p:cNvPr id="60" name="Slidesgo vector icon">
               <a:extLst>
                 <a:ext uri="{FF2B5EF4-FFF2-40B4-BE49-F238E27FC236}">
-                  <a16:creationId xmlns:a16="http://schemas.microsoft.com/office/drawing/2014/main" id="{385F08ED-5851-A04C-F690-E09E63556B83}"/>
+                  <ns2:creationId id="{385F08ED-5851-A04C-F690-E09E63556B83}"/>
                 </a:ext>
               </a:extLst>
             </p:cNvPr>
@@ -14360,7 +14361,7 @@
             <p:cNvPr id="61" name="Slidesgo vector icon">
               <a:extLst>
                 <a:ext uri="{FF2B5EF4-FFF2-40B4-BE49-F238E27FC236}">
-                  <a16:creationId xmlns:a16="http://schemas.microsoft.com/office/drawing/2014/main" id="{898DACC0-BEF7-E3DD-801B-4EB9EE851AE5}"/>
+                  <ns2:creationId id="{898DACC0-BEF7-E3DD-801B-4EB9EE851AE5}"/>
                 </a:ext>
               </a:extLst>
             </p:cNvPr>
@@ -14438,7 +14439,7 @@
             <p:cNvPr id="62" name="Slidesgo vector icon">
               <a:extLst>
                 <a:ext uri="{FF2B5EF4-FFF2-40B4-BE49-F238E27FC236}">
-                  <a16:creationId xmlns:a16="http://schemas.microsoft.com/office/drawing/2014/main" id="{4FC08471-C554-BA0A-1690-A3DAB72F88C0}"/>
+                  <ns2:creationId id="{4FC08471-C554-BA0A-1690-A3DAB72F88C0}"/>
                 </a:ext>
               </a:extLst>
             </p:cNvPr>
@@ -14519,7 +14520,7 @@
             <p:cNvPr id="63" name="Slidesgo vector icon">
               <a:extLst>
                 <a:ext uri="{FF2B5EF4-FFF2-40B4-BE49-F238E27FC236}">
-                  <a16:creationId xmlns:a16="http://schemas.microsoft.com/office/drawing/2014/main" id="{897B88E0-6A2B-FE2C-7D28-D35636C9F648}"/>
+                  <ns2:creationId id="{897B88E0-6A2B-FE2C-7D28-D35636C9F648}"/>
                 </a:ext>
               </a:extLst>
             </p:cNvPr>
@@ -14597,7 +14598,7 @@
             <p:cNvPr id="64" name="Slidesgo vector icon">
               <a:extLst>
                 <a:ext uri="{FF2B5EF4-FFF2-40B4-BE49-F238E27FC236}">
-                  <a16:creationId xmlns:a16="http://schemas.microsoft.com/office/drawing/2014/main" id="{61D90D7B-0769-C8BF-4AD7-C934D3F48F1A}"/>
+                  <ns2:creationId id="{61D90D7B-0769-C8BF-4AD7-C934D3F48F1A}"/>
                 </a:ext>
               </a:extLst>
             </p:cNvPr>
@@ -14676,7 +14677,7 @@
           <p:cNvPr id="65" name="Slidesgo vector icon">
             <a:extLst>
               <a:ext uri="{FF2B5EF4-FFF2-40B4-BE49-F238E27FC236}">
-                <a16:creationId xmlns:a16="http://schemas.microsoft.com/office/drawing/2014/main" id="{F4E728AA-6FE5-E075-01AF-63830C63AB7B}"/>
+                <ns2:creationId id="{F4E728AA-6FE5-E075-01AF-63830C63AB7B}"/>
               </a:ext>
             </a:extLst>
           </p:cNvPr>
@@ -14696,7 +14697,7 @@
             <p:cNvPr id="66" name="Slidesgo vector icon">
               <a:extLst>
                 <a:ext uri="{FF2B5EF4-FFF2-40B4-BE49-F238E27FC236}">
-                  <a16:creationId xmlns:a16="http://schemas.microsoft.com/office/drawing/2014/main" id="{997E6BE8-1228-17A3-B003-ABA0EA41D68B}"/>
+                  <ns2:creationId id="{997E6BE8-1228-17A3-B003-ABA0EA41D68B}"/>
                 </a:ext>
               </a:extLst>
             </p:cNvPr>
@@ -14774,7 +14775,7 @@
             <p:cNvPr id="67" name="Slidesgo vector icon">
               <a:extLst>
                 <a:ext uri="{FF2B5EF4-FFF2-40B4-BE49-F238E27FC236}">
-                  <a16:creationId xmlns:a16="http://schemas.microsoft.com/office/drawing/2014/main" id="{224197E4-A740-C7AF-E0C5-6FA3EB71C195}"/>
+                  <ns2:creationId id="{224197E4-A740-C7AF-E0C5-6FA3EB71C195}"/>
                 </a:ext>
               </a:extLst>
             </p:cNvPr>
@@ -14845,7 +14846,7 @@
             <p:cNvPr id="68" name="Slidesgo vector icon">
               <a:extLst>
                 <a:ext uri="{FF2B5EF4-FFF2-40B4-BE49-F238E27FC236}">
-                  <a16:creationId xmlns:a16="http://schemas.microsoft.com/office/drawing/2014/main" id="{1ABAD2F7-BED2-1C36-68DC-8593E2CC6D59}"/>
+                  <ns2:creationId id="{1ABAD2F7-BED2-1C36-68DC-8593E2CC6D59}"/>
                 </a:ext>
               </a:extLst>
             </p:cNvPr>
@@ -15023,7 +15024,7 @@
             <p:cNvPr id="69" name="Slidesgo vector icon">
               <a:extLst>
                 <a:ext uri="{FF2B5EF4-FFF2-40B4-BE49-F238E27FC236}">
-                  <a16:creationId xmlns:a16="http://schemas.microsoft.com/office/drawing/2014/main" id="{9ECA7519-BDB2-E67D-DFC3-8F736DF02376}"/>
+                  <ns2:creationId id="{9ECA7519-BDB2-E67D-DFC3-8F736DF02376}"/>
                 </a:ext>
               </a:extLst>
             </p:cNvPr>
@@ -15113,7 +15114,7 @@
 </file>
 
 <file path=ppt/slides/slide11.xml><?xml version="1.0" encoding="utf-8"?>
-<p:sld xmlns:a="http://schemas.openxmlformats.org/drawingml/2006/main" xmlns:r="http://schemas.openxmlformats.org/officeDocument/2006/relationships" xmlns:p="http://schemas.openxmlformats.org/presentationml/2006/main" showMasterSp="0">
+<p:sld xmlns:a="http://schemas.openxmlformats.org/drawingml/2006/main" xmlns:p="http://schemas.openxmlformats.org/presentationml/2006/main" showMasterSp="0">
   <p:cSld name="Short-term and long-term decisions">
     <p:bg>
       <p:bgPr>
@@ -15344,7 +15345,7 @@
                 <a:ea typeface="Roboto"/>
                 <a:cs typeface="Roboto"/>
               </a:rPr>
-              <a:t>11 /  14</a:t>
+              <a:t>12 / 15</a:t>
             </a:r>
             <a:endParaRPr lang="en-US" sz="825" dirty="0"/>
           </a:p>
@@ -17863,7 +17864,7 @@
 </file>
 
 <file path=ppt/slides/slide12.xml><?xml version="1.0" encoding="utf-8"?>
-<p:sld xmlns:a="http://schemas.openxmlformats.org/drawingml/2006/main" xmlns:r="http://schemas.openxmlformats.org/officeDocument/2006/relationships" xmlns:p="http://schemas.openxmlformats.org/presentationml/2006/main" showMasterSp="0">
+<p:sld xmlns:a="http://schemas.openxmlformats.org/drawingml/2006/main" xmlns:p="http://schemas.openxmlformats.org/presentationml/2006/main" showMasterSp="0">
   <p:cSld name="Connected decisions">
     <p:bg>
       <p:bgPr>
@@ -18045,7 +18046,7 @@
                 <a:ea typeface="Roboto"/>
                 <a:cs typeface="Roboto"/>
               </a:rPr>
-              <a:t>12 / </a:t>
+              <a:t>13 / 15</a:t>
             </a:r>
             <a:r>
               <a:rPr lang="en-US" sz="825" dirty="0">
@@ -18056,7 +18057,7 @@
                 <a:ea typeface="Roboto"/>
                 <a:cs typeface="Roboto"/>
               </a:rPr>
-              <a:t> 14</a:t>
+              <a:t/>
             </a:r>
             <a:endParaRPr lang="en-US" sz="825" dirty="0"/>
           </a:p>
@@ -20139,7 +20140,7 @@
 </file>
 
 <file path=ppt/slides/slide13.xml><?xml version="1.0" encoding="utf-8"?>
-<p:sld xmlns:a="http://schemas.openxmlformats.org/drawingml/2006/main" xmlns:r="http://schemas.openxmlformats.org/officeDocument/2006/relationships" xmlns:p="http://schemas.openxmlformats.org/presentationml/2006/main" showMasterSp="0">
+<p:sld xmlns:a="http://schemas.openxmlformats.org/drawingml/2006/main" xmlns:p="http://schemas.openxmlformats.org/presentationml/2006/main" showMasterSp="0">
   <p:cSld name="How machine learning helps">
     <p:bg>
       <p:bgPr>
@@ -20321,7 +20322,7 @@
                 <a:ea typeface="Roboto"/>
                 <a:cs typeface="Roboto"/>
               </a:rPr>
-              <a:t>13 </a:t>
+              <a:t>14 / 15</a:t>
             </a:r>
             <a:r>
               <a:rPr lang="en-US" sz="825">
@@ -20332,7 +20333,7 @@
                 <a:ea typeface="Roboto"/>
                 <a:cs typeface="Roboto"/>
               </a:rPr>
-              <a:t>/ 14</a:t>
+              <a:t/>
             </a:r>
             <a:endParaRPr lang="en-US" sz="825" dirty="0"/>
           </a:p>
@@ -22743,14 +22744,14 @@
 </file>
 
 <file path=ppt/slides/slide14.xml><?xml version="1.0" encoding="utf-8"?>
-<p:sld xmlns:a="http://schemas.openxmlformats.org/drawingml/2006/main" xmlns:r="http://schemas.openxmlformats.org/officeDocument/2006/relationships" xmlns:p="http://schemas.openxmlformats.org/presentationml/2006/main">
+<p:sld xmlns:a="http://schemas.openxmlformats.org/drawingml/2006/main" xmlns:ns2="http://schemas.microsoft.com/office/drawing/2014/main" xmlns:ns3="http://schemas.microsoft.com/office/powerpoint/2010/main" xmlns:p="http://schemas.openxmlformats.org/presentationml/2006/main">
   <p:cSld>
     <p:spTree>
       <p:nvGrpSpPr>
         <p:cNvPr id="1" name="Root">
           <a:extLst>
             <a:ext uri="{FF2B5EF4-FFF2-40B4-BE49-F238E27FC236}">
-              <a16:creationId xmlns:a16="http://schemas.microsoft.com/office/drawing/2014/main" id="{49B883FB-59AA-61C2-7CCC-52D1B478485B}"/>
+              <ns2:creationId id="{49B883FB-59AA-61C2-7CCC-52D1B478485B}"/>
             </a:ext>
           </a:extLst>
         </p:cNvPr>
@@ -22770,7 +22771,7 @@
           <p:cNvPr id="3" name="Connector">
             <a:extLst>
               <a:ext uri="{FF2B5EF4-FFF2-40B4-BE49-F238E27FC236}">
-                <a16:creationId xmlns:a16="http://schemas.microsoft.com/office/drawing/2014/main" id="{1F6F1DD7-9C27-2067-E159-24DBF3A1B124}"/>
+                <ns2:creationId id="{1F6F1DD7-9C27-2067-E159-24DBF3A1B124}"/>
               </a:ext>
             </a:extLst>
           </p:cNvPr>
@@ -22797,7 +22798,7 @@
           <p:cNvPr id="4" name="Text">
             <a:extLst>
               <a:ext uri="{FF2B5EF4-FFF2-40B4-BE49-F238E27FC236}">
-                <a16:creationId xmlns:a16="http://schemas.microsoft.com/office/drawing/2014/main" id="{0C6390FA-3996-05C3-EB82-7E1EB5F70CAC}"/>
+                <ns2:creationId id="{0C6390FA-3996-05C3-EB82-7E1EB5F70CAC}"/>
               </a:ext>
             </a:extLst>
           </p:cNvPr>
@@ -22852,7 +22853,7 @@
           <p:cNvPr id="6" name="Text">
             <a:extLst>
               <a:ext uri="{FF2B5EF4-FFF2-40B4-BE49-F238E27FC236}">
-                <a16:creationId xmlns:a16="http://schemas.microsoft.com/office/drawing/2014/main" id="{8BE238E8-78E0-D554-C2D7-59227F0105BB}"/>
+                <ns2:creationId id="{8BE238E8-78E0-D554-C2D7-59227F0105BB}"/>
               </a:ext>
             </a:extLst>
           </p:cNvPr>
@@ -22896,7 +22897,7 @@
                 <a:ea typeface="Roboto"/>
                 <a:cs typeface="Roboto"/>
               </a:rPr>
-              <a:t>14 / 14</a:t>
+              <a:t>15 / 15</a:t>
             </a:r>
             <a:endParaRPr lang="en-US" sz="825" dirty="0"/>
           </a:p>
@@ -22907,7 +22908,7 @@
           <p:cNvPr id="22" name="Text">
             <a:extLst>
               <a:ext uri="{FF2B5EF4-FFF2-40B4-BE49-F238E27FC236}">
-                <a16:creationId xmlns:a16="http://schemas.microsoft.com/office/drawing/2014/main" id="{402E276F-AAF5-DEAF-EC9D-95A2775EB50E}"/>
+                <ns2:creationId id="{402E276F-AAF5-DEAF-EC9D-95A2775EB50E}"/>
               </a:ext>
             </a:extLst>
           </p:cNvPr>
@@ -22998,7 +22999,7 @@
     </p:spTree>
     <p:extLst>
       <p:ext uri="{BB962C8B-B14F-4D97-AF65-F5344CB8AC3E}">
-        <p14:creationId xmlns:p14="http://schemas.microsoft.com/office/powerpoint/2010/main" val="4170041916"/>
+        <ns3:creationId val="4170041916"/>
       </p:ext>
     </p:extLst>
   </p:cSld>
@@ -23008,8 +23009,793 @@
 </p:sld>
 </file>
 
+<file path=ppt/slides/slide15.xml><?xml version="1.0" encoding="utf-8"?>
+<p:sld xmlns:a="http://schemas.openxmlformats.org/drawingml/2006/main" xmlns:p="http://schemas.openxmlformats.org/presentationml/2006/main" showMasterSp="0">
+  <p:cSld name="Agenda">
+    <p:bg>
+      <p:bgPr>
+        <a:solidFill>
+          <a:srgbClr val="FFFFFF"/>
+        </a:solidFill>
+        <a:effectLst/>
+      </p:bgPr>
+    </p:bg>
+    <p:spTree>
+      <p:nvGrpSpPr>
+        <p:cNvPr id="1" name="Root"/>
+        <p:cNvGrpSpPr/>
+        <p:nvPr/>
+      </p:nvGrpSpPr>
+      <p:grpSpPr>
+        <a:xfrm>
+          <a:off x="0" y="0"/>
+          <a:ext cx="0" cy="0"/>
+          <a:chOff x="0" y="0"/>
+          <a:chExt cx="0" cy="0"/>
+        </a:xfrm>
+      </p:grpSpPr>
+      <p:sp>
+        <p:nvSpPr>
+          <p:cNvPr id="2" name="Text"/>
+          <p:cNvSpPr txBox="1"/>
+          <p:nvPr/>
+        </p:nvSpPr>
+        <p:spPr>
+          <a:xfrm>
+            <a:off x="495300" y="361950"/>
+            <a:ext cx="8172450" cy="552450"/>
+          </a:xfrm>
+          <a:prstGeom prst="rect">
+            <a:avLst/>
+          </a:prstGeom>
+          <a:noFill/>
+          <a:ln w="9525">
+            <a:noFill/>
+          </a:ln>
+        </p:spPr>
+        <p:txBody>
+          <a:bodyPr wrap="none" lIns="0" tIns="0" rIns="0" bIns="0" anchor="t">
+            <a:noAutofit/>
+          </a:bodyPr>
+          <a:lstStyle/>
+          <a:p>
+            <a:pPr marL="0" indent="0" algn="l">
+              <a:lnSpc>
+                <a:spcPts val="3938"/>
+              </a:lnSpc>
+              <a:spcAft>
+                <a:spcPts val="0"/>
+              </a:spcAft>
+              <a:buNone/>
+            </a:pPr>
+            <a:r>
+              <a:rPr lang="en-US" sz="3150" b="1">
+                <a:solidFill>
+                  <a:srgbClr val="435D74"/>
+                </a:solidFill>
+                <a:latin typeface="Fira Sans Extra Condensed"/>
+                <a:ea typeface="Fira Sans Extra Condensed"/>
+                <a:cs typeface="Fira Sans Extra Condensed"/>
+              </a:rPr>
+              <a:t>Agenda</a:t>
+            </a:r>
+            <a:endParaRPr lang="en-US" sz="3150"/>
+          </a:p>
+        </p:txBody>
+      </p:sp>
+      <p:cxnSp>
+        <p:nvCxnSpPr>
+          <p:cNvPr id="3" name="Connector"/>
+          <p:cNvCxnSpPr/>
+          <p:nvPr/>
+        </p:nvCxnSpPr>
+        <p:spPr>
+          <a:xfrm>
+            <a:off x="495300" y="4762500"/>
+            <a:ext cx="8153400" cy="95"/>
+          </a:xfrm>
+          <a:prstGeom prst="line">
+            <a:avLst/>
+          </a:prstGeom>
+          <a:ln w="6191">
+            <a:solidFill>
+              <a:srgbClr val="D8E2E8"/>
+            </a:solidFill>
+          </a:ln>
+        </p:spPr>
+      </p:cxnSp>
+      <p:sp>
+        <p:nvSpPr>
+          <p:cNvPr id="4" name="Text"/>
+          <p:cNvSpPr txBox="1"/>
+          <p:nvPr/>
+        </p:nvSpPr>
+        <p:spPr>
+          <a:xfrm>
+            <a:off x="495300" y="4867275"/>
+            <a:ext cx="2762250" cy="171450"/>
+          </a:xfrm>
+          <a:prstGeom prst="rect">
+            <a:avLst/>
+          </a:prstGeom>
+          <a:noFill/>
+          <a:ln w="9525">
+            <a:noFill/>
+          </a:ln>
+        </p:spPr>
+        <p:txBody>
+          <a:bodyPr wrap="none" lIns="0" tIns="0" rIns="0" bIns="0" anchor="t">
+            <a:noAutofit/>
+          </a:bodyPr>
+          <a:lstStyle/>
+          <a:p>
+            <a:pPr marL="0" indent="0" algn="l">
+              <a:lnSpc>
+                <a:spcPts val="1031"/>
+              </a:lnSpc>
+              <a:spcAft>
+                <a:spcPts val="0"/>
+              </a:spcAft>
+              <a:buNone/>
+            </a:pPr>
+            <a:r>
+              <a:rPr lang="en-US" sz="825" b="0">
+                <a:solidFill>
+                  <a:srgbClr val="6D8495"/>
+                </a:solidFill>
+                <a:latin typeface="Roboto"/>
+                <a:ea typeface="Roboto"/>
+                <a:cs typeface="Roboto"/>
+              </a:rPr>
+              <a:t>Prescriptive analytics</a:t>
+            </a:r>
+            <a:endParaRPr lang="en-US" sz="825"/>
+          </a:p>
+        </p:txBody>
+      </p:sp>
+      <p:sp>
+        <p:nvSpPr>
+          <p:cNvPr id="6" name="Text"/>
+          <p:cNvSpPr txBox="1"/>
+          <p:nvPr/>
+        </p:nvSpPr>
+        <p:spPr>
+          <a:xfrm>
+            <a:off x="8048625" y="4867275"/>
+            <a:ext cx="600075" cy="171450"/>
+          </a:xfrm>
+          <a:prstGeom prst="rect">
+            <a:avLst/>
+          </a:prstGeom>
+          <a:noFill/>
+          <a:ln w="9525">
+            <a:noFill/>
+          </a:ln>
+        </p:spPr>
+        <p:txBody>
+          <a:bodyPr wrap="none" lIns="0" tIns="0" rIns="0" bIns="0" anchor="t">
+            <a:noAutofit/>
+          </a:bodyPr>
+          <a:lstStyle/>
+          <a:p>
+            <a:pPr algn="r">
+              <a:lnSpc>
+                <a:spcPts val="1031"/>
+              </a:lnSpc>
+            </a:pPr>
+            <a:r>
+              <a:rPr lang="en-US" sz="825" b="0" dirty="0">
+                <a:solidFill>
+                  <a:srgbClr val="6D8495"/>
+                </a:solidFill>
+                <a:latin typeface="Roboto"/>
+                <a:ea typeface="Roboto"/>
+                <a:cs typeface="Roboto"/>
+              </a:rPr>
+              <a:t>02 / 15</a:t>
+            </a:r>
+            <a:endParaRPr lang="en-US" sz="825" dirty="0"/>
+          </a:p>
+        </p:txBody>
+      </p:sp>
+      <p:sp>
+        <p:nvSpPr>
+          <p:cNvPr id="100" name="Agenda number 1"/>
+          <p:cNvSpPr txBox="1"/>
+          <p:nvPr/>
+        </p:nvSpPr>
+        <p:spPr>
+          <a:xfrm>
+            <a:off x="514350" y="1257300"/>
+            <a:ext cx="400050" cy="409575"/>
+          </a:xfrm>
+          <a:prstGeom prst="rect">
+            <a:avLst/>
+          </a:prstGeom>
+          <a:noFill/>
+          <a:ln w="9525">
+            <a:noFill/>
+          </a:ln>
+        </p:spPr>
+        <p:txBody>
+          <a:bodyPr wrap="none" lIns="0" tIns="0" rIns="0" bIns="0" anchor="t">
+            <a:noAutofit/>
+          </a:bodyPr>
+          <a:lstStyle/>
+          <a:p>
+            <a:pPr marL="0" indent="0" algn="l">
+              <a:lnSpc>
+                <a:spcPts val="2438"/>
+              </a:lnSpc>
+              <a:spcAft>
+                <a:spcPts val="0"/>
+              </a:spcAft>
+              <a:buNone/>
+            </a:pPr>
+            <a:r>
+              <a:rPr lang="en-US" sz="1950" b="1">
+                <a:solidFill>
+                  <a:srgbClr val="007D8B"/>
+                </a:solidFill>
+                <a:latin typeface="Roboto"/>
+                <a:ea typeface="Roboto"/>
+                <a:cs typeface="Roboto"/>
+              </a:rPr>
+              <a:t>01</a:t>
+            </a:r>
+            <a:endParaRPr lang="en-US" sz="1950"/>
+          </a:p>
+        </p:txBody>
+      </p:sp>
+      <p:sp>
+        <p:nvSpPr>
+          <p:cNvPr id="101" name="Agenda topic 1"/>
+          <p:cNvSpPr txBox="1"/>
+          <p:nvPr/>
+        </p:nvSpPr>
+        <p:spPr>
+          <a:xfrm>
+            <a:off x="1066800" y="1247775"/>
+            <a:ext cx="7477125" cy="419100"/>
+          </a:xfrm>
+          <a:prstGeom prst="rect">
+            <a:avLst/>
+          </a:prstGeom>
+          <a:noFill/>
+          <a:ln w="9525">
+            <a:noFill/>
+          </a:ln>
+        </p:spPr>
+        <p:txBody>
+          <a:bodyPr wrap="none" lIns="0" tIns="0" rIns="0" bIns="0" anchor="t">
+            <a:noAutofit/>
+          </a:bodyPr>
+          <a:lstStyle/>
+          <a:p>
+            <a:pPr marL="0" indent="0" algn="l">
+              <a:lnSpc>
+                <a:spcPts val="2531"/>
+              </a:lnSpc>
+              <a:spcAft>
+                <a:spcPts val="0"/>
+              </a:spcAft>
+              <a:buNone/>
+            </a:pPr>
+            <a:r>
+              <a:rPr lang="en-US" sz="2025" b="0">
+                <a:solidFill>
+                  <a:srgbClr val="435D74"/>
+                </a:solidFill>
+                <a:latin typeface="Roboto"/>
+                <a:ea typeface="Roboto"/>
+                <a:cs typeface="Roboto"/>
+              </a:rPr>
+              <a:t>Data science foundations</a:t>
+            </a:r>
+            <a:endParaRPr lang="en-US" sz="2025"/>
+          </a:p>
+        </p:txBody>
+      </p:sp>
+      <p:sp>
+        <p:nvSpPr>
+          <p:cNvPr id="102" name="Agenda number 2"/>
+          <p:cNvSpPr txBox="1"/>
+          <p:nvPr/>
+        </p:nvSpPr>
+        <p:spPr>
+          <a:xfrm>
+            <a:off x="514350" y="1800225"/>
+            <a:ext cx="400050" cy="409575"/>
+          </a:xfrm>
+          <a:prstGeom prst="rect">
+            <a:avLst/>
+          </a:prstGeom>
+          <a:noFill/>
+          <a:ln w="9525">
+            <a:noFill/>
+          </a:ln>
+        </p:spPr>
+        <p:txBody>
+          <a:bodyPr wrap="none" lIns="0" tIns="0" rIns="0" bIns="0" anchor="t">
+            <a:noAutofit/>
+          </a:bodyPr>
+          <a:lstStyle/>
+          <a:p>
+            <a:pPr marL="0" indent="0" algn="l">
+              <a:lnSpc>
+                <a:spcPts val="2438"/>
+              </a:lnSpc>
+              <a:spcAft>
+                <a:spcPts val="0"/>
+              </a:spcAft>
+              <a:buNone/>
+            </a:pPr>
+            <a:r>
+              <a:rPr lang="en-US" sz="1950" b="1">
+                <a:solidFill>
+                  <a:srgbClr val="007D8B"/>
+                </a:solidFill>
+                <a:latin typeface="Roboto"/>
+                <a:ea typeface="Roboto"/>
+                <a:cs typeface="Roboto"/>
+              </a:rPr>
+              <a:t>02</a:t>
+            </a:r>
+            <a:endParaRPr lang="en-US" sz="1950"/>
+          </a:p>
+        </p:txBody>
+      </p:sp>
+      <p:sp>
+        <p:nvSpPr>
+          <p:cNvPr id="103" name="Agenda topic 2"/>
+          <p:cNvSpPr txBox="1"/>
+          <p:nvPr/>
+        </p:nvSpPr>
+        <p:spPr>
+          <a:xfrm>
+            <a:off x="1066800" y="1790700"/>
+            <a:ext cx="7477125" cy="419100"/>
+          </a:xfrm>
+          <a:prstGeom prst="rect">
+            <a:avLst/>
+          </a:prstGeom>
+          <a:noFill/>
+          <a:ln w="9525">
+            <a:noFill/>
+          </a:ln>
+        </p:spPr>
+        <p:txBody>
+          <a:bodyPr wrap="none" lIns="0" tIns="0" rIns="0" bIns="0" anchor="t">
+            <a:noAutofit/>
+          </a:bodyPr>
+          <a:lstStyle/>
+          <a:p>
+            <a:pPr marL="0" indent="0" algn="l">
+              <a:lnSpc>
+                <a:spcPts val="2531"/>
+              </a:lnSpc>
+              <a:spcAft>
+                <a:spcPts val="0"/>
+              </a:spcAft>
+              <a:buNone/>
+            </a:pPr>
+            <a:r>
+              <a:rPr lang="en-US" sz="2025" b="0">
+                <a:solidFill>
+                  <a:srgbClr val="435D74"/>
+                </a:solidFill>
+                <a:latin typeface="Roboto"/>
+                <a:ea typeface="Roboto"/>
+                <a:cs typeface="Roboto"/>
+              </a:rPr>
+              <a:t>The role of prescriptive analytics</a:t>
+            </a:r>
+            <a:endParaRPr lang="en-US" sz="2025"/>
+          </a:p>
+        </p:txBody>
+      </p:sp>
+      <p:sp>
+        <p:nvSpPr>
+          <p:cNvPr id="104" name="Agenda number 3"/>
+          <p:cNvSpPr txBox="1"/>
+          <p:nvPr/>
+        </p:nvSpPr>
+        <p:spPr>
+          <a:xfrm>
+            <a:off x="514350" y="2343150"/>
+            <a:ext cx="400050" cy="409575"/>
+          </a:xfrm>
+          <a:prstGeom prst="rect">
+            <a:avLst/>
+          </a:prstGeom>
+          <a:noFill/>
+          <a:ln w="9525">
+            <a:noFill/>
+          </a:ln>
+        </p:spPr>
+        <p:txBody>
+          <a:bodyPr wrap="none" lIns="0" tIns="0" rIns="0" bIns="0" anchor="t">
+            <a:noAutofit/>
+          </a:bodyPr>
+          <a:lstStyle/>
+          <a:p>
+            <a:pPr marL="0" indent="0" algn="l">
+              <a:lnSpc>
+                <a:spcPts val="2438"/>
+              </a:lnSpc>
+              <a:spcAft>
+                <a:spcPts val="0"/>
+              </a:spcAft>
+              <a:buNone/>
+            </a:pPr>
+            <a:r>
+              <a:rPr lang="en-US" sz="1950" b="1">
+                <a:solidFill>
+                  <a:srgbClr val="007D8B"/>
+                </a:solidFill>
+                <a:latin typeface="Roboto"/>
+                <a:ea typeface="Roboto"/>
+                <a:cs typeface="Roboto"/>
+              </a:rPr>
+              <a:t>03</a:t>
+            </a:r>
+            <a:endParaRPr lang="en-US" sz="1950"/>
+          </a:p>
+        </p:txBody>
+      </p:sp>
+      <p:sp>
+        <p:nvSpPr>
+          <p:cNvPr id="105" name="Agenda topic 3"/>
+          <p:cNvSpPr txBox="1"/>
+          <p:nvPr/>
+        </p:nvSpPr>
+        <p:spPr>
+          <a:xfrm>
+            <a:off x="1066800" y="2333625"/>
+            <a:ext cx="7477125" cy="419100"/>
+          </a:xfrm>
+          <a:prstGeom prst="rect">
+            <a:avLst/>
+          </a:prstGeom>
+          <a:noFill/>
+          <a:ln w="9525">
+            <a:noFill/>
+          </a:ln>
+        </p:spPr>
+        <p:txBody>
+          <a:bodyPr wrap="none" lIns="0" tIns="0" rIns="0" bIns="0" anchor="t">
+            <a:noAutofit/>
+          </a:bodyPr>
+          <a:lstStyle/>
+          <a:p>
+            <a:pPr marL="0" indent="0" algn="l">
+              <a:lnSpc>
+                <a:spcPts val="2531"/>
+              </a:lnSpc>
+              <a:spcAft>
+                <a:spcPts val="0"/>
+              </a:spcAft>
+              <a:buNone/>
+            </a:pPr>
+            <a:r>
+              <a:rPr lang="en-US" sz="2025" b="0">
+                <a:solidFill>
+                  <a:srgbClr val="435D74"/>
+                </a:solidFill>
+                <a:latin typeface="Roboto"/>
+                <a:ea typeface="Roboto"/>
+                <a:cs typeface="Roboto"/>
+              </a:rPr>
+              <a:t>Decision models and recommendations</a:t>
+            </a:r>
+            <a:endParaRPr lang="en-US" sz="2025"/>
+          </a:p>
+        </p:txBody>
+      </p:sp>
+      <p:sp>
+        <p:nvSpPr>
+          <p:cNvPr id="106" name="Agenda number 4"/>
+          <p:cNvSpPr txBox="1"/>
+          <p:nvPr/>
+        </p:nvSpPr>
+        <p:spPr>
+          <a:xfrm>
+            <a:off x="514350" y="2886075"/>
+            <a:ext cx="400050" cy="409575"/>
+          </a:xfrm>
+          <a:prstGeom prst="rect">
+            <a:avLst/>
+          </a:prstGeom>
+          <a:noFill/>
+          <a:ln w="9525">
+            <a:noFill/>
+          </a:ln>
+        </p:spPr>
+        <p:txBody>
+          <a:bodyPr wrap="none" lIns="0" tIns="0" rIns="0" bIns="0" anchor="t">
+            <a:noAutofit/>
+          </a:bodyPr>
+          <a:lstStyle/>
+          <a:p>
+            <a:pPr marL="0" indent="0" algn="l">
+              <a:lnSpc>
+                <a:spcPts val="2438"/>
+              </a:lnSpc>
+              <a:spcAft>
+                <a:spcPts val="0"/>
+              </a:spcAft>
+              <a:buNone/>
+            </a:pPr>
+            <a:r>
+              <a:rPr lang="en-US" sz="1950" b="1">
+                <a:solidFill>
+                  <a:srgbClr val="007D8B"/>
+                </a:solidFill>
+                <a:latin typeface="Roboto"/>
+                <a:ea typeface="Roboto"/>
+                <a:cs typeface="Roboto"/>
+              </a:rPr>
+              <a:t>04</a:t>
+            </a:r>
+            <a:endParaRPr lang="en-US" sz="1950"/>
+          </a:p>
+        </p:txBody>
+      </p:sp>
+      <p:sp>
+        <p:nvSpPr>
+          <p:cNvPr id="107" name="Agenda topic 4"/>
+          <p:cNvSpPr txBox="1"/>
+          <p:nvPr/>
+        </p:nvSpPr>
+        <p:spPr>
+          <a:xfrm>
+            <a:off x="1066800" y="2876550"/>
+            <a:ext cx="7477125" cy="419100"/>
+          </a:xfrm>
+          <a:prstGeom prst="rect">
+            <a:avLst/>
+          </a:prstGeom>
+          <a:noFill/>
+          <a:ln w="9525">
+            <a:noFill/>
+          </a:ln>
+        </p:spPr>
+        <p:txBody>
+          <a:bodyPr wrap="none" lIns="0" tIns="0" rIns="0" bIns="0" anchor="t">
+            <a:noAutofit/>
+          </a:bodyPr>
+          <a:lstStyle/>
+          <a:p>
+            <a:pPr marL="0" indent="0" algn="l">
+              <a:lnSpc>
+                <a:spcPts val="2531"/>
+              </a:lnSpc>
+              <a:spcAft>
+                <a:spcPts val="0"/>
+              </a:spcAft>
+              <a:buNone/>
+            </a:pPr>
+            <a:r>
+              <a:rPr lang="en-US" sz="2025" b="0">
+                <a:solidFill>
+                  <a:srgbClr val="435D74"/>
+                </a:solidFill>
+                <a:latin typeface="Roboto"/>
+                <a:ea typeface="Roboto"/>
+                <a:cs typeface="Roboto"/>
+              </a:rPr>
+              <a:t>Methods and model outputs</a:t>
+            </a:r>
+            <a:endParaRPr lang="en-US" sz="2025"/>
+          </a:p>
+        </p:txBody>
+      </p:sp>
+      <p:sp>
+        <p:nvSpPr>
+          <p:cNvPr id="108" name="Agenda number 5"/>
+          <p:cNvSpPr txBox="1"/>
+          <p:nvPr/>
+        </p:nvSpPr>
+        <p:spPr>
+          <a:xfrm>
+            <a:off x="514350" y="3429000"/>
+            <a:ext cx="400050" cy="409575"/>
+          </a:xfrm>
+          <a:prstGeom prst="rect">
+            <a:avLst/>
+          </a:prstGeom>
+          <a:noFill/>
+          <a:ln w="9525">
+            <a:noFill/>
+          </a:ln>
+        </p:spPr>
+        <p:txBody>
+          <a:bodyPr wrap="none" lIns="0" tIns="0" rIns="0" bIns="0" anchor="t">
+            <a:noAutofit/>
+          </a:bodyPr>
+          <a:lstStyle/>
+          <a:p>
+            <a:pPr marL="0" indent="0" algn="l">
+              <a:lnSpc>
+                <a:spcPts val="2438"/>
+              </a:lnSpc>
+              <a:spcAft>
+                <a:spcPts val="0"/>
+              </a:spcAft>
+              <a:buNone/>
+            </a:pPr>
+            <a:r>
+              <a:rPr lang="en-US" sz="1950" b="1">
+                <a:solidFill>
+                  <a:srgbClr val="007D8B"/>
+                </a:solidFill>
+                <a:latin typeface="Roboto"/>
+                <a:ea typeface="Roboto"/>
+                <a:cs typeface="Roboto"/>
+              </a:rPr>
+              <a:t>05</a:t>
+            </a:r>
+            <a:endParaRPr lang="en-US" sz="1950"/>
+          </a:p>
+        </p:txBody>
+      </p:sp>
+      <p:sp>
+        <p:nvSpPr>
+          <p:cNvPr id="109" name="Agenda topic 5"/>
+          <p:cNvSpPr txBox="1"/>
+          <p:nvPr/>
+        </p:nvSpPr>
+        <p:spPr>
+          <a:xfrm>
+            <a:off x="1066800" y="3419475"/>
+            <a:ext cx="7477125" cy="419100"/>
+          </a:xfrm>
+          <a:prstGeom prst="rect">
+            <a:avLst/>
+          </a:prstGeom>
+          <a:noFill/>
+          <a:ln w="9525">
+            <a:noFill/>
+          </a:ln>
+        </p:spPr>
+        <p:txBody>
+          <a:bodyPr wrap="none" lIns="0" tIns="0" rIns="0" bIns="0" anchor="t">
+            <a:noAutofit/>
+          </a:bodyPr>
+          <a:lstStyle/>
+          <a:p>
+            <a:pPr marL="0" indent="0" algn="l">
+              <a:lnSpc>
+                <a:spcPts val="2531"/>
+              </a:lnSpc>
+              <a:spcAft>
+                <a:spcPts val="0"/>
+              </a:spcAft>
+              <a:buNone/>
+            </a:pPr>
+            <a:r>
+              <a:rPr lang="en-US" sz="2025" b="0">
+                <a:solidFill>
+                  <a:srgbClr val="435D74"/>
+                </a:solidFill>
+                <a:latin typeface="Roboto"/>
+                <a:ea typeface="Roboto"/>
+                <a:cs typeface="Roboto"/>
+              </a:rPr>
+              <a:t>Business decisions and planning</a:t>
+            </a:r>
+            <a:endParaRPr lang="en-US" sz="2025"/>
+          </a:p>
+        </p:txBody>
+      </p:sp>
+      <p:sp>
+        <p:nvSpPr>
+          <p:cNvPr id="110" name="Agenda number 6"/>
+          <p:cNvSpPr txBox="1"/>
+          <p:nvPr/>
+        </p:nvSpPr>
+        <p:spPr>
+          <a:xfrm>
+            <a:off x="514350" y="3971925"/>
+            <a:ext cx="400050" cy="409575"/>
+          </a:xfrm>
+          <a:prstGeom prst="rect">
+            <a:avLst/>
+          </a:prstGeom>
+          <a:noFill/>
+          <a:ln w="9525">
+            <a:noFill/>
+          </a:ln>
+        </p:spPr>
+        <p:txBody>
+          <a:bodyPr wrap="none" lIns="0" tIns="0" rIns="0" bIns="0" anchor="t">
+            <a:noAutofit/>
+          </a:bodyPr>
+          <a:lstStyle/>
+          <a:p>
+            <a:pPr marL="0" indent="0" algn="l">
+              <a:lnSpc>
+                <a:spcPts val="2438"/>
+              </a:lnSpc>
+              <a:spcAft>
+                <a:spcPts val="0"/>
+              </a:spcAft>
+              <a:buNone/>
+            </a:pPr>
+            <a:r>
+              <a:rPr lang="en-US" sz="1950" b="1">
+                <a:solidFill>
+                  <a:srgbClr val="007D8B"/>
+                </a:solidFill>
+                <a:latin typeface="Roboto"/>
+                <a:ea typeface="Roboto"/>
+                <a:cs typeface="Roboto"/>
+              </a:rPr>
+              <a:t>06</a:t>
+            </a:r>
+            <a:endParaRPr lang="en-US" sz="1950"/>
+          </a:p>
+        </p:txBody>
+      </p:sp>
+      <p:sp>
+        <p:nvSpPr>
+          <p:cNvPr id="111" name="Agenda topic 6"/>
+          <p:cNvSpPr txBox="1"/>
+          <p:nvPr/>
+        </p:nvSpPr>
+        <p:spPr>
+          <a:xfrm>
+            <a:off x="1066800" y="3962400"/>
+            <a:ext cx="7477125" cy="419100"/>
+          </a:xfrm>
+          <a:prstGeom prst="rect">
+            <a:avLst/>
+          </a:prstGeom>
+          <a:noFill/>
+          <a:ln w="9525">
+            <a:noFill/>
+          </a:ln>
+        </p:spPr>
+        <p:txBody>
+          <a:bodyPr wrap="none" lIns="0" tIns="0" rIns="0" bIns="0" anchor="t">
+            <a:noAutofit/>
+          </a:bodyPr>
+          <a:lstStyle/>
+          <a:p>
+            <a:pPr marL="0" indent="0" algn="l">
+              <a:lnSpc>
+                <a:spcPts val="2531"/>
+              </a:lnSpc>
+              <a:spcAft>
+                <a:spcPts val="0"/>
+              </a:spcAft>
+              <a:buNone/>
+            </a:pPr>
+            <a:r>
+              <a:rPr lang="en-US" sz="2025" b="0">
+                <a:solidFill>
+                  <a:srgbClr val="435D74"/>
+                </a:solidFill>
+                <a:latin typeface="Roboto"/>
+                <a:ea typeface="Roboto"/>
+                <a:cs typeface="Roboto"/>
+              </a:rPr>
+              <a:t>Connected decisions and fairness</a:t>
+            </a:r>
+            <a:endParaRPr lang="en-US" sz="2025"/>
+          </a:p>
+        </p:txBody>
+      </p:sp>
+    </p:spTree>
+  </p:cSld>
+  <p:clrMapOvr>
+    <a:masterClrMapping/>
+  </p:clrMapOvr>
+</p:sld>
+</file>
+
 <file path=ppt/slides/slide2.xml><?xml version="1.0" encoding="utf-8"?>
-<p:sld xmlns:a="http://schemas.openxmlformats.org/drawingml/2006/main" xmlns:r="http://schemas.openxmlformats.org/officeDocument/2006/relationships" xmlns:p="http://schemas.openxmlformats.org/presentationml/2006/main" showMasterSp="0">
+<p:sld xmlns:a="http://schemas.openxmlformats.org/drawingml/2006/main" xmlns:p="http://schemas.openxmlformats.org/presentationml/2006/main" showMasterSp="0">
   <p:cSld name="The data science life cycle">
     <p:bg>
       <p:bgPr>
@@ -23191,7 +23977,7 @@
                 <a:ea typeface="Roboto"/>
                 <a:cs typeface="Roboto"/>
               </a:rPr>
-              <a:t>02 </a:t>
+              <a:t>03 / 15</a:t>
             </a:r>
             <a:r>
               <a:rPr lang="en-US" sz="825" dirty="0">
@@ -23202,7 +23988,7 @@
                 <a:ea typeface="Roboto"/>
                 <a:cs typeface="Roboto"/>
               </a:rPr>
-              <a:t>/ 14</a:t>
+              <a:t/>
             </a:r>
             <a:endParaRPr lang="en-US" sz="825" dirty="0"/>
           </a:p>
@@ -26482,7 +27268,7 @@
 </file>
 
 <file path=ppt/slides/slide3.xml><?xml version="1.0" encoding="utf-8"?>
-<p:sld xmlns:a="http://schemas.openxmlformats.org/drawingml/2006/main" xmlns:r="http://schemas.openxmlformats.org/officeDocument/2006/relationships" xmlns:p="http://schemas.openxmlformats.org/presentationml/2006/main" showMasterSp="0">
+<p:sld xmlns:a="http://schemas.openxmlformats.org/drawingml/2006/main" xmlns:p="http://schemas.openxmlformats.org/presentationml/2006/main" showMasterSp="0">
   <p:cSld name="Four types of analytics">
     <p:bg>
       <p:bgPr>
@@ -26664,7 +27450,7 @@
                 <a:ea typeface="Roboto"/>
                 <a:cs typeface="Roboto"/>
               </a:rPr>
-              <a:t>03 / 14</a:t>
+              <a:t>04 / 15</a:t>
             </a:r>
             <a:endParaRPr lang="en-US" sz="825" dirty="0"/>
           </a:p>
@@ -28932,7 +29718,7 @@
 </file>
 
 <file path=ppt/slides/slide4.xml><?xml version="1.0" encoding="utf-8"?>
-<p:sld xmlns:a="http://schemas.openxmlformats.org/drawingml/2006/main" xmlns:r="http://schemas.openxmlformats.org/officeDocument/2006/relationships" xmlns:p="http://schemas.openxmlformats.org/presentationml/2006/main" showMasterSp="0">
+<p:sld xmlns:a="http://schemas.openxmlformats.org/drawingml/2006/main" xmlns:p="http://schemas.openxmlformats.org/presentationml/2006/main" showMasterSp="0">
   <p:cSld name="The role of prescriptive analytics">
     <p:bg>
       <p:bgPr>
@@ -29114,7 +29900,7 @@
                 <a:ea typeface="Roboto"/>
                 <a:cs typeface="Roboto"/>
               </a:rPr>
-              <a:t>04 </a:t>
+              <a:t>05 / 15</a:t>
             </a:r>
             <a:r>
               <a:rPr lang="en-US" sz="825" dirty="0">
@@ -29125,7 +29911,7 @@
                 <a:ea typeface="Roboto"/>
                 <a:cs typeface="Roboto"/>
               </a:rPr>
-              <a:t>/ 14</a:t>
+              <a:t/>
             </a:r>
             <a:endParaRPr lang="en-US" sz="825" dirty="0"/>
           </a:p>
@@ -30589,7 +31375,7 @@
 </file>
 
 <file path=ppt/slides/slide5.xml><?xml version="1.0" encoding="utf-8"?>
-<p:sld xmlns:a="http://schemas.openxmlformats.org/drawingml/2006/main" xmlns:r="http://schemas.openxmlformats.org/officeDocument/2006/relationships" xmlns:p="http://schemas.openxmlformats.org/presentationml/2006/main" showMasterSp="0">
+<p:sld xmlns:a="http://schemas.openxmlformats.org/drawingml/2006/main" xmlns:p="http://schemas.openxmlformats.org/presentationml/2006/main" showMasterSp="0">
   <p:cSld name="The decision model">
     <p:bg>
       <p:bgPr>
@@ -30771,7 +31557,7 @@
                 <a:ea typeface="Roboto"/>
                 <a:cs typeface="Roboto"/>
               </a:rPr>
-              <a:t>05 </a:t>
+              <a:t>06 / 15</a:t>
             </a:r>
             <a:r>
               <a:rPr lang="en-US" sz="825" dirty="0">
@@ -30782,7 +31568,7 @@
                 <a:ea typeface="Roboto"/>
                 <a:cs typeface="Roboto"/>
               </a:rPr>
-              <a:t>/ 14</a:t>
+              <a:t/>
             </a:r>
             <a:endParaRPr lang="en-US" sz="825" dirty="0"/>
           </a:p>
@@ -33669,7 +34455,7 @@
 </file>
 
 <file path=ppt/slides/slide6.xml><?xml version="1.0" encoding="utf-8"?>
-<p:sld xmlns:a="http://schemas.openxmlformats.org/drawingml/2006/main" xmlns:r="http://schemas.openxmlformats.org/officeDocument/2006/relationships" xmlns:p="http://schemas.openxmlformats.org/presentationml/2006/main" showMasterSp="0">
+<p:sld xmlns:a="http://schemas.openxmlformats.org/drawingml/2006/main" xmlns:p="http://schemas.openxmlformats.org/presentationml/2006/main" showMasterSp="0">
   <p:cSld name="The recommendation process">
     <p:bg>
       <p:bgPr>
@@ -33851,7 +34637,7 @@
                 <a:ea typeface="Roboto"/>
                 <a:cs typeface="Roboto"/>
               </a:rPr>
-              <a:t>06 </a:t>
+              <a:t>07 / 15</a:t>
             </a:r>
             <a:r>
               <a:rPr lang="en-US" sz="825" dirty="0">
@@ -33862,7 +34648,7 @@
                 <a:ea typeface="Roboto"/>
                 <a:cs typeface="Roboto"/>
               </a:rPr>
-              <a:t>/ 14</a:t>
+              <a:t/>
             </a:r>
             <a:endParaRPr lang="en-US" sz="825" dirty="0"/>
           </a:p>
@@ -37293,7 +38079,7 @@
 </file>
 
 <file path=ppt/slides/slide7.xml><?xml version="1.0" encoding="utf-8"?>
-<p:sld xmlns:a="http://schemas.openxmlformats.org/drawingml/2006/main" xmlns:r="http://schemas.openxmlformats.org/officeDocument/2006/relationships" xmlns:p="http://schemas.openxmlformats.org/presentationml/2006/main" showMasterSp="0">
+<p:sld xmlns:a="http://schemas.openxmlformats.org/drawingml/2006/main" xmlns:p="http://schemas.openxmlformats.org/presentationml/2006/main" showMasterSp="0">
   <p:cSld name="Methods used in prescriptive analytics">
     <p:bg>
       <p:bgPr>
@@ -37475,7 +38261,7 @@
                 <a:ea typeface="Roboto"/>
                 <a:cs typeface="Roboto"/>
               </a:rPr>
-              <a:t>07 / 14</a:t>
+              <a:t>08 / 15</a:t>
             </a:r>
             <a:endParaRPr lang="en-US" sz="825" dirty="0"/>
           </a:p>
@@ -39747,7 +40533,7 @@
 </file>
 
 <file path=ppt/slides/slide8.xml><?xml version="1.0" encoding="utf-8"?>
-<p:sld xmlns:a="http://schemas.openxmlformats.org/drawingml/2006/main" xmlns:r="http://schemas.openxmlformats.org/officeDocument/2006/relationships" xmlns:p="http://schemas.openxmlformats.org/presentationml/2006/main" showMasterSp="0">
+<p:sld xmlns:a="http://schemas.openxmlformats.org/drawingml/2006/main" xmlns:p="http://schemas.openxmlformats.org/presentationml/2006/main" showMasterSp="0">
   <p:cSld name="What does the model produce?">
     <p:bg>
       <p:bgPr>
@@ -39929,7 +40715,7 @@
                 <a:ea typeface="Roboto"/>
                 <a:cs typeface="Roboto"/>
               </a:rPr>
-              <a:t>08 </a:t>
+              <a:t>09 / 15</a:t>
             </a:r>
             <a:r>
               <a:rPr lang="en-US" sz="825" dirty="0">
@@ -39940,7 +40726,7 @@
                 <a:ea typeface="Roboto"/>
                 <a:cs typeface="Roboto"/>
               </a:rPr>
-              <a:t>/ 14</a:t>
+              <a:t/>
             </a:r>
             <a:endParaRPr lang="en-US" sz="825" dirty="0"/>
           </a:p>
@@ -42274,7 +43060,7 @@
 </file>
 
 <file path=ppt/slides/slide9.xml><?xml version="1.0" encoding="utf-8"?>
-<p:sld xmlns:a="http://schemas.openxmlformats.org/drawingml/2006/main" xmlns:r="http://schemas.openxmlformats.org/officeDocument/2006/relationships" xmlns:p="http://schemas.openxmlformats.org/presentationml/2006/main" showMasterSp="0">
+<p:sld xmlns:a="http://schemas.openxmlformats.org/drawingml/2006/main" xmlns:p="http://schemas.openxmlformats.org/presentationml/2006/main" showMasterSp="0">
   <p:cSld name="Decisions prescriptive analytics can support">
     <p:bg>
       <p:bgPr>
@@ -42456,7 +43242,7 @@
                 <a:ea typeface="Roboto"/>
                 <a:cs typeface="Roboto"/>
               </a:rPr>
-              <a:t>09 </a:t>
+              <a:t>10 / 15</a:t>
             </a:r>
             <a:r>
               <a:rPr lang="en-US" sz="825" dirty="0">
@@ -42467,7 +43253,7 @@
                 <a:ea typeface="Roboto"/>
                 <a:cs typeface="Roboto"/>
               </a:rPr>
-              <a:t>/ 14</a:t>
+              <a:t/>
             </a:r>
             <a:endParaRPr lang="en-US" sz="825" dirty="0"/>
           </a:p>

</xml_diff>